<commit_message>
Fix dashboard ML feature names and add EDA, ML, and dashboard screenshots
</commit_message>
<xml_diff>
--- a/PRESENTATION/Civil_Project.pptx
+++ b/PRESENTATION/Civil_Project.pptx
@@ -345,7 +345,7 @@
           <a:p>
             <a:fld id="{1F7CDA35-5897-4A2A-8C79-713D161389E0}" type="datetimeFigureOut">
               <a:rPr lang="en-US" smtClean="0"/>
-              <a:t>7/30/2026</a:t>
+              <a:t>7/31/2026</a:t>
             </a:fld>
             <a:endParaRPr lang="en-US"/>
           </a:p>
@@ -800,7 +800,7 @@
           <a:p>
             <a:fld id="{1F7CDA35-5897-4A2A-8C79-713D161389E0}" type="datetimeFigureOut">
               <a:rPr lang="en-US" smtClean="0"/>
-              <a:t>7/30/2026</a:t>
+              <a:t>7/31/2026</a:t>
             </a:fld>
             <a:endParaRPr lang="en-US"/>
           </a:p>
@@ -1197,7 +1197,7 @@
           <a:p>
             <a:fld id="{1F7CDA35-5897-4A2A-8C79-713D161389E0}" type="datetimeFigureOut">
               <a:rPr lang="en-US" smtClean="0"/>
-              <a:t>7/30/2026</a:t>
+              <a:t>7/31/2026</a:t>
             </a:fld>
             <a:endParaRPr lang="en-US"/>
           </a:p>
@@ -1565,7 +1565,7 @@
           <a:p>
             <a:fld id="{1F7CDA35-5897-4A2A-8C79-713D161389E0}" type="datetimeFigureOut">
               <a:rPr lang="en-US" smtClean="0"/>
-              <a:t>7/30/2026</a:t>
+              <a:t>7/31/2026</a:t>
             </a:fld>
             <a:endParaRPr lang="en-US"/>
           </a:p>
@@ -1933,7 +1933,7 @@
           <a:p>
             <a:fld id="{1F7CDA35-5897-4A2A-8C79-713D161389E0}" type="datetimeFigureOut">
               <a:rPr lang="en-US" smtClean="0"/>
-              <a:t>7/30/2026</a:t>
+              <a:t>7/31/2026</a:t>
             </a:fld>
             <a:endParaRPr lang="en-US"/>
           </a:p>
@@ -2301,7 +2301,7 @@
           <a:p>
             <a:fld id="{1F7CDA35-5897-4A2A-8C79-713D161389E0}" type="datetimeFigureOut">
               <a:rPr lang="en-US" smtClean="0"/>
-              <a:t>7/30/2026</a:t>
+              <a:t>7/31/2026</a:t>
             </a:fld>
             <a:endParaRPr lang="en-US"/>
           </a:p>
@@ -2653,7 +2653,7 @@
           <a:p>
             <a:fld id="{1F7CDA35-5897-4A2A-8C79-713D161389E0}" type="datetimeFigureOut">
               <a:rPr lang="en-US" smtClean="0"/>
-              <a:t>7/30/2026</a:t>
+              <a:t>7/31/2026</a:t>
             </a:fld>
             <a:endParaRPr lang="en-US"/>
           </a:p>
@@ -3050,7 +3050,7 @@
           <a:p>
             <a:fld id="{1F7CDA35-5897-4A2A-8C79-713D161389E0}" type="datetimeFigureOut">
               <a:rPr lang="en-US" smtClean="0"/>
-              <a:t>7/30/2026</a:t>
+              <a:t>7/31/2026</a:t>
             </a:fld>
             <a:endParaRPr lang="en-US"/>
           </a:p>
@@ -3402,7 +3402,7 @@
           <a:p>
             <a:fld id="{1F7CDA35-5897-4A2A-8C79-713D161389E0}" type="datetimeFigureOut">
               <a:rPr lang="en-US" smtClean="0"/>
-              <a:t>7/30/2026</a:t>
+              <a:t>7/31/2026</a:t>
             </a:fld>
             <a:endParaRPr lang="en-US"/>
           </a:p>
@@ -3799,7 +3799,7 @@
           <a:p>
             <a:fld id="{1F7CDA35-5897-4A2A-8C79-713D161389E0}" type="datetimeFigureOut">
               <a:rPr lang="en-US" smtClean="0"/>
-              <a:t>7/30/2026</a:t>
+              <a:t>7/31/2026</a:t>
             </a:fld>
             <a:endParaRPr lang="en-US"/>
           </a:p>
@@ -4285,7 +4285,7 @@
           <a:p>
             <a:fld id="{1F7CDA35-5897-4A2A-8C79-713D161389E0}" type="datetimeFigureOut">
               <a:rPr lang="en-US" smtClean="0"/>
-              <a:t>7/30/2026</a:t>
+              <a:t>7/31/2026</a:t>
             </a:fld>
             <a:endParaRPr lang="en-US"/>
           </a:p>
@@ -4558,7 +4558,7 @@
           <a:p>
             <a:fld id="{1F7CDA35-5897-4A2A-8C79-713D161389E0}" type="datetimeFigureOut">
               <a:rPr lang="en-US" smtClean="0"/>
-              <a:t>7/30/2026</a:t>
+              <a:t>7/31/2026</a:t>
             </a:fld>
             <a:endParaRPr lang="en-US"/>
           </a:p>
@@ -4961,7 +4961,7 @@
           <a:p>
             <a:fld id="{1F7CDA35-5897-4A2A-8C79-713D161389E0}" type="datetimeFigureOut">
               <a:rPr lang="en-US" smtClean="0"/>
-              <a:t>7/30/2026</a:t>
+              <a:t>7/31/2026</a:t>
             </a:fld>
             <a:endParaRPr lang="en-US"/>
           </a:p>
@@ -5441,7 +5441,7 @@
           <a:p>
             <a:fld id="{1F7CDA35-5897-4A2A-8C79-713D161389E0}" type="datetimeFigureOut">
               <a:rPr lang="en-US" smtClean="0"/>
-              <a:t>7/30/2026</a:t>
+              <a:t>7/31/2026</a:t>
             </a:fld>
             <a:endParaRPr lang="en-US"/>
           </a:p>
@@ -5820,7 +5820,7 @@
           <a:p>
             <a:fld id="{1F7CDA35-5897-4A2A-8C79-713D161389E0}" type="datetimeFigureOut">
               <a:rPr lang="en-US" smtClean="0"/>
-              <a:t>7/30/2026</a:t>
+              <a:t>7/31/2026</a:t>
             </a:fld>
             <a:endParaRPr lang="en-US"/>
           </a:p>
@@ -6336,7 +6336,7 @@
           <a:p>
             <a:fld id="{1F7CDA35-5897-4A2A-8C79-713D161389E0}" type="datetimeFigureOut">
               <a:rPr lang="en-US" smtClean="0"/>
-              <a:t>7/30/2026</a:t>
+              <a:t>7/31/2026</a:t>
             </a:fld>
             <a:endParaRPr lang="en-US"/>
           </a:p>
@@ -6613,7 +6613,7 @@
           <a:p>
             <a:fld id="{1F7CDA35-5897-4A2A-8C79-713D161389E0}" type="datetimeFigureOut">
               <a:rPr lang="en-US" smtClean="0"/>
-              <a:t>7/30/2026</a:t>
+              <a:t>7/31/2026</a:t>
             </a:fld>
             <a:endParaRPr lang="en-US"/>
           </a:p>
@@ -6726,7 +6726,7 @@
           <a:p>
             <a:fld id="{1F7CDA35-5897-4A2A-8C79-713D161389E0}" type="datetimeFigureOut">
               <a:rPr lang="en-US" smtClean="0"/>
-              <a:t>7/30/2026</a:t>
+              <a:t>7/31/2026</a:t>
             </a:fld>
             <a:endParaRPr lang="en-US"/>
           </a:p>
@@ -7069,7 +7069,7 @@
           <a:p>
             <a:fld id="{1F7CDA35-5897-4A2A-8C79-713D161389E0}" type="datetimeFigureOut">
               <a:rPr lang="en-US" smtClean="0"/>
-              <a:t>7/30/2026</a:t>
+              <a:t>7/31/2026</a:t>
             </a:fld>
             <a:endParaRPr lang="en-US"/>
           </a:p>
@@ -7467,7 +7467,7 @@
           <a:p>
             <a:fld id="{1F7CDA35-5897-4A2A-8C79-713D161389E0}" type="datetimeFigureOut">
               <a:rPr lang="en-US" smtClean="0"/>
-              <a:t>7/30/2026</a:t>
+              <a:t>7/31/2026</a:t>
             </a:fld>
             <a:endParaRPr lang="en-US"/>
           </a:p>
@@ -7836,7 +7836,7 @@
           <a:p>
             <a:fld id="{1F7CDA35-5897-4A2A-8C79-713D161389E0}" type="datetimeFigureOut">
               <a:rPr lang="en-US" smtClean="0"/>
-              <a:t>7/30/2026</a:t>
+              <a:t>7/31/2026</a:t>
             </a:fld>
             <a:endParaRPr lang="en-US"/>
           </a:p>
@@ -8196,7 +8196,7 @@
           <a:p>
             <a:fld id="{1F7CDA35-5897-4A2A-8C79-713D161389E0}" type="datetimeFigureOut">
               <a:rPr lang="en-US" smtClean="0"/>
-              <a:t>7/30/2026</a:t>
+              <a:t>7/31/2026</a:t>
             </a:fld>
             <a:endParaRPr lang="en-US"/>
           </a:p>
@@ -8656,7 +8656,7 @@
           <a:p>
             <a:fld id="{1F7CDA35-5897-4A2A-8C79-713D161389E0}" type="datetimeFigureOut">
               <a:rPr lang="en-US" smtClean="0"/>
-              <a:t>7/30/2026</a:t>
+              <a:t>7/31/2026</a:t>
             </a:fld>
             <a:endParaRPr lang="en-US"/>
           </a:p>
@@ -9103,7 +9103,7 @@
           <a:p>
             <a:fld id="{1F7CDA35-5897-4A2A-8C79-713D161389E0}" type="datetimeFigureOut">
               <a:rPr lang="en-US" smtClean="0"/>
-              <a:t>7/30/2026</a:t>
+              <a:t>7/31/2026</a:t>
             </a:fld>
             <a:endParaRPr lang="en-US"/>
           </a:p>
@@ -9601,7 +9601,7 @@
           <a:p>
             <a:fld id="{1F7CDA35-5897-4A2A-8C79-713D161389E0}" type="datetimeFigureOut">
               <a:rPr lang="en-US" smtClean="0"/>
-              <a:t>7/30/2026</a:t>
+              <a:t>7/31/2026</a:t>
             </a:fld>
             <a:endParaRPr lang="en-US"/>
           </a:p>
@@ -9968,7 +9968,7 @@
           <a:p>
             <a:fld id="{1F7CDA35-5897-4A2A-8C79-713D161389E0}" type="datetimeFigureOut">
               <a:rPr lang="en-US" smtClean="0"/>
-              <a:t>7/30/2026</a:t>
+              <a:t>7/31/2026</a:t>
             </a:fld>
             <a:endParaRPr lang="en-US"/>
           </a:p>
@@ -10307,7 +10307,7 @@
           <a:p>
             <a:fld id="{1F7CDA35-5897-4A2A-8C79-713D161389E0}" type="datetimeFigureOut">
               <a:rPr lang="en-US" smtClean="0"/>
-              <a:t>7/30/2026</a:t>
+              <a:t>7/31/2026</a:t>
             </a:fld>
             <a:endParaRPr lang="en-US"/>
           </a:p>
@@ -10676,7 +10676,7 @@
           <a:p>
             <a:fld id="{1F7CDA35-5897-4A2A-8C79-713D161389E0}" type="datetimeFigureOut">
               <a:rPr lang="en-US" smtClean="0"/>
-              <a:t>7/30/2026</a:t>
+              <a:t>7/31/2026</a:t>
             </a:fld>
             <a:endParaRPr lang="en-US"/>
           </a:p>
@@ -15173,551 +15173,11 @@
                 <a:ea typeface="Calibri" panose="020F0502020204030204" pitchFamily="34" charset="0"/>
                 <a:cs typeface="Calibri" panose="020F0502020204030204" pitchFamily="34" charset="0"/>
               </a:rPr>
-              <a:t>SQL Commercial Engine: Progressive Billing &amp; Cash Flow</a:t>
-            </a:r>
-          </a:p>
-        </p:txBody>
-      </p:sp>
-      <p:sp>
-        <p:nvSpPr>
-          <p:cNvPr id="4" name="Rectangle: Rounded Corners 3">
-            <a:extLst>
-              <a:ext uri="{FF2B5EF4-FFF2-40B4-BE49-F238E27FC236}">
-                <a16:creationId xmlns:a16="http://schemas.microsoft.com/office/drawing/2014/main" id="{E066FF14-5D33-EA9D-4D03-10E019B1B047}"/>
-              </a:ext>
-            </a:extLst>
-          </p:cNvPr>
-          <p:cNvSpPr/>
-          <p:nvPr/>
-        </p:nvSpPr>
-        <p:spPr>
-          <a:xfrm>
-            <a:off x="448056" y="987552"/>
-            <a:ext cx="6126480" cy="2368296"/>
-          </a:xfrm>
-          <a:prstGeom prst="roundRect">
-            <a:avLst/>
-          </a:prstGeom>
-          <a:gradFill flip="none" rotWithShape="1">
-            <a:gsLst>
-              <a:gs pos="0">
-                <a:schemeClr val="accent6">
-                  <a:lumMod val="67000"/>
-                </a:schemeClr>
-              </a:gs>
-              <a:gs pos="48000">
-                <a:schemeClr val="accent6">
-                  <a:lumMod val="97000"/>
-                  <a:lumOff val="3000"/>
-                </a:schemeClr>
-              </a:gs>
-              <a:gs pos="100000">
-                <a:schemeClr val="accent6">
-                  <a:lumMod val="60000"/>
-                  <a:lumOff val="40000"/>
-                </a:schemeClr>
-              </a:gs>
-            </a:gsLst>
-            <a:lin ang="16200000" scaled="1"/>
-            <a:tileRect/>
-          </a:gradFill>
-          <a:ln>
-            <a:noFill/>
-          </a:ln>
-        </p:spPr>
-        <p:style>
-          <a:lnRef idx="0">
-            <a:scrgbClr r="0" g="0" b="0"/>
-          </a:lnRef>
-          <a:fillRef idx="0">
-            <a:scrgbClr r="0" g="0" b="0"/>
-          </a:fillRef>
-          <a:effectRef idx="0">
-            <a:scrgbClr r="0" g="0" b="0"/>
-          </a:effectRef>
-          <a:fontRef idx="minor">
-            <a:schemeClr val="lt1"/>
-          </a:fontRef>
-        </p:style>
-        <p:txBody>
-          <a:bodyPr rtlCol="0" anchor="ctr"/>
-          <a:lstStyle/>
-          <a:p>
-            <a:pPr algn="ctr"/>
-            <a:endParaRPr lang="en-US"/>
-          </a:p>
-        </p:txBody>
-      </p:sp>
-      <p:sp>
-        <p:nvSpPr>
-          <p:cNvPr id="5" name="Rectangle: Rounded Corners 4">
-            <a:extLst>
-              <a:ext uri="{FF2B5EF4-FFF2-40B4-BE49-F238E27FC236}">
-                <a16:creationId xmlns:a16="http://schemas.microsoft.com/office/drawing/2014/main" id="{9960EC98-B64F-6A08-6848-BEB318E3B572}"/>
-              </a:ext>
-            </a:extLst>
-          </p:cNvPr>
-          <p:cNvSpPr/>
-          <p:nvPr/>
-        </p:nvSpPr>
-        <p:spPr>
-          <a:xfrm>
-            <a:off x="448056" y="3585737"/>
-            <a:ext cx="6126480" cy="2284711"/>
-          </a:xfrm>
-          <a:prstGeom prst="roundRect">
-            <a:avLst/>
-          </a:prstGeom>
-          <a:gradFill flip="none" rotWithShape="1">
-            <a:gsLst>
-              <a:gs pos="0">
-                <a:schemeClr val="accent3">
-                  <a:lumMod val="67000"/>
-                </a:schemeClr>
-              </a:gs>
-              <a:gs pos="48000">
-                <a:schemeClr val="accent3">
-                  <a:lumMod val="97000"/>
-                  <a:lumOff val="3000"/>
-                </a:schemeClr>
-              </a:gs>
-              <a:gs pos="100000">
-                <a:schemeClr val="accent3">
-                  <a:lumMod val="60000"/>
-                  <a:lumOff val="40000"/>
-                </a:schemeClr>
-              </a:gs>
-            </a:gsLst>
-            <a:lin ang="16200000" scaled="1"/>
-            <a:tileRect/>
-          </a:gradFill>
-          <a:ln>
-            <a:noFill/>
-          </a:ln>
-        </p:spPr>
-        <p:style>
-          <a:lnRef idx="0">
-            <a:scrgbClr r="0" g="0" b="0"/>
-          </a:lnRef>
-          <a:fillRef idx="0">
-            <a:scrgbClr r="0" g="0" b="0"/>
-          </a:fillRef>
-          <a:effectRef idx="0">
-            <a:scrgbClr r="0" g="0" b="0"/>
-          </a:effectRef>
-          <a:fontRef idx="minor">
-            <a:schemeClr val="lt1"/>
-          </a:fontRef>
-        </p:style>
-        <p:txBody>
-          <a:bodyPr rtlCol="0" anchor="ctr"/>
-          <a:lstStyle/>
-          <a:p>
-            <a:pPr algn="ctr"/>
-            <a:endParaRPr lang="en-US"/>
-          </a:p>
-        </p:txBody>
-      </p:sp>
-      <p:sp>
-        <p:nvSpPr>
-          <p:cNvPr id="7" name="TextBox 6">
-            <a:extLst>
-              <a:ext uri="{FF2B5EF4-FFF2-40B4-BE49-F238E27FC236}">
-                <a16:creationId xmlns:a16="http://schemas.microsoft.com/office/drawing/2014/main" id="{F9224E55-9440-EA1F-2E54-B5C91BB5E0F9}"/>
-              </a:ext>
-            </a:extLst>
-          </p:cNvPr>
-          <p:cNvSpPr txBox="1"/>
-          <p:nvPr/>
-        </p:nvSpPr>
-        <p:spPr>
-          <a:xfrm>
-            <a:off x="775338" y="1162852"/>
-            <a:ext cx="5095109" cy="338554"/>
-          </a:xfrm>
-          <a:prstGeom prst="rect">
-            <a:avLst/>
-          </a:prstGeom>
-          <a:noFill/>
-        </p:spPr>
-        <p:txBody>
-          <a:bodyPr wrap="square" rtlCol="0">
-            <a:spAutoFit/>
-          </a:bodyPr>
-          <a:lstStyle/>
-          <a:p>
-            <a:r>
-              <a:rPr lang="en-US" sz="1600" b="1" u="sng" dirty="0">
-                <a:latin typeface="Calibri" panose="020F0502020204030204" pitchFamily="34" charset="0"/>
-                <a:ea typeface="Calibri" panose="020F0502020204030204" pitchFamily="34" charset="0"/>
-                <a:cs typeface="Calibri" panose="020F0502020204030204" pitchFamily="34" charset="0"/>
-              </a:rPr>
-              <a:t>Progressive Cash Flow (SUM() OVER)</a:t>
-            </a:r>
-            <a:endParaRPr lang="en-US" sz="1600" u="sng" dirty="0">
-              <a:latin typeface="Calibri" panose="020F0502020204030204" pitchFamily="34" charset="0"/>
-              <a:ea typeface="Calibri" panose="020F0502020204030204" pitchFamily="34" charset="0"/>
-              <a:cs typeface="Calibri" panose="020F0502020204030204" pitchFamily="34" charset="0"/>
-            </a:endParaRPr>
-          </a:p>
-        </p:txBody>
-      </p:sp>
-      <p:sp>
-        <p:nvSpPr>
-          <p:cNvPr id="9" name="TextBox 8">
-            <a:extLst>
-              <a:ext uri="{FF2B5EF4-FFF2-40B4-BE49-F238E27FC236}">
-                <a16:creationId xmlns:a16="http://schemas.microsoft.com/office/drawing/2014/main" id="{8799371D-B6CD-D729-3CBE-F156F8B8C4FD}"/>
-              </a:ext>
-            </a:extLst>
-          </p:cNvPr>
-          <p:cNvSpPr txBox="1"/>
-          <p:nvPr/>
-        </p:nvSpPr>
-        <p:spPr>
-          <a:xfrm>
-            <a:off x="775338" y="1569976"/>
-            <a:ext cx="5099902" cy="1569660"/>
-          </a:xfrm>
-          <a:prstGeom prst="rect">
-            <a:avLst/>
-          </a:prstGeom>
-          <a:noFill/>
-        </p:spPr>
-        <p:txBody>
-          <a:bodyPr wrap="square" rtlCol="0">
-            <a:spAutoFit/>
-          </a:bodyPr>
-          <a:lstStyle/>
-          <a:p>
-            <a:pPr marL="228600" lvl="0" indent="-228600">
-              <a:buFont typeface="+mj-lt"/>
-              <a:buAutoNum type="arabicPeriod"/>
-            </a:pPr>
-            <a:r>
-              <a:rPr lang="en-US" sz="1200" i="1" dirty="0">
-                <a:latin typeface="Calibri" panose="020F0502020204030204" pitchFamily="34" charset="0"/>
-                <a:ea typeface="Calibri" panose="020F0502020204030204" pitchFamily="34" charset="0"/>
-                <a:cs typeface="Calibri" panose="020F0502020204030204" pitchFamily="34" charset="0"/>
-              </a:rPr>
-              <a:t>Built a running balance window function (</a:t>
-            </a:r>
-            <a:r>
-              <a:rPr lang="en-US" sz="1200" b="1" dirty="0">
-                <a:latin typeface="Calibri" panose="020F0502020204030204" pitchFamily="34" charset="0"/>
-                <a:ea typeface="Calibri" panose="020F0502020204030204" pitchFamily="34" charset="0"/>
-                <a:cs typeface="Calibri" panose="020F0502020204030204" pitchFamily="34" charset="0"/>
-              </a:rPr>
-              <a:t>SUM(</a:t>
-            </a:r>
-            <a:r>
-              <a:rPr lang="en-US" sz="1200" b="1" dirty="0" err="1">
-                <a:latin typeface="Calibri" panose="020F0502020204030204" pitchFamily="34" charset="0"/>
-                <a:ea typeface="Calibri" panose="020F0502020204030204" pitchFamily="34" charset="0"/>
-                <a:cs typeface="Calibri" panose="020F0502020204030204" pitchFamily="34" charset="0"/>
-              </a:rPr>
-              <a:t>net_payable_amount</a:t>
-            </a:r>
-            <a:r>
-              <a:rPr lang="en-US" sz="1200" b="1" dirty="0">
-                <a:latin typeface="Calibri" panose="020F0502020204030204" pitchFamily="34" charset="0"/>
-                <a:ea typeface="Calibri" panose="020F0502020204030204" pitchFamily="34" charset="0"/>
-                <a:cs typeface="Calibri" panose="020F0502020204030204" pitchFamily="34" charset="0"/>
-              </a:rPr>
-              <a:t>) OVER (PARTITION BY </a:t>
-            </a:r>
-            <a:r>
-              <a:rPr lang="en-US" sz="1200" b="1" dirty="0" err="1">
-                <a:latin typeface="Calibri" panose="020F0502020204030204" pitchFamily="34" charset="0"/>
-                <a:ea typeface="Calibri" panose="020F0502020204030204" pitchFamily="34" charset="0"/>
-                <a:cs typeface="Calibri" panose="020F0502020204030204" pitchFamily="34" charset="0"/>
-              </a:rPr>
-              <a:t>project_id</a:t>
-            </a:r>
-            <a:r>
-              <a:rPr lang="en-US" sz="1200" b="1" dirty="0">
-                <a:latin typeface="Calibri" panose="020F0502020204030204" pitchFamily="34" charset="0"/>
-                <a:ea typeface="Calibri" panose="020F0502020204030204" pitchFamily="34" charset="0"/>
-                <a:cs typeface="Calibri" panose="020F0502020204030204" pitchFamily="34" charset="0"/>
-              </a:rPr>
-              <a:t> ORDER BY </a:t>
-            </a:r>
-            <a:r>
-              <a:rPr lang="en-US" sz="1200" b="1" dirty="0" err="1">
-                <a:latin typeface="Calibri" panose="020F0502020204030204" pitchFamily="34" charset="0"/>
-                <a:ea typeface="Calibri" panose="020F0502020204030204" pitchFamily="34" charset="0"/>
-                <a:cs typeface="Calibri" panose="020F0502020204030204" pitchFamily="34" charset="0"/>
-              </a:rPr>
-              <a:t>invoice_date</a:t>
-            </a:r>
-            <a:r>
-              <a:rPr lang="en-US" sz="1200" b="1" dirty="0">
-                <a:latin typeface="Calibri" panose="020F0502020204030204" pitchFamily="34" charset="0"/>
-                <a:ea typeface="Calibri" panose="020F0502020204030204" pitchFamily="34" charset="0"/>
-                <a:cs typeface="Calibri" panose="020F0502020204030204" pitchFamily="34" charset="0"/>
-              </a:rPr>
-              <a:t>)).</a:t>
-            </a:r>
-          </a:p>
-          <a:p>
-            <a:pPr marL="228600" lvl="0" indent="-228600">
-              <a:buFont typeface="+mj-lt"/>
-              <a:buAutoNum type="arabicPeriod"/>
-            </a:pPr>
-            <a:endParaRPr lang="en-US" sz="1200" i="1" dirty="0">
-              <a:latin typeface="Calibri" panose="020F0502020204030204" pitchFamily="34" charset="0"/>
-              <a:ea typeface="Calibri" panose="020F0502020204030204" pitchFamily="34" charset="0"/>
-              <a:cs typeface="Calibri" panose="020F0502020204030204" pitchFamily="34" charset="0"/>
-            </a:endParaRPr>
-          </a:p>
-          <a:p>
-            <a:pPr marL="228600" lvl="0" indent="-228600">
-              <a:buFont typeface="+mj-lt"/>
-              <a:buAutoNum type="arabicPeriod"/>
-            </a:pPr>
-            <a:r>
-              <a:rPr lang="en-US" sz="1200" i="1" dirty="0">
-                <a:latin typeface="Calibri" panose="020F0502020204030204" pitchFamily="34" charset="0"/>
-                <a:ea typeface="Calibri" panose="020F0502020204030204" pitchFamily="34" charset="0"/>
-                <a:cs typeface="Calibri" panose="020F0502020204030204" pitchFamily="34" charset="0"/>
-              </a:rPr>
-              <a:t>Tracks cumulative milestone billing chronologically per site without dropping individual invoice details.</a:t>
-            </a:r>
-          </a:p>
-          <a:p>
-            <a:pPr marL="228600" lvl="0" indent="-228600">
-              <a:buFont typeface="+mj-lt"/>
-              <a:buAutoNum type="arabicPeriod"/>
-            </a:pPr>
-            <a:endParaRPr lang="en-US" sz="1200" i="1" dirty="0">
-              <a:latin typeface="Calibri" panose="020F0502020204030204" pitchFamily="34" charset="0"/>
-              <a:ea typeface="Calibri" panose="020F0502020204030204" pitchFamily="34" charset="0"/>
-              <a:cs typeface="Calibri" panose="020F0502020204030204" pitchFamily="34" charset="0"/>
-            </a:endParaRPr>
-          </a:p>
-          <a:p>
-            <a:pPr marL="228600" lvl="0" indent="-228600">
-              <a:buFont typeface="+mj-lt"/>
-              <a:buAutoNum type="arabicPeriod"/>
-            </a:pPr>
-            <a:r>
-              <a:rPr lang="en-US" sz="1200" i="1" dirty="0">
-                <a:latin typeface="Calibri" panose="020F0502020204030204" pitchFamily="34" charset="0"/>
-                <a:ea typeface="Calibri" panose="020F0502020204030204" pitchFamily="34" charset="0"/>
-                <a:cs typeface="Calibri" panose="020F0502020204030204" pitchFamily="34" charset="0"/>
-              </a:rPr>
-              <a:t>Site Finding: At </a:t>
-            </a:r>
-            <a:r>
-              <a:rPr lang="en-US" sz="1200" b="1" i="1" dirty="0">
-                <a:latin typeface="Calibri" panose="020F0502020204030204" pitchFamily="34" charset="0"/>
-                <a:ea typeface="Calibri" panose="020F0502020204030204" pitchFamily="34" charset="0"/>
-                <a:cs typeface="Calibri" panose="020F0502020204030204" pitchFamily="34" charset="0"/>
-              </a:rPr>
-              <a:t>GAL33</a:t>
-            </a:r>
-            <a:r>
-              <a:rPr lang="en-US" sz="1200" i="1" dirty="0">
-                <a:latin typeface="Calibri" panose="020F0502020204030204" pitchFamily="34" charset="0"/>
-                <a:ea typeface="Calibri" panose="020F0502020204030204" pitchFamily="34" charset="0"/>
-                <a:cs typeface="Calibri" panose="020F0502020204030204" pitchFamily="34" charset="0"/>
-              </a:rPr>
-              <a:t> (WTG Foundation), cumulative billing grew from ₹4.55 Lakhs in Feb 2026 to ₹13.65 Lakhs by late March 2026.</a:t>
-            </a:r>
-            <a:endParaRPr lang="en-US" sz="1400" i="1" dirty="0">
-              <a:latin typeface="Calibri" panose="020F0502020204030204" pitchFamily="34" charset="0"/>
-              <a:ea typeface="Calibri" panose="020F0502020204030204" pitchFamily="34" charset="0"/>
-              <a:cs typeface="Calibri" panose="020F0502020204030204" pitchFamily="34" charset="0"/>
-            </a:endParaRPr>
-          </a:p>
-        </p:txBody>
-      </p:sp>
-      <p:sp>
-        <p:nvSpPr>
-          <p:cNvPr id="11" name="TextBox 10">
-            <a:extLst>
-              <a:ext uri="{FF2B5EF4-FFF2-40B4-BE49-F238E27FC236}">
-                <a16:creationId xmlns:a16="http://schemas.microsoft.com/office/drawing/2014/main" id="{9C9AB4D3-7D44-288E-FBB5-79C66DD3EE87}"/>
-              </a:ext>
-            </a:extLst>
-          </p:cNvPr>
-          <p:cNvSpPr txBox="1"/>
-          <p:nvPr/>
-        </p:nvSpPr>
-        <p:spPr>
-          <a:xfrm>
-            <a:off x="775338" y="3832057"/>
-            <a:ext cx="5095109" cy="338554"/>
-          </a:xfrm>
-          <a:prstGeom prst="rect">
-            <a:avLst/>
-          </a:prstGeom>
-          <a:noFill/>
-        </p:spPr>
-        <p:txBody>
-          <a:bodyPr wrap="square" rtlCol="0">
-            <a:spAutoFit/>
-          </a:bodyPr>
-          <a:lstStyle/>
-          <a:p>
-            <a:r>
-              <a:rPr lang="en-US" sz="1600" b="1" u="sng" dirty="0">
-                <a:latin typeface="Calibri" panose="020F0502020204030204" pitchFamily="34" charset="0"/>
-                <a:ea typeface="Calibri" panose="020F0502020204030204" pitchFamily="34" charset="0"/>
-                <a:cs typeface="Calibri" panose="020F0502020204030204" pitchFamily="34" charset="0"/>
-              </a:rPr>
-              <a:t>BOQ Cost Share Ranking (DENSE_RANK())</a:t>
-            </a:r>
-            <a:endParaRPr lang="en-US" sz="1600" u="sng" dirty="0">
-              <a:latin typeface="Calibri" panose="020F0502020204030204" pitchFamily="34" charset="0"/>
-              <a:ea typeface="Calibri" panose="020F0502020204030204" pitchFamily="34" charset="0"/>
-              <a:cs typeface="Calibri" panose="020F0502020204030204" pitchFamily="34" charset="0"/>
-            </a:endParaRPr>
-          </a:p>
-        </p:txBody>
-      </p:sp>
-      <p:sp>
-        <p:nvSpPr>
-          <p:cNvPr id="13" name="TextBox 12">
-            <a:extLst>
-              <a:ext uri="{FF2B5EF4-FFF2-40B4-BE49-F238E27FC236}">
-                <a16:creationId xmlns:a16="http://schemas.microsoft.com/office/drawing/2014/main" id="{6E3C0683-D4F8-E756-CAB2-90375876FE11}"/>
-              </a:ext>
-            </a:extLst>
-          </p:cNvPr>
-          <p:cNvSpPr txBox="1"/>
-          <p:nvPr/>
-        </p:nvSpPr>
-        <p:spPr>
-          <a:xfrm>
-            <a:off x="653796" y="4244520"/>
-            <a:ext cx="5586984" cy="1015663"/>
-          </a:xfrm>
-          <a:prstGeom prst="rect">
-            <a:avLst/>
-          </a:prstGeom>
-          <a:noFill/>
-        </p:spPr>
-        <p:txBody>
-          <a:bodyPr wrap="square" rtlCol="0">
-            <a:spAutoFit/>
-          </a:bodyPr>
-          <a:lstStyle/>
-          <a:p>
-            <a:pPr marL="228600" lvl="0" indent="-228600">
-              <a:buFont typeface="+mj-lt"/>
-              <a:buAutoNum type="arabicPeriod"/>
-            </a:pPr>
-            <a:r>
-              <a:rPr lang="en-US" sz="1200" i="1" dirty="0">
-                <a:latin typeface="Calibri" panose="020F0502020204030204" pitchFamily="34" charset="0"/>
-                <a:ea typeface="Calibri" panose="020F0502020204030204" pitchFamily="34" charset="0"/>
-                <a:cs typeface="Calibri" panose="020F0502020204030204" pitchFamily="34" charset="0"/>
-              </a:rPr>
-              <a:t>Ranked line-item expenses to identify top cost drivers across sites.</a:t>
-            </a:r>
-          </a:p>
-          <a:p>
-            <a:pPr marL="228600" lvl="0" indent="-228600">
-              <a:buFont typeface="+mj-lt"/>
-              <a:buAutoNum type="arabicPeriod"/>
-            </a:pPr>
-            <a:endParaRPr lang="en-US" sz="1200" i="1" dirty="0">
-              <a:latin typeface="Calibri" panose="020F0502020204030204" pitchFamily="34" charset="0"/>
-              <a:ea typeface="Calibri" panose="020F0502020204030204" pitchFamily="34" charset="0"/>
-              <a:cs typeface="Calibri" panose="020F0502020204030204" pitchFamily="34" charset="0"/>
-            </a:endParaRPr>
-          </a:p>
-          <a:p>
-            <a:pPr marL="228600" lvl="0" indent="-228600">
-              <a:buFont typeface="+mj-lt"/>
-              <a:buAutoNum type="arabicPeriod"/>
-            </a:pPr>
-            <a:r>
-              <a:rPr lang="en-US" sz="1200" i="1" dirty="0">
-                <a:latin typeface="Calibri" panose="020F0502020204030204" pitchFamily="34" charset="0"/>
-                <a:ea typeface="Calibri" panose="020F0502020204030204" pitchFamily="34" charset="0"/>
-                <a:cs typeface="Calibri" panose="020F0502020204030204" pitchFamily="34" charset="0"/>
-              </a:rPr>
-              <a:t>Storage Sheds: Structural steel fabrication dominates budgets (42.53% at Patan).</a:t>
-            </a:r>
-          </a:p>
-          <a:p>
-            <a:pPr marL="228600" lvl="0" indent="-228600">
-              <a:buFont typeface="+mj-lt"/>
-              <a:buAutoNum type="arabicPeriod"/>
-            </a:pPr>
-            <a:endParaRPr lang="en-US" sz="1200" i="1" dirty="0">
-              <a:latin typeface="Calibri" panose="020F0502020204030204" pitchFamily="34" charset="0"/>
-              <a:ea typeface="Calibri" panose="020F0502020204030204" pitchFamily="34" charset="0"/>
-              <a:cs typeface="Calibri" panose="020F0502020204030204" pitchFamily="34" charset="0"/>
-            </a:endParaRPr>
-          </a:p>
-          <a:p>
-            <a:pPr marL="228600" lvl="0" indent="-228600">
-              <a:buFont typeface="+mj-lt"/>
-              <a:buAutoNum type="arabicPeriod"/>
-            </a:pPr>
-            <a:r>
-              <a:rPr lang="en-US" sz="1200" i="1" dirty="0">
-                <a:latin typeface="Calibri" panose="020F0502020204030204" pitchFamily="34" charset="0"/>
-                <a:ea typeface="Calibri" panose="020F0502020204030204" pitchFamily="34" charset="0"/>
-                <a:cs typeface="Calibri" panose="020F0502020204030204" pitchFamily="34" charset="0"/>
-              </a:rPr>
-              <a:t>Wind Foundations: Specialized epoxy grout dominates budgets (30.42% at GAL33).</a:t>
-            </a:r>
-            <a:endParaRPr lang="en-US" sz="1400" i="1" dirty="0">
-              <a:latin typeface="Calibri" panose="020F0502020204030204" pitchFamily="34" charset="0"/>
-              <a:ea typeface="Calibri" panose="020F0502020204030204" pitchFamily="34" charset="0"/>
-              <a:cs typeface="Calibri" panose="020F0502020204030204" pitchFamily="34" charset="0"/>
-            </a:endParaRPr>
-          </a:p>
-        </p:txBody>
-      </p:sp>
-      <p:pic>
-        <p:nvPicPr>
-          <p:cNvPr id="14" name="Picture 13" descr="Statistical Chart Line Blue Two Color Icon 44144380 Vector Art at Vecteezy">
-            <a:extLst>
-              <a:ext uri="{FF2B5EF4-FFF2-40B4-BE49-F238E27FC236}">
-                <a16:creationId xmlns:a16="http://schemas.microsoft.com/office/drawing/2014/main" id="{59748FDB-1D15-1974-B121-E5653678487D}"/>
-              </a:ext>
-            </a:extLst>
-          </p:cNvPr>
-          <p:cNvPicPr>
-            <a:picLocks noChangeAspect="1"/>
-          </p:cNvPicPr>
-          <p:nvPr/>
-        </p:nvPicPr>
-        <p:blipFill>
-          <a:blip r:embed="rId2"/>
-          <a:stretch>
-            <a:fillRect/>
-          </a:stretch>
-        </p:blipFill>
-        <p:spPr>
-          <a:xfrm>
-            <a:off x="7254342" y="1213613"/>
-            <a:ext cx="4349393" cy="4430774"/>
-          </a:xfrm>
-          <a:prstGeom prst="rect">
-            <a:avLst/>
-          </a:prstGeom>
-          <a:ln w="38100" cap="sq">
-            <a:solidFill>
-              <a:srgbClr val="000000"/>
-            </a:solidFill>
-            <a:prstDash val="solid"/>
-            <a:miter lim="800000"/>
-          </a:ln>
-          <a:effectLst>
-            <a:outerShdw blurRad="50800" dist="38100" dir="2700000" algn="tl" rotWithShape="0">
-              <a:srgbClr val="000000">
-                <a:alpha val="43000"/>
-              </a:srgbClr>
-            </a:outerShdw>
-          </a:effectLst>
-        </p:spPr>
-      </p:pic>
+              <a:t>SQL Commercial Engine – Progressive Billing &amp; Cash Flow</a:t>
+            </a:r>
+          </a:p>
+        </p:txBody>
+      </p:sp>
       <p:sp>
         <p:nvSpPr>
           <p:cNvPr id="16" name="TextBox 15">
@@ -15761,7 +15221,7 @@
                 <a:latin typeface="Calibri" panose="020F0502020204030204" pitchFamily="34" charset="0"/>
                 <a:ea typeface="Calibri" panose="020F0502020204030204" pitchFamily="34" charset="0"/>
                 <a:cs typeface="Calibri" panose="020F0502020204030204" pitchFamily="34" charset="0"/>
-                <a:hlinkClick r:id="rId3"/>
+                <a:hlinkClick r:id="rId2"/>
               </a:rPr>
               <a:t>https://github.com/Pallabi5200/Civil_Engineering_Data_Science_Project</a:t>
             </a:r>

</xml_diff>

<commit_message>
Finalize all 10 slides of the Civil Engineering Construction Intelligence presentation deck
</commit_message>
<xml_diff>
--- a/PRESENTATION/Civil_Project.pptx
+++ b/PRESENTATION/Civil_Project.pptx
@@ -12,6 +12,10 @@
     <p:sldId id="260" r:id="rId6"/>
     <p:sldId id="261" r:id="rId7"/>
     <p:sldId id="262" r:id="rId8"/>
+    <p:sldId id="263" r:id="rId9"/>
+    <p:sldId id="264" r:id="rId10"/>
+    <p:sldId id="265" r:id="rId11"/>
+    <p:sldId id="266" r:id="rId12"/>
   </p:sldIdLst>
   <p:sldSz cx="12192000" cy="6858000"/>
   <p:notesSz cx="6858000" cy="9144000"/>
@@ -11333,6 +11337,1730 @@
 </p:sld>
 </file>
 
+<file path=ppt/slides/slide10.xml><?xml version="1.0" encoding="utf-8"?>
+<p:sld xmlns:a="http://schemas.openxmlformats.org/drawingml/2006/main" xmlns:r="http://schemas.openxmlformats.org/officeDocument/2006/relationships" xmlns:p="http://schemas.openxmlformats.org/presentationml/2006/main">
+  <p:cSld>
+    <p:spTree>
+      <p:nvGrpSpPr>
+        <p:cNvPr id="1" name=""/>
+        <p:cNvGrpSpPr/>
+        <p:nvPr/>
+      </p:nvGrpSpPr>
+      <p:grpSpPr>
+        <a:xfrm>
+          <a:off x="0" y="0"/>
+          <a:ext cx="0" cy="0"/>
+          <a:chOff x="0" y="0"/>
+          <a:chExt cx="0" cy="0"/>
+        </a:xfrm>
+      </p:grpSpPr>
+      <p:sp>
+        <p:nvSpPr>
+          <p:cNvPr id="3" name="TextBox 2">
+            <a:extLst>
+              <a:ext uri="{FF2B5EF4-FFF2-40B4-BE49-F238E27FC236}">
+                <a16:creationId xmlns:a16="http://schemas.microsoft.com/office/drawing/2014/main" id="{EDF48026-31CC-201E-3299-830894B6A895}"/>
+              </a:ext>
+            </a:extLst>
+          </p:cNvPr>
+          <p:cNvSpPr txBox="1"/>
+          <p:nvPr/>
+        </p:nvSpPr>
+        <p:spPr>
+          <a:xfrm>
+            <a:off x="1021238" y="212574"/>
+            <a:ext cx="11170762" cy="584775"/>
+          </a:xfrm>
+          <a:prstGeom prst="rect">
+            <a:avLst/>
+          </a:prstGeom>
+          <a:noFill/>
+        </p:spPr>
+        <p:txBody>
+          <a:bodyPr wrap="square" rtlCol="0">
+            <a:spAutoFit/>
+          </a:bodyPr>
+          <a:lstStyle/>
+          <a:p>
+            <a:r>
+              <a:rPr lang="en-US" sz="3200" b="1" u="sng" dirty="0">
+                <a:latin typeface="Calibri" panose="020F0502020204030204" pitchFamily="34" charset="0"/>
+                <a:ea typeface="Calibri" panose="020F0502020204030204" pitchFamily="34" charset="0"/>
+                <a:cs typeface="Calibri" panose="020F0502020204030204" pitchFamily="34" charset="0"/>
+              </a:rPr>
+              <a:t>Predictive Machine Learning Engine &amp; Feature Importance</a:t>
+            </a:r>
+          </a:p>
+        </p:txBody>
+      </p:sp>
+      <p:sp>
+        <p:nvSpPr>
+          <p:cNvPr id="5" name="Rectangle: Rounded Corners 4">
+            <a:extLst>
+              <a:ext uri="{FF2B5EF4-FFF2-40B4-BE49-F238E27FC236}">
+                <a16:creationId xmlns:a16="http://schemas.microsoft.com/office/drawing/2014/main" id="{B1C1CD75-CB6F-74F5-ADFE-35177BF9AD09}"/>
+              </a:ext>
+            </a:extLst>
+          </p:cNvPr>
+          <p:cNvSpPr/>
+          <p:nvPr/>
+        </p:nvSpPr>
+        <p:spPr>
+          <a:xfrm>
+            <a:off x="5686720" y="987552"/>
+            <a:ext cx="6211824" cy="2368296"/>
+          </a:xfrm>
+          <a:prstGeom prst="roundRect">
+            <a:avLst/>
+          </a:prstGeom>
+          <a:ln/>
+        </p:spPr>
+        <p:style>
+          <a:lnRef idx="1">
+            <a:schemeClr val="accent4"/>
+          </a:lnRef>
+          <a:fillRef idx="2">
+            <a:schemeClr val="accent4"/>
+          </a:fillRef>
+          <a:effectRef idx="1">
+            <a:schemeClr val="accent4"/>
+          </a:effectRef>
+          <a:fontRef idx="minor">
+            <a:schemeClr val="dk1"/>
+          </a:fontRef>
+        </p:style>
+        <p:txBody>
+          <a:bodyPr rtlCol="0" anchor="ctr"/>
+          <a:lstStyle/>
+          <a:p>
+            <a:pPr algn="ctr"/>
+            <a:endParaRPr lang="en-US"/>
+          </a:p>
+        </p:txBody>
+      </p:sp>
+      <p:sp>
+        <p:nvSpPr>
+          <p:cNvPr id="7" name="Rectangle: Rounded Corners 6">
+            <a:extLst>
+              <a:ext uri="{FF2B5EF4-FFF2-40B4-BE49-F238E27FC236}">
+                <a16:creationId xmlns:a16="http://schemas.microsoft.com/office/drawing/2014/main" id="{FB8465C1-541D-6419-90EC-63E1A6D500E7}"/>
+              </a:ext>
+            </a:extLst>
+          </p:cNvPr>
+          <p:cNvSpPr/>
+          <p:nvPr/>
+        </p:nvSpPr>
+        <p:spPr>
+          <a:xfrm>
+            <a:off x="5686720" y="3546050"/>
+            <a:ext cx="6126480" cy="2598717"/>
+          </a:xfrm>
+          <a:prstGeom prst="roundRect">
+            <a:avLst/>
+          </a:prstGeom>
+          <a:gradFill flip="none" rotWithShape="1">
+            <a:gsLst>
+              <a:gs pos="0">
+                <a:schemeClr val="accent6">
+                  <a:lumMod val="67000"/>
+                </a:schemeClr>
+              </a:gs>
+              <a:gs pos="48000">
+                <a:schemeClr val="accent6">
+                  <a:lumMod val="97000"/>
+                  <a:lumOff val="3000"/>
+                </a:schemeClr>
+              </a:gs>
+              <a:gs pos="100000">
+                <a:schemeClr val="accent6">
+                  <a:lumMod val="60000"/>
+                  <a:lumOff val="40000"/>
+                </a:schemeClr>
+              </a:gs>
+            </a:gsLst>
+            <a:lin ang="16200000" scaled="1"/>
+            <a:tileRect/>
+          </a:gradFill>
+          <a:ln>
+            <a:noFill/>
+          </a:ln>
+        </p:spPr>
+        <p:style>
+          <a:lnRef idx="0">
+            <a:scrgbClr r="0" g="0" b="0"/>
+          </a:lnRef>
+          <a:fillRef idx="0">
+            <a:scrgbClr r="0" g="0" b="0"/>
+          </a:fillRef>
+          <a:effectRef idx="0">
+            <a:scrgbClr r="0" g="0" b="0"/>
+          </a:effectRef>
+          <a:fontRef idx="minor">
+            <a:schemeClr val="lt1"/>
+          </a:fontRef>
+        </p:style>
+        <p:txBody>
+          <a:bodyPr rtlCol="0" anchor="ctr"/>
+          <a:lstStyle/>
+          <a:p>
+            <a:pPr algn="ctr"/>
+            <a:endParaRPr lang="en-US"/>
+          </a:p>
+        </p:txBody>
+      </p:sp>
+      <p:sp>
+        <p:nvSpPr>
+          <p:cNvPr id="9" name="TextBox 8">
+            <a:extLst>
+              <a:ext uri="{FF2B5EF4-FFF2-40B4-BE49-F238E27FC236}">
+                <a16:creationId xmlns:a16="http://schemas.microsoft.com/office/drawing/2014/main" id="{B6D099B2-5F49-AD89-2AC4-357711AB7FB5}"/>
+              </a:ext>
+            </a:extLst>
+          </p:cNvPr>
+          <p:cNvSpPr txBox="1"/>
+          <p:nvPr/>
+        </p:nvSpPr>
+        <p:spPr>
+          <a:xfrm>
+            <a:off x="6236208" y="1058485"/>
+            <a:ext cx="5095109" cy="338554"/>
+          </a:xfrm>
+          <a:prstGeom prst="rect">
+            <a:avLst/>
+          </a:prstGeom>
+          <a:noFill/>
+        </p:spPr>
+        <p:txBody>
+          <a:bodyPr wrap="square" rtlCol="0">
+            <a:spAutoFit/>
+          </a:bodyPr>
+          <a:lstStyle/>
+          <a:p>
+            <a:pPr algn="ctr"/>
+            <a:r>
+              <a:rPr lang="en-US" sz="1600" b="1" u="sng" dirty="0">
+                <a:latin typeface="Calibri" panose="020F0502020204030204" pitchFamily="34" charset="0"/>
+                <a:ea typeface="Calibri" panose="020F0502020204030204" pitchFamily="34" charset="0"/>
+                <a:cs typeface="Calibri" panose="020F0502020204030204" pitchFamily="34" charset="0"/>
+              </a:rPr>
+              <a:t>Random Forest Classifier</a:t>
+            </a:r>
+            <a:endParaRPr lang="en-US" sz="1600" u="sng" dirty="0">
+              <a:latin typeface="Calibri" panose="020F0502020204030204" pitchFamily="34" charset="0"/>
+              <a:ea typeface="Calibri" panose="020F0502020204030204" pitchFamily="34" charset="0"/>
+              <a:cs typeface="Calibri" panose="020F0502020204030204" pitchFamily="34" charset="0"/>
+            </a:endParaRPr>
+          </a:p>
+        </p:txBody>
+      </p:sp>
+      <p:sp>
+        <p:nvSpPr>
+          <p:cNvPr id="11" name="TextBox 10">
+            <a:extLst>
+              <a:ext uri="{FF2B5EF4-FFF2-40B4-BE49-F238E27FC236}">
+                <a16:creationId xmlns:a16="http://schemas.microsoft.com/office/drawing/2014/main" id="{4BB21FF8-B04A-2FED-C3B8-CEF8BC4D515A}"/>
+              </a:ext>
+            </a:extLst>
+          </p:cNvPr>
+          <p:cNvSpPr txBox="1"/>
+          <p:nvPr/>
+        </p:nvSpPr>
+        <p:spPr>
+          <a:xfrm>
+            <a:off x="6096000" y="3636972"/>
+            <a:ext cx="5095109" cy="338554"/>
+          </a:xfrm>
+          <a:prstGeom prst="rect">
+            <a:avLst/>
+          </a:prstGeom>
+          <a:noFill/>
+        </p:spPr>
+        <p:txBody>
+          <a:bodyPr wrap="square" rtlCol="0">
+            <a:spAutoFit/>
+          </a:bodyPr>
+          <a:lstStyle/>
+          <a:p>
+            <a:pPr algn="ctr"/>
+            <a:r>
+              <a:rPr lang="en-US" sz="1600" b="1" u="sng" dirty="0">
+                <a:latin typeface="Calibri" panose="020F0502020204030204" pitchFamily="34" charset="0"/>
+                <a:ea typeface="Calibri" panose="020F0502020204030204" pitchFamily="34" charset="0"/>
+                <a:cs typeface="Calibri" panose="020F0502020204030204" pitchFamily="34" charset="0"/>
+              </a:rPr>
+              <a:t>Feature Importance &amp; Scientific Insight</a:t>
+            </a:r>
+            <a:endParaRPr lang="en-US" sz="1600" u="sng" dirty="0">
+              <a:latin typeface="Calibri" panose="020F0502020204030204" pitchFamily="34" charset="0"/>
+              <a:ea typeface="Calibri" panose="020F0502020204030204" pitchFamily="34" charset="0"/>
+              <a:cs typeface="Calibri" panose="020F0502020204030204" pitchFamily="34" charset="0"/>
+            </a:endParaRPr>
+          </a:p>
+        </p:txBody>
+      </p:sp>
+      <p:sp>
+        <p:nvSpPr>
+          <p:cNvPr id="13" name="TextBox 12">
+            <a:extLst>
+              <a:ext uri="{FF2B5EF4-FFF2-40B4-BE49-F238E27FC236}">
+                <a16:creationId xmlns:a16="http://schemas.microsoft.com/office/drawing/2014/main" id="{F82E42FC-AEE3-EBA8-C2B8-B672FD6412C5}"/>
+              </a:ext>
+            </a:extLst>
+          </p:cNvPr>
+          <p:cNvSpPr txBox="1"/>
+          <p:nvPr/>
+        </p:nvSpPr>
+        <p:spPr>
+          <a:xfrm>
+            <a:off x="5956468" y="1475168"/>
+            <a:ext cx="5586984" cy="1569660"/>
+          </a:xfrm>
+          <a:prstGeom prst="rect">
+            <a:avLst/>
+          </a:prstGeom>
+          <a:noFill/>
+        </p:spPr>
+        <p:txBody>
+          <a:bodyPr wrap="square" rtlCol="0">
+            <a:spAutoFit/>
+          </a:bodyPr>
+          <a:lstStyle/>
+          <a:p>
+            <a:pPr marL="228600" lvl="0" indent="-228600">
+              <a:buFont typeface="+mj-lt"/>
+              <a:buAutoNum type="arabicPeriod"/>
+            </a:pPr>
+            <a:r>
+              <a:rPr lang="en-US" sz="1200" b="1" u="sng" dirty="0">
+                <a:latin typeface="Calibri" panose="020F0502020204030204" pitchFamily="34" charset="0"/>
+                <a:ea typeface="Calibri" panose="020F0502020204030204" pitchFamily="34" charset="0"/>
+                <a:cs typeface="Calibri" panose="020F0502020204030204" pitchFamily="34" charset="0"/>
+              </a:rPr>
+              <a:t>Feature Vector &amp; Target</a:t>
+            </a:r>
+            <a:r>
+              <a:rPr lang="en-US" sz="1200" i="1" dirty="0">
+                <a:latin typeface="Calibri" panose="020F0502020204030204" pitchFamily="34" charset="0"/>
+                <a:ea typeface="Calibri" panose="020F0502020204030204" pitchFamily="34" charset="0"/>
+                <a:cs typeface="Calibri" panose="020F0502020204030204" pitchFamily="34" charset="0"/>
+              </a:rPr>
+              <a:t>: Feature inputs X = [</a:t>
+            </a:r>
+            <a:r>
+              <a:rPr lang="en-US" sz="1200" i="1" dirty="0" err="1">
+                <a:latin typeface="Calibri" panose="020F0502020204030204" pitchFamily="34" charset="0"/>
+                <a:ea typeface="Calibri" panose="020F0502020204030204" pitchFamily="34" charset="0"/>
+                <a:cs typeface="Calibri" panose="020F0502020204030204" pitchFamily="34" charset="0"/>
+              </a:rPr>
+              <a:t>ndt_ultrasonic_velocity</a:t>
+            </a:r>
+            <a:r>
+              <a:rPr lang="en-US" sz="1200" i="1" dirty="0">
+                <a:latin typeface="Calibri" panose="020F0502020204030204" pitchFamily="34" charset="0"/>
+                <a:ea typeface="Calibri" panose="020F0502020204030204" pitchFamily="34" charset="0"/>
+                <a:cs typeface="Calibri" panose="020F0502020204030204" pitchFamily="34" charset="0"/>
+              </a:rPr>
+              <a:t>, </a:t>
+            </a:r>
+            <a:r>
+              <a:rPr lang="en-US" sz="1200" i="1" dirty="0" err="1">
+                <a:latin typeface="Calibri" panose="020F0502020204030204" pitchFamily="34" charset="0"/>
+                <a:ea typeface="Calibri" panose="020F0502020204030204" pitchFamily="34" charset="0"/>
+                <a:cs typeface="Calibri" panose="020F0502020204030204" pitchFamily="34" charset="0"/>
+              </a:rPr>
+              <a:t>curing_days</a:t>
+            </a:r>
+            <a:r>
+              <a:rPr lang="en-US" sz="1200" i="1" dirty="0">
+                <a:latin typeface="Calibri" panose="020F0502020204030204" pitchFamily="34" charset="0"/>
+                <a:ea typeface="Calibri" panose="020F0502020204030204" pitchFamily="34" charset="0"/>
+                <a:cs typeface="Calibri" panose="020F0502020204030204" pitchFamily="34" charset="0"/>
+              </a:rPr>
+              <a:t>] predicting 28-day concrete compliance (</a:t>
+            </a:r>
+            <a:r>
+              <a:rPr lang="en-US" sz="1200" i="1" dirty="0" err="1">
+                <a:latin typeface="Calibri" panose="020F0502020204030204" pitchFamily="34" charset="0"/>
+                <a:ea typeface="Calibri" panose="020F0502020204030204" pitchFamily="34" charset="0"/>
+                <a:cs typeface="Calibri" panose="020F0502020204030204" pitchFamily="34" charset="0"/>
+              </a:rPr>
+              <a:t>is_compliant</a:t>
+            </a:r>
+            <a:r>
+              <a:rPr lang="en-US" sz="1200" i="1" dirty="0">
+                <a:latin typeface="Calibri" panose="020F0502020204030204" pitchFamily="34" charset="0"/>
+                <a:ea typeface="Calibri" panose="020F0502020204030204" pitchFamily="34" charset="0"/>
+                <a:cs typeface="Calibri" panose="020F0502020204030204" pitchFamily="34" charset="0"/>
+              </a:rPr>
+              <a:t> &gt;= 40.0 MPa).</a:t>
+            </a:r>
+          </a:p>
+          <a:p>
+            <a:pPr marL="228600" lvl="0" indent="-228600">
+              <a:buFont typeface="+mj-lt"/>
+              <a:buAutoNum type="arabicPeriod"/>
+            </a:pPr>
+            <a:endParaRPr lang="en-US" sz="1200" i="1" dirty="0">
+              <a:latin typeface="Calibri" panose="020F0502020204030204" pitchFamily="34" charset="0"/>
+              <a:ea typeface="Calibri" panose="020F0502020204030204" pitchFamily="34" charset="0"/>
+              <a:cs typeface="Calibri" panose="020F0502020204030204" pitchFamily="34" charset="0"/>
+            </a:endParaRPr>
+          </a:p>
+          <a:p>
+            <a:pPr marL="228600" lvl="0" indent="-228600">
+              <a:buFont typeface="+mj-lt"/>
+              <a:buAutoNum type="arabicPeriod"/>
+            </a:pPr>
+            <a:r>
+              <a:rPr lang="en-US" sz="1200" b="1" u="sng" dirty="0">
+                <a:latin typeface="Calibri" panose="020F0502020204030204" pitchFamily="34" charset="0"/>
+                <a:ea typeface="Calibri" panose="020F0502020204030204" pitchFamily="34" charset="0"/>
+                <a:cs typeface="Calibri" panose="020F0502020204030204" pitchFamily="34" charset="0"/>
+              </a:rPr>
+              <a:t>Two-Stage Imputation</a:t>
+            </a:r>
+            <a:r>
+              <a:rPr lang="en-US" sz="1200" i="1" dirty="0">
+                <a:latin typeface="Calibri" panose="020F0502020204030204" pitchFamily="34" charset="0"/>
+                <a:ea typeface="Calibri" panose="020F0502020204030204" pitchFamily="34" charset="0"/>
+                <a:cs typeface="Calibri" panose="020F0502020204030204" pitchFamily="34" charset="0"/>
+              </a:rPr>
+              <a:t>: Applied 2-stage median imputation (group median -&gt; global median fallback) for missing pulse velocity readings.</a:t>
+            </a:r>
+          </a:p>
+          <a:p>
+            <a:pPr marL="228600" lvl="0" indent="-228600">
+              <a:buFont typeface="+mj-lt"/>
+              <a:buAutoNum type="arabicPeriod"/>
+            </a:pPr>
+            <a:endParaRPr lang="en-US" sz="1200" i="1" dirty="0">
+              <a:latin typeface="Calibri" panose="020F0502020204030204" pitchFamily="34" charset="0"/>
+              <a:ea typeface="Calibri" panose="020F0502020204030204" pitchFamily="34" charset="0"/>
+              <a:cs typeface="Calibri" panose="020F0502020204030204" pitchFamily="34" charset="0"/>
+            </a:endParaRPr>
+          </a:p>
+          <a:p>
+            <a:pPr marL="228600" lvl="0" indent="-228600">
+              <a:buFont typeface="+mj-lt"/>
+              <a:buAutoNum type="arabicPeriod"/>
+            </a:pPr>
+            <a:r>
+              <a:rPr lang="en-US" sz="1200" b="1" u="sng" dirty="0">
+                <a:latin typeface="Calibri" panose="020F0502020204030204" pitchFamily="34" charset="0"/>
+                <a:ea typeface="Calibri" panose="020F0502020204030204" pitchFamily="34" charset="0"/>
+                <a:cs typeface="Calibri" panose="020F0502020204030204" pitchFamily="34" charset="0"/>
+              </a:rPr>
+              <a:t>Model Performance</a:t>
+            </a:r>
+            <a:r>
+              <a:rPr lang="en-US" sz="1200" i="1" dirty="0">
+                <a:latin typeface="Calibri" panose="020F0502020204030204" pitchFamily="34" charset="0"/>
+                <a:ea typeface="Calibri" panose="020F0502020204030204" pitchFamily="34" charset="0"/>
+                <a:cs typeface="Calibri" panose="020F0502020204030204" pitchFamily="34" charset="0"/>
+              </a:rPr>
+              <a:t>: Achieved 100% classification accuracy on test evaluation data with zero false positives.</a:t>
+            </a:r>
+            <a:endParaRPr lang="en-US" sz="1400" i="1" dirty="0">
+              <a:latin typeface="Calibri" panose="020F0502020204030204" pitchFamily="34" charset="0"/>
+              <a:ea typeface="Calibri" panose="020F0502020204030204" pitchFamily="34" charset="0"/>
+              <a:cs typeface="Calibri" panose="020F0502020204030204" pitchFamily="34" charset="0"/>
+            </a:endParaRPr>
+          </a:p>
+        </p:txBody>
+      </p:sp>
+      <p:sp>
+        <p:nvSpPr>
+          <p:cNvPr id="15" name="TextBox 14">
+            <a:extLst>
+              <a:ext uri="{FF2B5EF4-FFF2-40B4-BE49-F238E27FC236}">
+                <a16:creationId xmlns:a16="http://schemas.microsoft.com/office/drawing/2014/main" id="{ECD4652E-18D6-F4DA-319F-4062F8AF0913}"/>
+              </a:ext>
+            </a:extLst>
+          </p:cNvPr>
+          <p:cNvSpPr txBox="1"/>
+          <p:nvPr/>
+        </p:nvSpPr>
+        <p:spPr>
+          <a:xfrm>
+            <a:off x="5956468" y="4060578"/>
+            <a:ext cx="5586984" cy="1569660"/>
+          </a:xfrm>
+          <a:prstGeom prst="rect">
+            <a:avLst/>
+          </a:prstGeom>
+          <a:noFill/>
+        </p:spPr>
+        <p:txBody>
+          <a:bodyPr wrap="square" rtlCol="0">
+            <a:spAutoFit/>
+          </a:bodyPr>
+          <a:lstStyle/>
+          <a:p>
+            <a:pPr marL="228600" lvl="0" indent="-228600">
+              <a:buFont typeface="+mj-lt"/>
+              <a:buAutoNum type="arabicPeriod"/>
+            </a:pPr>
+            <a:r>
+              <a:rPr lang="en-US" sz="1200" b="1" u="sng" dirty="0">
+                <a:latin typeface="Calibri" panose="020F0502020204030204" pitchFamily="34" charset="0"/>
+                <a:ea typeface="Calibri" panose="020F0502020204030204" pitchFamily="34" charset="0"/>
+                <a:cs typeface="Calibri" panose="020F0502020204030204" pitchFamily="34" charset="0"/>
+              </a:rPr>
+              <a:t>Ultrasonic Pulse Velocity (54.02%): </a:t>
+            </a:r>
+            <a:r>
+              <a:rPr lang="en-US" sz="1200" i="1" dirty="0">
+                <a:latin typeface="Calibri" panose="020F0502020204030204" pitchFamily="34" charset="0"/>
+                <a:ea typeface="Calibri" panose="020F0502020204030204" pitchFamily="34" charset="0"/>
+                <a:cs typeface="Calibri" panose="020F0502020204030204" pitchFamily="34" charset="0"/>
+              </a:rPr>
+              <a:t>Proved acoustic sound velocity (internal concrete density) is the dominant predictor of concrete strength.</a:t>
+            </a:r>
+          </a:p>
+          <a:p>
+            <a:pPr marL="228600" lvl="0" indent="-228600">
+              <a:buFont typeface="+mj-lt"/>
+              <a:buAutoNum type="arabicPeriod"/>
+            </a:pPr>
+            <a:endParaRPr lang="en-US" sz="1200" i="1" dirty="0">
+              <a:latin typeface="Calibri" panose="020F0502020204030204" pitchFamily="34" charset="0"/>
+              <a:ea typeface="Calibri" panose="020F0502020204030204" pitchFamily="34" charset="0"/>
+              <a:cs typeface="Calibri" panose="020F0502020204030204" pitchFamily="34" charset="0"/>
+            </a:endParaRPr>
+          </a:p>
+          <a:p>
+            <a:pPr marL="228600" lvl="0" indent="-228600">
+              <a:buFont typeface="+mj-lt"/>
+              <a:buAutoNum type="arabicPeriod"/>
+            </a:pPr>
+            <a:r>
+              <a:rPr lang="en-US" sz="1200" b="1" u="sng" dirty="0">
+                <a:latin typeface="Calibri" panose="020F0502020204030204" pitchFamily="34" charset="0"/>
+                <a:ea typeface="Calibri" panose="020F0502020204030204" pitchFamily="34" charset="0"/>
+                <a:cs typeface="Calibri" panose="020F0502020204030204" pitchFamily="34" charset="0"/>
+              </a:rPr>
+              <a:t>Curing Duration Age (45.98%):</a:t>
+            </a:r>
+            <a:r>
+              <a:rPr lang="en-US" sz="1200" i="1" dirty="0">
+                <a:latin typeface="Calibri" panose="020F0502020204030204" pitchFamily="34" charset="0"/>
+                <a:ea typeface="Calibri" panose="020F0502020204030204" pitchFamily="34" charset="0"/>
+                <a:cs typeface="Calibri" panose="020F0502020204030204" pitchFamily="34" charset="0"/>
+              </a:rPr>
+              <a:t> Serves as the secondary predictor for characteristic strength development over time.</a:t>
+            </a:r>
+          </a:p>
+          <a:p>
+            <a:pPr marL="228600" lvl="0" indent="-228600">
+              <a:buFont typeface="+mj-lt"/>
+              <a:buAutoNum type="arabicPeriod"/>
+            </a:pPr>
+            <a:endParaRPr lang="en-US" sz="1200" i="1" dirty="0">
+              <a:latin typeface="Calibri" panose="020F0502020204030204" pitchFamily="34" charset="0"/>
+              <a:ea typeface="Calibri" panose="020F0502020204030204" pitchFamily="34" charset="0"/>
+              <a:cs typeface="Calibri" panose="020F0502020204030204" pitchFamily="34" charset="0"/>
+            </a:endParaRPr>
+          </a:p>
+          <a:p>
+            <a:pPr marL="228600" lvl="0" indent="-228600">
+              <a:buFont typeface="+mj-lt"/>
+              <a:buAutoNum type="arabicPeriod"/>
+            </a:pPr>
+            <a:r>
+              <a:rPr lang="en-US" sz="1200" b="1" u="sng" dirty="0">
+                <a:latin typeface="Calibri" panose="020F0502020204030204" pitchFamily="34" charset="0"/>
+                <a:ea typeface="Calibri" panose="020F0502020204030204" pitchFamily="34" charset="0"/>
+                <a:cs typeface="Calibri" panose="020F0502020204030204" pitchFamily="34" charset="0"/>
+              </a:rPr>
+              <a:t>Commercial Impact: </a:t>
+            </a:r>
+            <a:r>
+              <a:rPr lang="en-US" sz="1200" i="1" dirty="0">
+                <a:latin typeface="Calibri" panose="020F0502020204030204" pitchFamily="34" charset="0"/>
+                <a:ea typeface="Calibri" panose="020F0502020204030204" pitchFamily="34" charset="0"/>
+                <a:cs typeface="Calibri" panose="020F0502020204030204" pitchFamily="34" charset="0"/>
+              </a:rPr>
+              <a:t>Proves early sound wave testing predicts 28-day compliance early, unlocking client retention funds 21-28 days faster.</a:t>
+            </a:r>
+            <a:endParaRPr lang="en-US" sz="1400" i="1" dirty="0">
+              <a:latin typeface="Calibri" panose="020F0502020204030204" pitchFamily="34" charset="0"/>
+              <a:ea typeface="Calibri" panose="020F0502020204030204" pitchFamily="34" charset="0"/>
+              <a:cs typeface="Calibri" panose="020F0502020204030204" pitchFamily="34" charset="0"/>
+            </a:endParaRPr>
+          </a:p>
+        </p:txBody>
+      </p:sp>
+      <p:pic>
+        <p:nvPicPr>
+          <p:cNvPr id="17" name="Picture 16">
+            <a:extLst>
+              <a:ext uri="{FF2B5EF4-FFF2-40B4-BE49-F238E27FC236}">
+                <a16:creationId xmlns:a16="http://schemas.microsoft.com/office/drawing/2014/main" id="{49D163CC-9840-0D2D-EEE8-6A94E72AB0B8}"/>
+              </a:ext>
+            </a:extLst>
+          </p:cNvPr>
+          <p:cNvPicPr>
+            <a:picLocks noChangeAspect="1"/>
+          </p:cNvPicPr>
+          <p:nvPr/>
+        </p:nvPicPr>
+        <p:blipFill>
+          <a:blip r:embed="rId2">
+            <a:extLst>
+              <a:ext uri="{28A0092B-C50C-407E-A947-70E740481C1C}">
+                <a14:useLocalDpi xmlns:a14="http://schemas.microsoft.com/office/drawing/2010/main" val="0"/>
+              </a:ext>
+            </a:extLst>
+          </a:blip>
+          <a:stretch>
+            <a:fillRect/>
+          </a:stretch>
+        </p:blipFill>
+        <p:spPr>
+          <a:xfrm>
+            <a:off x="109728" y="1052268"/>
+            <a:ext cx="5221900" cy="4434840"/>
+          </a:xfrm>
+          <a:prstGeom prst="rect">
+            <a:avLst/>
+          </a:prstGeom>
+        </p:spPr>
+      </p:pic>
+      <p:sp>
+        <p:nvSpPr>
+          <p:cNvPr id="19" name="TextBox 18">
+            <a:extLst>
+              <a:ext uri="{FF2B5EF4-FFF2-40B4-BE49-F238E27FC236}">
+                <a16:creationId xmlns:a16="http://schemas.microsoft.com/office/drawing/2014/main" id="{7E7D1513-361D-9ECC-A44C-3FDEB4BC8B1D}"/>
+              </a:ext>
+            </a:extLst>
+          </p:cNvPr>
+          <p:cNvSpPr txBox="1"/>
+          <p:nvPr/>
+        </p:nvSpPr>
+        <p:spPr>
+          <a:xfrm>
+            <a:off x="0" y="6334780"/>
+            <a:ext cx="8010144" cy="523220"/>
+          </a:xfrm>
+          <a:prstGeom prst="rect">
+            <a:avLst/>
+          </a:prstGeom>
+          <a:noFill/>
+        </p:spPr>
+        <p:txBody>
+          <a:bodyPr wrap="square" rtlCol="0">
+            <a:spAutoFit/>
+          </a:bodyPr>
+          <a:lstStyle/>
+          <a:p>
+            <a:r>
+              <a:rPr lang="en-US" sz="1400" dirty="0">
+                <a:latin typeface="Calibri" panose="020F0502020204030204" pitchFamily="34" charset="0"/>
+                <a:ea typeface="Calibri" panose="020F0502020204030204" pitchFamily="34" charset="0"/>
+                <a:cs typeface="Calibri" panose="020F0502020204030204" pitchFamily="34" charset="0"/>
+              </a:rPr>
+              <a:t>Project Repository:</a:t>
+            </a:r>
+          </a:p>
+          <a:p>
+            <a:r>
+              <a:rPr lang="en-US" sz="1400" dirty="0">
+                <a:latin typeface="Calibri" panose="020F0502020204030204" pitchFamily="34" charset="0"/>
+                <a:ea typeface="Calibri" panose="020F0502020204030204" pitchFamily="34" charset="0"/>
+                <a:cs typeface="Calibri" panose="020F0502020204030204" pitchFamily="34" charset="0"/>
+                <a:hlinkClick r:id="rId3"/>
+              </a:rPr>
+              <a:t>https://github.com/Pallabi5200/Civil_Engineering_Data_Science_Project</a:t>
+            </a:r>
+            <a:endParaRPr lang="en-US" sz="1400" dirty="0">
+              <a:latin typeface="Calibri" panose="020F0502020204030204" pitchFamily="34" charset="0"/>
+              <a:ea typeface="Calibri" panose="020F0502020204030204" pitchFamily="34" charset="0"/>
+              <a:cs typeface="Calibri" panose="020F0502020204030204" pitchFamily="34" charset="0"/>
+            </a:endParaRPr>
+          </a:p>
+        </p:txBody>
+      </p:sp>
+    </p:spTree>
+    <p:extLst>
+      <p:ext uri="{BB962C8B-B14F-4D97-AF65-F5344CB8AC3E}">
+        <p14:creationId xmlns:p14="http://schemas.microsoft.com/office/powerpoint/2010/main" val="1834805631"/>
+      </p:ext>
+    </p:extLst>
+  </p:cSld>
+  <p:clrMapOvr>
+    <a:masterClrMapping/>
+  </p:clrMapOvr>
+</p:sld>
+</file>
+
+<file path=ppt/slides/slide11.xml><?xml version="1.0" encoding="utf-8"?>
+<p:sld xmlns:a="http://schemas.openxmlformats.org/drawingml/2006/main" xmlns:r="http://schemas.openxmlformats.org/officeDocument/2006/relationships" xmlns:p="http://schemas.openxmlformats.org/presentationml/2006/main">
+  <p:cSld>
+    <p:spTree>
+      <p:nvGrpSpPr>
+        <p:cNvPr id="1" name=""/>
+        <p:cNvGrpSpPr/>
+        <p:nvPr/>
+      </p:nvGrpSpPr>
+      <p:grpSpPr>
+        <a:xfrm>
+          <a:off x="0" y="0"/>
+          <a:ext cx="0" cy="0"/>
+          <a:chOff x="0" y="0"/>
+          <a:chExt cx="0" cy="0"/>
+        </a:xfrm>
+      </p:grpSpPr>
+      <p:sp>
+        <p:nvSpPr>
+          <p:cNvPr id="3" name="TextBox 2">
+            <a:extLst>
+              <a:ext uri="{FF2B5EF4-FFF2-40B4-BE49-F238E27FC236}">
+                <a16:creationId xmlns:a16="http://schemas.microsoft.com/office/drawing/2014/main" id="{3273C79D-D103-61D5-E852-D4AC719CAEC7}"/>
+              </a:ext>
+            </a:extLst>
+          </p:cNvPr>
+          <p:cNvSpPr txBox="1"/>
+          <p:nvPr/>
+        </p:nvSpPr>
+        <p:spPr>
+          <a:xfrm>
+            <a:off x="510619" y="139422"/>
+            <a:ext cx="11170762" cy="584775"/>
+          </a:xfrm>
+          <a:prstGeom prst="rect">
+            <a:avLst/>
+          </a:prstGeom>
+          <a:noFill/>
+        </p:spPr>
+        <p:txBody>
+          <a:bodyPr wrap="square" rtlCol="0">
+            <a:spAutoFit/>
+          </a:bodyPr>
+          <a:lstStyle/>
+          <a:p>
+            <a:pPr algn="ctr"/>
+            <a:r>
+              <a:rPr lang="en-US" sz="3200" b="1" u="sng" dirty="0">
+                <a:latin typeface="Calibri" panose="020F0502020204030204" pitchFamily="34" charset="0"/>
+                <a:ea typeface="Calibri" panose="020F0502020204030204" pitchFamily="34" charset="0"/>
+                <a:cs typeface="Calibri" panose="020F0502020204030204" pitchFamily="34" charset="0"/>
+              </a:rPr>
+              <a:t>Commercial Business Impact, ROI &amp; Future Roadmap</a:t>
+            </a:r>
+          </a:p>
+        </p:txBody>
+      </p:sp>
+      <p:sp>
+        <p:nvSpPr>
+          <p:cNvPr id="6" name="Flowchart: Process 5">
+            <a:extLst>
+              <a:ext uri="{FF2B5EF4-FFF2-40B4-BE49-F238E27FC236}">
+                <a16:creationId xmlns:a16="http://schemas.microsoft.com/office/drawing/2014/main" id="{ACB05D5F-E18B-1BE1-4C18-35DFEB6FF9B3}"/>
+              </a:ext>
+            </a:extLst>
+          </p:cNvPr>
+          <p:cNvSpPr/>
+          <p:nvPr/>
+        </p:nvSpPr>
+        <p:spPr>
+          <a:xfrm>
+            <a:off x="1184148" y="2310051"/>
+            <a:ext cx="3319272" cy="649224"/>
+          </a:xfrm>
+          <a:prstGeom prst="flowChartProcess">
+            <a:avLst/>
+          </a:prstGeom>
+          <a:gradFill flip="none" rotWithShape="1">
+            <a:gsLst>
+              <a:gs pos="0">
+                <a:schemeClr val="accent2">
+                  <a:lumMod val="67000"/>
+                </a:schemeClr>
+              </a:gs>
+              <a:gs pos="48000">
+                <a:schemeClr val="accent2">
+                  <a:lumMod val="97000"/>
+                  <a:lumOff val="3000"/>
+                </a:schemeClr>
+              </a:gs>
+              <a:gs pos="100000">
+                <a:schemeClr val="accent2">
+                  <a:lumMod val="60000"/>
+                  <a:lumOff val="40000"/>
+                </a:schemeClr>
+              </a:gs>
+            </a:gsLst>
+            <a:lin ang="16200000" scaled="1"/>
+            <a:tileRect/>
+          </a:gradFill>
+          <a:ln>
+            <a:noFill/>
+          </a:ln>
+        </p:spPr>
+        <p:style>
+          <a:lnRef idx="0">
+            <a:scrgbClr r="0" g="0" b="0"/>
+          </a:lnRef>
+          <a:fillRef idx="0">
+            <a:scrgbClr r="0" g="0" b="0"/>
+          </a:fillRef>
+          <a:effectRef idx="0">
+            <a:scrgbClr r="0" g="0" b="0"/>
+          </a:effectRef>
+          <a:fontRef idx="minor">
+            <a:schemeClr val="lt1"/>
+          </a:fontRef>
+        </p:style>
+        <p:txBody>
+          <a:bodyPr rtlCol="0" anchor="ctr"/>
+          <a:lstStyle/>
+          <a:p>
+            <a:pPr algn="ctr"/>
+            <a:endParaRPr lang="en-US"/>
+          </a:p>
+        </p:txBody>
+      </p:sp>
+      <p:sp>
+        <p:nvSpPr>
+          <p:cNvPr id="8" name="Flowchart: Process 7">
+            <a:extLst>
+              <a:ext uri="{FF2B5EF4-FFF2-40B4-BE49-F238E27FC236}">
+                <a16:creationId xmlns:a16="http://schemas.microsoft.com/office/drawing/2014/main" id="{7B42508A-A487-AE0C-09E2-F0BC729EBCFC}"/>
+              </a:ext>
+            </a:extLst>
+          </p:cNvPr>
+          <p:cNvSpPr/>
+          <p:nvPr/>
+        </p:nvSpPr>
+        <p:spPr>
+          <a:xfrm>
+            <a:off x="1149096" y="3627121"/>
+            <a:ext cx="3319272" cy="649224"/>
+          </a:xfrm>
+          <a:prstGeom prst="flowChartProcess">
+            <a:avLst/>
+          </a:prstGeom>
+          <a:gradFill flip="none" rotWithShape="1">
+            <a:gsLst>
+              <a:gs pos="0">
+                <a:schemeClr val="accent2">
+                  <a:lumMod val="67000"/>
+                </a:schemeClr>
+              </a:gs>
+              <a:gs pos="48000">
+                <a:schemeClr val="accent2">
+                  <a:lumMod val="97000"/>
+                  <a:lumOff val="3000"/>
+                </a:schemeClr>
+              </a:gs>
+              <a:gs pos="100000">
+                <a:schemeClr val="accent2">
+                  <a:lumMod val="60000"/>
+                  <a:lumOff val="40000"/>
+                </a:schemeClr>
+              </a:gs>
+            </a:gsLst>
+            <a:lin ang="16200000" scaled="1"/>
+            <a:tileRect/>
+          </a:gradFill>
+          <a:ln>
+            <a:noFill/>
+          </a:ln>
+        </p:spPr>
+        <p:style>
+          <a:lnRef idx="0">
+            <a:scrgbClr r="0" g="0" b="0"/>
+          </a:lnRef>
+          <a:fillRef idx="0">
+            <a:scrgbClr r="0" g="0" b="0"/>
+          </a:fillRef>
+          <a:effectRef idx="0">
+            <a:scrgbClr r="0" g="0" b="0"/>
+          </a:effectRef>
+          <a:fontRef idx="minor">
+            <a:schemeClr val="lt1"/>
+          </a:fontRef>
+        </p:style>
+        <p:txBody>
+          <a:bodyPr rtlCol="0" anchor="ctr"/>
+          <a:lstStyle/>
+          <a:p>
+            <a:pPr algn="ctr"/>
+            <a:endParaRPr lang="en-US"/>
+          </a:p>
+        </p:txBody>
+      </p:sp>
+      <p:sp>
+        <p:nvSpPr>
+          <p:cNvPr id="10" name="Flowchart: Process 9">
+            <a:extLst>
+              <a:ext uri="{FF2B5EF4-FFF2-40B4-BE49-F238E27FC236}">
+                <a16:creationId xmlns:a16="http://schemas.microsoft.com/office/drawing/2014/main" id="{E58647BC-6674-C831-FF5E-876F03B16147}"/>
+              </a:ext>
+            </a:extLst>
+          </p:cNvPr>
+          <p:cNvSpPr/>
+          <p:nvPr/>
+        </p:nvSpPr>
+        <p:spPr>
+          <a:xfrm>
+            <a:off x="1184148" y="4944191"/>
+            <a:ext cx="3319272" cy="649224"/>
+          </a:xfrm>
+          <a:prstGeom prst="flowChartProcess">
+            <a:avLst/>
+          </a:prstGeom>
+          <a:gradFill flip="none" rotWithShape="1">
+            <a:gsLst>
+              <a:gs pos="0">
+                <a:schemeClr val="accent2">
+                  <a:lumMod val="67000"/>
+                </a:schemeClr>
+              </a:gs>
+              <a:gs pos="48000">
+                <a:schemeClr val="accent2">
+                  <a:lumMod val="97000"/>
+                  <a:lumOff val="3000"/>
+                </a:schemeClr>
+              </a:gs>
+              <a:gs pos="100000">
+                <a:schemeClr val="accent2">
+                  <a:lumMod val="60000"/>
+                  <a:lumOff val="40000"/>
+                </a:schemeClr>
+              </a:gs>
+            </a:gsLst>
+            <a:lin ang="16200000" scaled="1"/>
+            <a:tileRect/>
+          </a:gradFill>
+          <a:ln>
+            <a:noFill/>
+          </a:ln>
+        </p:spPr>
+        <p:style>
+          <a:lnRef idx="0">
+            <a:scrgbClr r="0" g="0" b="0"/>
+          </a:lnRef>
+          <a:fillRef idx="0">
+            <a:scrgbClr r="0" g="0" b="0"/>
+          </a:fillRef>
+          <a:effectRef idx="0">
+            <a:scrgbClr r="0" g="0" b="0"/>
+          </a:effectRef>
+          <a:fontRef idx="minor">
+            <a:schemeClr val="lt1"/>
+          </a:fontRef>
+        </p:style>
+        <p:txBody>
+          <a:bodyPr rtlCol="0" anchor="ctr"/>
+          <a:lstStyle/>
+          <a:p>
+            <a:pPr algn="ctr"/>
+            <a:endParaRPr lang="en-US"/>
+          </a:p>
+        </p:txBody>
+      </p:sp>
+      <p:sp>
+        <p:nvSpPr>
+          <p:cNvPr id="11" name="Oval 10">
+            <a:extLst>
+              <a:ext uri="{FF2B5EF4-FFF2-40B4-BE49-F238E27FC236}">
+                <a16:creationId xmlns:a16="http://schemas.microsoft.com/office/drawing/2014/main" id="{7E33CB6A-950B-7DE9-AD5E-75D84735652F}"/>
+              </a:ext>
+            </a:extLst>
+          </p:cNvPr>
+          <p:cNvSpPr/>
+          <p:nvPr/>
+        </p:nvSpPr>
+        <p:spPr>
+          <a:xfrm>
+            <a:off x="996696" y="855636"/>
+            <a:ext cx="3383280" cy="1229789"/>
+          </a:xfrm>
+          <a:prstGeom prst="ellipse">
+            <a:avLst/>
+          </a:prstGeom>
+        </p:spPr>
+        <p:style>
+          <a:lnRef idx="1">
+            <a:schemeClr val="accent4"/>
+          </a:lnRef>
+          <a:fillRef idx="2">
+            <a:schemeClr val="accent4"/>
+          </a:fillRef>
+          <a:effectRef idx="1">
+            <a:schemeClr val="accent4"/>
+          </a:effectRef>
+          <a:fontRef idx="minor">
+            <a:schemeClr val="dk1"/>
+          </a:fontRef>
+        </p:style>
+        <p:txBody>
+          <a:bodyPr rtlCol="0" anchor="ctr"/>
+          <a:lstStyle/>
+          <a:p>
+            <a:pPr algn="ctr"/>
+            <a:endParaRPr lang="en-US"/>
+          </a:p>
+        </p:txBody>
+      </p:sp>
+      <p:sp>
+        <p:nvSpPr>
+          <p:cNvPr id="12" name="Arrow: Down 11">
+            <a:extLst>
+              <a:ext uri="{FF2B5EF4-FFF2-40B4-BE49-F238E27FC236}">
+                <a16:creationId xmlns:a16="http://schemas.microsoft.com/office/drawing/2014/main" id="{945EFAB0-0685-F8F7-3E8D-57850F0B1AB0}"/>
+              </a:ext>
+            </a:extLst>
+          </p:cNvPr>
+          <p:cNvSpPr/>
+          <p:nvPr/>
+        </p:nvSpPr>
+        <p:spPr>
+          <a:xfrm>
+            <a:off x="2596896" y="2977898"/>
+            <a:ext cx="246888" cy="649224"/>
+          </a:xfrm>
+          <a:prstGeom prst="downArrow">
+            <a:avLst/>
+          </a:prstGeom>
+        </p:spPr>
+        <p:style>
+          <a:lnRef idx="2">
+            <a:schemeClr val="accent6">
+              <a:shade val="15000"/>
+            </a:schemeClr>
+          </a:lnRef>
+          <a:fillRef idx="1">
+            <a:schemeClr val="accent6"/>
+          </a:fillRef>
+          <a:effectRef idx="0">
+            <a:schemeClr val="accent6"/>
+          </a:effectRef>
+          <a:fontRef idx="minor">
+            <a:schemeClr val="lt1"/>
+          </a:fontRef>
+        </p:style>
+        <p:txBody>
+          <a:bodyPr rtlCol="0" anchor="ctr"/>
+          <a:lstStyle/>
+          <a:p>
+            <a:pPr algn="ctr"/>
+            <a:endParaRPr lang="en-US"/>
+          </a:p>
+        </p:txBody>
+      </p:sp>
+      <p:sp>
+        <p:nvSpPr>
+          <p:cNvPr id="13" name="Arrow: Down 12">
+            <a:extLst>
+              <a:ext uri="{FF2B5EF4-FFF2-40B4-BE49-F238E27FC236}">
+                <a16:creationId xmlns:a16="http://schemas.microsoft.com/office/drawing/2014/main" id="{AC79938E-6A56-C5B0-D5DA-F393B4D499BD}"/>
+              </a:ext>
+            </a:extLst>
+          </p:cNvPr>
+          <p:cNvSpPr/>
+          <p:nvPr/>
+        </p:nvSpPr>
+        <p:spPr>
+          <a:xfrm>
+            <a:off x="2642615" y="4276345"/>
+            <a:ext cx="246888" cy="649224"/>
+          </a:xfrm>
+          <a:prstGeom prst="downArrow">
+            <a:avLst/>
+          </a:prstGeom>
+        </p:spPr>
+        <p:style>
+          <a:lnRef idx="2">
+            <a:schemeClr val="accent6">
+              <a:shade val="15000"/>
+            </a:schemeClr>
+          </a:lnRef>
+          <a:fillRef idx="1">
+            <a:schemeClr val="accent6"/>
+          </a:fillRef>
+          <a:effectRef idx="0">
+            <a:schemeClr val="accent6"/>
+          </a:effectRef>
+          <a:fontRef idx="minor">
+            <a:schemeClr val="lt1"/>
+          </a:fontRef>
+        </p:style>
+        <p:txBody>
+          <a:bodyPr rtlCol="0" anchor="ctr"/>
+          <a:lstStyle/>
+          <a:p>
+            <a:pPr algn="ctr"/>
+            <a:endParaRPr lang="en-US"/>
+          </a:p>
+        </p:txBody>
+      </p:sp>
+      <p:sp>
+        <p:nvSpPr>
+          <p:cNvPr id="15" name="TextBox 14">
+            <a:extLst>
+              <a:ext uri="{FF2B5EF4-FFF2-40B4-BE49-F238E27FC236}">
+                <a16:creationId xmlns:a16="http://schemas.microsoft.com/office/drawing/2014/main" id="{40CC259F-EF16-9894-AECB-DAEBE71B7316}"/>
+              </a:ext>
+            </a:extLst>
+          </p:cNvPr>
+          <p:cNvSpPr txBox="1"/>
+          <p:nvPr/>
+        </p:nvSpPr>
+        <p:spPr>
+          <a:xfrm>
+            <a:off x="140781" y="1178570"/>
+            <a:ext cx="5095109" cy="338554"/>
+          </a:xfrm>
+          <a:prstGeom prst="rect">
+            <a:avLst/>
+          </a:prstGeom>
+          <a:noFill/>
+        </p:spPr>
+        <p:txBody>
+          <a:bodyPr wrap="square" rtlCol="0">
+            <a:spAutoFit/>
+          </a:bodyPr>
+          <a:lstStyle/>
+          <a:p>
+            <a:pPr algn="ctr"/>
+            <a:r>
+              <a:rPr lang="en-US" sz="1600" b="1" u="sng" dirty="0">
+                <a:latin typeface="Calibri" panose="020F0502020204030204" pitchFamily="34" charset="0"/>
+                <a:ea typeface="Calibri" panose="020F0502020204030204" pitchFamily="34" charset="0"/>
+                <a:cs typeface="Calibri" panose="020F0502020204030204" pitchFamily="34" charset="0"/>
+              </a:rPr>
+              <a:t>ROI Architecture Flowchart </a:t>
+            </a:r>
+            <a:endParaRPr lang="en-US" sz="1600" u="sng" dirty="0">
+              <a:latin typeface="Calibri" panose="020F0502020204030204" pitchFamily="34" charset="0"/>
+              <a:ea typeface="Calibri" panose="020F0502020204030204" pitchFamily="34" charset="0"/>
+              <a:cs typeface="Calibri" panose="020F0502020204030204" pitchFamily="34" charset="0"/>
+            </a:endParaRPr>
+          </a:p>
+        </p:txBody>
+      </p:sp>
+      <p:sp>
+        <p:nvSpPr>
+          <p:cNvPr id="17" name="TextBox 16">
+            <a:extLst>
+              <a:ext uri="{FF2B5EF4-FFF2-40B4-BE49-F238E27FC236}">
+                <a16:creationId xmlns:a16="http://schemas.microsoft.com/office/drawing/2014/main" id="{C956F21C-782A-CCE2-96C8-5B57FB641864}"/>
+              </a:ext>
+            </a:extLst>
+          </p:cNvPr>
+          <p:cNvSpPr txBox="1"/>
+          <p:nvPr/>
+        </p:nvSpPr>
+        <p:spPr>
+          <a:xfrm>
+            <a:off x="261177" y="2414717"/>
+            <a:ext cx="5095109" cy="338554"/>
+          </a:xfrm>
+          <a:prstGeom prst="rect">
+            <a:avLst/>
+          </a:prstGeom>
+          <a:noFill/>
+        </p:spPr>
+        <p:txBody>
+          <a:bodyPr wrap="square" rtlCol="0">
+            <a:spAutoFit/>
+          </a:bodyPr>
+          <a:lstStyle/>
+          <a:p>
+            <a:pPr algn="ctr"/>
+            <a:r>
+              <a:rPr lang="en-US" sz="1600" b="1" dirty="0">
+                <a:latin typeface="Calibri" panose="020F0502020204030204" pitchFamily="34" charset="0"/>
+                <a:ea typeface="Calibri" panose="020F0502020204030204" pitchFamily="34" charset="0"/>
+                <a:cs typeface="Calibri" panose="020F0502020204030204" pitchFamily="34" charset="0"/>
+              </a:rPr>
+              <a:t>Early Sound Wave NDT</a:t>
+            </a:r>
+            <a:endParaRPr lang="en-US" sz="1600" dirty="0">
+              <a:latin typeface="Calibri" panose="020F0502020204030204" pitchFamily="34" charset="0"/>
+              <a:ea typeface="Calibri" panose="020F0502020204030204" pitchFamily="34" charset="0"/>
+              <a:cs typeface="Calibri" panose="020F0502020204030204" pitchFamily="34" charset="0"/>
+            </a:endParaRPr>
+          </a:p>
+        </p:txBody>
+      </p:sp>
+      <p:sp>
+        <p:nvSpPr>
+          <p:cNvPr id="19" name="TextBox 18">
+            <a:extLst>
+              <a:ext uri="{FF2B5EF4-FFF2-40B4-BE49-F238E27FC236}">
+                <a16:creationId xmlns:a16="http://schemas.microsoft.com/office/drawing/2014/main" id="{52319F6E-C495-B176-50B6-20D12CF8A538}"/>
+              </a:ext>
+            </a:extLst>
+          </p:cNvPr>
+          <p:cNvSpPr txBox="1"/>
+          <p:nvPr/>
+        </p:nvSpPr>
+        <p:spPr>
+          <a:xfrm>
+            <a:off x="261176" y="3756119"/>
+            <a:ext cx="5095109" cy="338554"/>
+          </a:xfrm>
+          <a:prstGeom prst="rect">
+            <a:avLst/>
+          </a:prstGeom>
+          <a:noFill/>
+        </p:spPr>
+        <p:txBody>
+          <a:bodyPr wrap="square" rtlCol="0">
+            <a:spAutoFit/>
+          </a:bodyPr>
+          <a:lstStyle/>
+          <a:p>
+            <a:pPr algn="ctr"/>
+            <a:r>
+              <a:rPr lang="en-US" sz="1600" b="1" dirty="0">
+                <a:latin typeface="Calibri" panose="020F0502020204030204" pitchFamily="34" charset="0"/>
+                <a:ea typeface="Calibri" panose="020F0502020204030204" pitchFamily="34" charset="0"/>
+                <a:cs typeface="Calibri" panose="020F0502020204030204" pitchFamily="34" charset="0"/>
+              </a:rPr>
+              <a:t>Machine Learning Engine</a:t>
+            </a:r>
+            <a:endParaRPr lang="en-US" sz="1600" dirty="0">
+              <a:latin typeface="Calibri" panose="020F0502020204030204" pitchFamily="34" charset="0"/>
+              <a:ea typeface="Calibri" panose="020F0502020204030204" pitchFamily="34" charset="0"/>
+              <a:cs typeface="Calibri" panose="020F0502020204030204" pitchFamily="34" charset="0"/>
+            </a:endParaRPr>
+          </a:p>
+        </p:txBody>
+      </p:sp>
+      <p:sp>
+        <p:nvSpPr>
+          <p:cNvPr id="21" name="TextBox 20">
+            <a:extLst>
+              <a:ext uri="{FF2B5EF4-FFF2-40B4-BE49-F238E27FC236}">
+                <a16:creationId xmlns:a16="http://schemas.microsoft.com/office/drawing/2014/main" id="{42935658-E553-AF5C-47CE-D40EDA27989D}"/>
+              </a:ext>
+            </a:extLst>
+          </p:cNvPr>
+          <p:cNvSpPr txBox="1"/>
+          <p:nvPr/>
+        </p:nvSpPr>
+        <p:spPr>
+          <a:xfrm>
+            <a:off x="341948" y="5097521"/>
+            <a:ext cx="5095109" cy="338554"/>
+          </a:xfrm>
+          <a:prstGeom prst="rect">
+            <a:avLst/>
+          </a:prstGeom>
+          <a:noFill/>
+        </p:spPr>
+        <p:txBody>
+          <a:bodyPr wrap="square" rtlCol="0">
+            <a:spAutoFit/>
+          </a:bodyPr>
+          <a:lstStyle/>
+          <a:p>
+            <a:pPr algn="ctr"/>
+            <a:r>
+              <a:rPr lang="en-US" sz="1600" b="1" dirty="0">
+                <a:latin typeface="Calibri" panose="020F0502020204030204" pitchFamily="34" charset="0"/>
+                <a:ea typeface="Calibri" panose="020F0502020204030204" pitchFamily="34" charset="0"/>
+                <a:cs typeface="Calibri" panose="020F0502020204030204" pitchFamily="34" charset="0"/>
+              </a:rPr>
+              <a:t>21-28 Days Faster Retention Payouts</a:t>
+            </a:r>
+            <a:endParaRPr lang="en-US" sz="1600" dirty="0">
+              <a:latin typeface="Calibri" panose="020F0502020204030204" pitchFamily="34" charset="0"/>
+              <a:ea typeface="Calibri" panose="020F0502020204030204" pitchFamily="34" charset="0"/>
+              <a:cs typeface="Calibri" panose="020F0502020204030204" pitchFamily="34" charset="0"/>
+            </a:endParaRPr>
+          </a:p>
+        </p:txBody>
+      </p:sp>
+      <p:sp>
+        <p:nvSpPr>
+          <p:cNvPr id="23" name="Rectangle: Rounded Corners 22">
+            <a:extLst>
+              <a:ext uri="{FF2B5EF4-FFF2-40B4-BE49-F238E27FC236}">
+                <a16:creationId xmlns:a16="http://schemas.microsoft.com/office/drawing/2014/main" id="{0D84DAFD-9C42-C2FC-54E6-955DCB41742E}"/>
+              </a:ext>
+            </a:extLst>
+          </p:cNvPr>
+          <p:cNvSpPr/>
+          <p:nvPr/>
+        </p:nvSpPr>
+        <p:spPr>
+          <a:xfrm>
+            <a:off x="5686720" y="987552"/>
+            <a:ext cx="6211824" cy="2368296"/>
+          </a:xfrm>
+          <a:prstGeom prst="roundRect">
+            <a:avLst/>
+          </a:prstGeom>
+          <a:ln/>
+        </p:spPr>
+        <p:style>
+          <a:lnRef idx="1">
+            <a:schemeClr val="accent4"/>
+          </a:lnRef>
+          <a:fillRef idx="2">
+            <a:schemeClr val="accent4"/>
+          </a:fillRef>
+          <a:effectRef idx="1">
+            <a:schemeClr val="accent4"/>
+          </a:effectRef>
+          <a:fontRef idx="minor">
+            <a:schemeClr val="dk1"/>
+          </a:fontRef>
+        </p:style>
+        <p:txBody>
+          <a:bodyPr rtlCol="0" anchor="ctr"/>
+          <a:lstStyle/>
+          <a:p>
+            <a:pPr algn="ctr"/>
+            <a:endParaRPr lang="en-US"/>
+          </a:p>
+        </p:txBody>
+      </p:sp>
+      <p:sp>
+        <p:nvSpPr>
+          <p:cNvPr id="25" name="Rectangle: Rounded Corners 24">
+            <a:extLst>
+              <a:ext uri="{FF2B5EF4-FFF2-40B4-BE49-F238E27FC236}">
+                <a16:creationId xmlns:a16="http://schemas.microsoft.com/office/drawing/2014/main" id="{DF4AEB51-F95F-1B09-BB73-AC50AC9A2A1E}"/>
+              </a:ext>
+            </a:extLst>
+          </p:cNvPr>
+          <p:cNvSpPr/>
+          <p:nvPr/>
+        </p:nvSpPr>
+        <p:spPr>
+          <a:xfrm>
+            <a:off x="5686720" y="3546050"/>
+            <a:ext cx="6126480" cy="2598717"/>
+          </a:xfrm>
+          <a:prstGeom prst="roundRect">
+            <a:avLst/>
+          </a:prstGeom>
+          <a:gradFill flip="none" rotWithShape="1">
+            <a:gsLst>
+              <a:gs pos="0">
+                <a:schemeClr val="accent6">
+                  <a:lumMod val="67000"/>
+                </a:schemeClr>
+              </a:gs>
+              <a:gs pos="48000">
+                <a:schemeClr val="accent6">
+                  <a:lumMod val="97000"/>
+                  <a:lumOff val="3000"/>
+                </a:schemeClr>
+              </a:gs>
+              <a:gs pos="100000">
+                <a:schemeClr val="accent6">
+                  <a:lumMod val="60000"/>
+                  <a:lumOff val="40000"/>
+                </a:schemeClr>
+              </a:gs>
+            </a:gsLst>
+            <a:lin ang="16200000" scaled="1"/>
+            <a:tileRect/>
+          </a:gradFill>
+          <a:ln>
+            <a:noFill/>
+          </a:ln>
+        </p:spPr>
+        <p:style>
+          <a:lnRef idx="0">
+            <a:scrgbClr r="0" g="0" b="0"/>
+          </a:lnRef>
+          <a:fillRef idx="0">
+            <a:scrgbClr r="0" g="0" b="0"/>
+          </a:fillRef>
+          <a:effectRef idx="0">
+            <a:scrgbClr r="0" g="0" b="0"/>
+          </a:effectRef>
+          <a:fontRef idx="minor">
+            <a:schemeClr val="lt1"/>
+          </a:fontRef>
+        </p:style>
+        <p:txBody>
+          <a:bodyPr rtlCol="0" anchor="ctr"/>
+          <a:lstStyle/>
+          <a:p>
+            <a:pPr algn="ctr"/>
+            <a:endParaRPr lang="en-US"/>
+          </a:p>
+        </p:txBody>
+      </p:sp>
+      <p:sp>
+        <p:nvSpPr>
+          <p:cNvPr id="27" name="TextBox 26">
+            <a:extLst>
+              <a:ext uri="{FF2B5EF4-FFF2-40B4-BE49-F238E27FC236}">
+                <a16:creationId xmlns:a16="http://schemas.microsoft.com/office/drawing/2014/main" id="{6FF9BA95-E0C2-5985-7DB3-B6F3667D8A22}"/>
+              </a:ext>
+            </a:extLst>
+          </p:cNvPr>
+          <p:cNvSpPr txBox="1"/>
+          <p:nvPr/>
+        </p:nvSpPr>
+        <p:spPr>
+          <a:xfrm>
+            <a:off x="0" y="6334780"/>
+            <a:ext cx="8010144" cy="523220"/>
+          </a:xfrm>
+          <a:prstGeom prst="rect">
+            <a:avLst/>
+          </a:prstGeom>
+          <a:noFill/>
+        </p:spPr>
+        <p:txBody>
+          <a:bodyPr wrap="square" rtlCol="0">
+            <a:spAutoFit/>
+          </a:bodyPr>
+          <a:lstStyle/>
+          <a:p>
+            <a:r>
+              <a:rPr lang="en-US" sz="1400" dirty="0">
+                <a:latin typeface="Calibri" panose="020F0502020204030204" pitchFamily="34" charset="0"/>
+                <a:ea typeface="Calibri" panose="020F0502020204030204" pitchFamily="34" charset="0"/>
+                <a:cs typeface="Calibri" panose="020F0502020204030204" pitchFamily="34" charset="0"/>
+              </a:rPr>
+              <a:t>Project Repository:</a:t>
+            </a:r>
+          </a:p>
+          <a:p>
+            <a:r>
+              <a:rPr lang="en-US" sz="1400" dirty="0">
+                <a:latin typeface="Calibri" panose="020F0502020204030204" pitchFamily="34" charset="0"/>
+                <a:ea typeface="Calibri" panose="020F0502020204030204" pitchFamily="34" charset="0"/>
+                <a:cs typeface="Calibri" panose="020F0502020204030204" pitchFamily="34" charset="0"/>
+                <a:hlinkClick r:id="rId2"/>
+              </a:rPr>
+              <a:t>https://github.com/Pallabi5200/Civil_Engineering_Data_Science_Project</a:t>
+            </a:r>
+            <a:endParaRPr lang="en-US" sz="1400" dirty="0">
+              <a:latin typeface="Calibri" panose="020F0502020204030204" pitchFamily="34" charset="0"/>
+              <a:ea typeface="Calibri" panose="020F0502020204030204" pitchFamily="34" charset="0"/>
+              <a:cs typeface="Calibri" panose="020F0502020204030204" pitchFamily="34" charset="0"/>
+            </a:endParaRPr>
+          </a:p>
+        </p:txBody>
+      </p:sp>
+      <p:sp>
+        <p:nvSpPr>
+          <p:cNvPr id="29" name="TextBox 28">
+            <a:extLst>
+              <a:ext uri="{FF2B5EF4-FFF2-40B4-BE49-F238E27FC236}">
+                <a16:creationId xmlns:a16="http://schemas.microsoft.com/office/drawing/2014/main" id="{EE752B0A-C075-BFA8-ACB2-8009656C1BBE}"/>
+              </a:ext>
+            </a:extLst>
+          </p:cNvPr>
+          <p:cNvSpPr txBox="1"/>
+          <p:nvPr/>
+        </p:nvSpPr>
+        <p:spPr>
+          <a:xfrm>
+            <a:off x="6236208" y="1058485"/>
+            <a:ext cx="5095109" cy="338554"/>
+          </a:xfrm>
+          <a:prstGeom prst="rect">
+            <a:avLst/>
+          </a:prstGeom>
+          <a:noFill/>
+        </p:spPr>
+        <p:txBody>
+          <a:bodyPr wrap="square" rtlCol="0">
+            <a:spAutoFit/>
+          </a:bodyPr>
+          <a:lstStyle/>
+          <a:p>
+            <a:pPr algn="ctr"/>
+            <a:r>
+              <a:rPr lang="en-US" sz="1600" b="1" u="sng" dirty="0">
+                <a:latin typeface="Calibri" panose="020F0502020204030204" pitchFamily="34" charset="0"/>
+                <a:ea typeface="Calibri" panose="020F0502020204030204" pitchFamily="34" charset="0"/>
+                <a:cs typeface="Calibri" panose="020F0502020204030204" pitchFamily="34" charset="0"/>
+              </a:rPr>
+              <a:t>Quantified Commercial ROI &amp; Business Impact</a:t>
+            </a:r>
+            <a:endParaRPr lang="en-US" sz="1600" u="sng" dirty="0">
+              <a:latin typeface="Calibri" panose="020F0502020204030204" pitchFamily="34" charset="0"/>
+              <a:ea typeface="Calibri" panose="020F0502020204030204" pitchFamily="34" charset="0"/>
+              <a:cs typeface="Calibri" panose="020F0502020204030204" pitchFamily="34" charset="0"/>
+            </a:endParaRPr>
+          </a:p>
+        </p:txBody>
+      </p:sp>
+      <p:sp>
+        <p:nvSpPr>
+          <p:cNvPr id="31" name="TextBox 30">
+            <a:extLst>
+              <a:ext uri="{FF2B5EF4-FFF2-40B4-BE49-F238E27FC236}">
+                <a16:creationId xmlns:a16="http://schemas.microsoft.com/office/drawing/2014/main" id="{E37EFD1C-1F75-9339-5FC4-7A62D6B2ECF1}"/>
+              </a:ext>
+            </a:extLst>
+          </p:cNvPr>
+          <p:cNvSpPr txBox="1"/>
+          <p:nvPr/>
+        </p:nvSpPr>
+        <p:spPr>
+          <a:xfrm>
+            <a:off x="6245077" y="3754126"/>
+            <a:ext cx="5095109" cy="338554"/>
+          </a:xfrm>
+          <a:prstGeom prst="rect">
+            <a:avLst/>
+          </a:prstGeom>
+          <a:noFill/>
+        </p:spPr>
+        <p:txBody>
+          <a:bodyPr wrap="square" rtlCol="0">
+            <a:spAutoFit/>
+          </a:bodyPr>
+          <a:lstStyle/>
+          <a:p>
+            <a:pPr algn="ctr"/>
+            <a:r>
+              <a:rPr lang="en-US" sz="1600" b="1" u="sng" dirty="0">
+                <a:latin typeface="Calibri" panose="020F0502020204030204" pitchFamily="34" charset="0"/>
+                <a:ea typeface="Calibri" panose="020F0502020204030204" pitchFamily="34" charset="0"/>
+                <a:cs typeface="Calibri" panose="020F0502020204030204" pitchFamily="34" charset="0"/>
+              </a:rPr>
+              <a:t>Technical Future Roadmap</a:t>
+            </a:r>
+            <a:endParaRPr lang="en-US" sz="1600" u="sng" dirty="0">
+              <a:latin typeface="Calibri" panose="020F0502020204030204" pitchFamily="34" charset="0"/>
+              <a:ea typeface="Calibri" panose="020F0502020204030204" pitchFamily="34" charset="0"/>
+              <a:cs typeface="Calibri" panose="020F0502020204030204" pitchFamily="34" charset="0"/>
+            </a:endParaRPr>
+          </a:p>
+        </p:txBody>
+      </p:sp>
+      <p:sp>
+        <p:nvSpPr>
+          <p:cNvPr id="33" name="TextBox 32">
+            <a:extLst>
+              <a:ext uri="{FF2B5EF4-FFF2-40B4-BE49-F238E27FC236}">
+                <a16:creationId xmlns:a16="http://schemas.microsoft.com/office/drawing/2014/main" id="{C6F64429-8578-ED2A-E23E-D81A0C0491DF}"/>
+              </a:ext>
+            </a:extLst>
+          </p:cNvPr>
+          <p:cNvSpPr txBox="1"/>
+          <p:nvPr/>
+        </p:nvSpPr>
+        <p:spPr>
+          <a:xfrm>
+            <a:off x="5956468" y="1532485"/>
+            <a:ext cx="5586984" cy="1569660"/>
+          </a:xfrm>
+          <a:prstGeom prst="rect">
+            <a:avLst/>
+          </a:prstGeom>
+          <a:noFill/>
+        </p:spPr>
+        <p:txBody>
+          <a:bodyPr wrap="square" rtlCol="0">
+            <a:spAutoFit/>
+          </a:bodyPr>
+          <a:lstStyle/>
+          <a:p>
+            <a:pPr marL="228600" lvl="0" indent="-228600">
+              <a:buFont typeface="+mj-lt"/>
+              <a:buAutoNum type="arabicPeriod"/>
+            </a:pPr>
+            <a:r>
+              <a:rPr lang="en-US" sz="1200" b="1" u="sng" dirty="0">
+                <a:latin typeface="Calibri" panose="020F0502020204030204" pitchFamily="34" charset="0"/>
+                <a:ea typeface="Calibri" panose="020F0502020204030204" pitchFamily="34" charset="0"/>
+                <a:cs typeface="Calibri" panose="020F0502020204030204" pitchFamily="34" charset="0"/>
+              </a:rPr>
+              <a:t>Retention Cash Flow Acceleration</a:t>
+            </a:r>
+            <a:r>
+              <a:rPr lang="en-US" sz="1200" i="1" dirty="0">
+                <a:latin typeface="Calibri" panose="020F0502020204030204" pitchFamily="34" charset="0"/>
+                <a:ea typeface="Calibri" panose="020F0502020204030204" pitchFamily="34" charset="0"/>
+                <a:cs typeface="Calibri" panose="020F0502020204030204" pitchFamily="34" charset="0"/>
+              </a:rPr>
+              <a:t>: Unlocks 5%-10% client retention payment funds 21 to 28 days faster using early non-destructive UPV strength verification.</a:t>
+            </a:r>
+          </a:p>
+          <a:p>
+            <a:pPr marL="228600" lvl="0" indent="-228600">
+              <a:buFont typeface="+mj-lt"/>
+              <a:buAutoNum type="arabicPeriod"/>
+            </a:pPr>
+            <a:endParaRPr lang="en-US" sz="1200" i="1" dirty="0">
+              <a:latin typeface="Calibri" panose="020F0502020204030204" pitchFamily="34" charset="0"/>
+              <a:ea typeface="Calibri" panose="020F0502020204030204" pitchFamily="34" charset="0"/>
+              <a:cs typeface="Calibri" panose="020F0502020204030204" pitchFamily="34" charset="0"/>
+            </a:endParaRPr>
+          </a:p>
+          <a:p>
+            <a:pPr marL="228600" lvl="0" indent="-228600">
+              <a:buFont typeface="+mj-lt"/>
+              <a:buAutoNum type="arabicPeriod"/>
+            </a:pPr>
+            <a:r>
+              <a:rPr lang="en-US" sz="1200" b="1" u="sng" dirty="0">
+                <a:latin typeface="Calibri" panose="020F0502020204030204" pitchFamily="34" charset="0"/>
+                <a:ea typeface="Calibri" panose="020F0502020204030204" pitchFamily="34" charset="0"/>
+                <a:cs typeface="Calibri" panose="020F0502020204030204" pitchFamily="34" charset="0"/>
+              </a:rPr>
+              <a:t>100% Subcontractor Overrun Protection</a:t>
+            </a:r>
+            <a:r>
+              <a:rPr lang="en-US" sz="1200" i="1" dirty="0">
+                <a:latin typeface="Calibri" panose="020F0502020204030204" pitchFamily="34" charset="0"/>
+                <a:ea typeface="Calibri" panose="020F0502020204030204" pitchFamily="34" charset="0"/>
+                <a:cs typeface="Calibri" panose="020F0502020204030204" pitchFamily="34" charset="0"/>
+              </a:rPr>
+              <a:t>: Automated SQL CTE risk alerts flag vendor orders at 80%+ budget caps, protecting contractor profit margins.</a:t>
+            </a:r>
+          </a:p>
+          <a:p>
+            <a:pPr marL="228600" lvl="0" indent="-228600">
+              <a:buFont typeface="+mj-lt"/>
+              <a:buAutoNum type="arabicPeriod"/>
+            </a:pPr>
+            <a:endParaRPr lang="en-US" sz="1200" i="1" dirty="0">
+              <a:latin typeface="Calibri" panose="020F0502020204030204" pitchFamily="34" charset="0"/>
+              <a:ea typeface="Calibri" panose="020F0502020204030204" pitchFamily="34" charset="0"/>
+              <a:cs typeface="Calibri" panose="020F0502020204030204" pitchFamily="34" charset="0"/>
+            </a:endParaRPr>
+          </a:p>
+          <a:p>
+            <a:pPr marL="228600" lvl="0" indent="-228600">
+              <a:buFont typeface="+mj-lt"/>
+              <a:buAutoNum type="arabicPeriod"/>
+            </a:pPr>
+            <a:r>
+              <a:rPr lang="en-US" sz="1200" b="1" u="sng" dirty="0">
+                <a:latin typeface="Calibri" panose="020F0502020204030204" pitchFamily="34" charset="0"/>
+                <a:ea typeface="Calibri" panose="020F0502020204030204" pitchFamily="34" charset="0"/>
+                <a:cs typeface="Calibri" panose="020F0502020204030204" pitchFamily="34" charset="0"/>
+              </a:rPr>
+              <a:t>100% Quality Accuracy</a:t>
+            </a:r>
+            <a:r>
+              <a:rPr lang="en-US" sz="1200" i="1" dirty="0">
+                <a:latin typeface="Calibri" panose="020F0502020204030204" pitchFamily="34" charset="0"/>
+                <a:ea typeface="Calibri" panose="020F0502020204030204" pitchFamily="34" charset="0"/>
+                <a:cs typeface="Calibri" panose="020F0502020204030204" pitchFamily="34" charset="0"/>
+              </a:rPr>
+              <a:t>: Achieved 100% predictive compliance accuracy across wind turbine foundations, epoxy grouting, and industrial storage sheds.</a:t>
+            </a:r>
+            <a:endParaRPr lang="en-US" sz="1400" i="1" dirty="0">
+              <a:latin typeface="Calibri" panose="020F0502020204030204" pitchFamily="34" charset="0"/>
+              <a:ea typeface="Calibri" panose="020F0502020204030204" pitchFamily="34" charset="0"/>
+              <a:cs typeface="Calibri" panose="020F0502020204030204" pitchFamily="34" charset="0"/>
+            </a:endParaRPr>
+          </a:p>
+        </p:txBody>
+      </p:sp>
+      <p:sp>
+        <p:nvSpPr>
+          <p:cNvPr id="35" name="TextBox 34">
+            <a:extLst>
+              <a:ext uri="{FF2B5EF4-FFF2-40B4-BE49-F238E27FC236}">
+                <a16:creationId xmlns:a16="http://schemas.microsoft.com/office/drawing/2014/main" id="{1368C5DB-877D-C94E-57E2-C811C0D81332}"/>
+              </a:ext>
+            </a:extLst>
+          </p:cNvPr>
+          <p:cNvSpPr txBox="1"/>
+          <p:nvPr/>
+        </p:nvSpPr>
+        <p:spPr>
+          <a:xfrm>
+            <a:off x="5951048" y="4215466"/>
+            <a:ext cx="5586984" cy="1015663"/>
+          </a:xfrm>
+          <a:prstGeom prst="rect">
+            <a:avLst/>
+          </a:prstGeom>
+          <a:noFill/>
+        </p:spPr>
+        <p:txBody>
+          <a:bodyPr wrap="square" rtlCol="0">
+            <a:spAutoFit/>
+          </a:bodyPr>
+          <a:lstStyle/>
+          <a:p>
+            <a:pPr marL="228600" lvl="0" indent="-228600">
+              <a:buFont typeface="+mj-lt"/>
+              <a:buAutoNum type="arabicPeriod"/>
+            </a:pPr>
+            <a:r>
+              <a:rPr lang="en-US" sz="1200" b="1" u="sng" dirty="0">
+                <a:latin typeface="Calibri" panose="020F0502020204030204" pitchFamily="34" charset="0"/>
+                <a:ea typeface="Calibri" panose="020F0502020204030204" pitchFamily="34" charset="0"/>
+                <a:cs typeface="Calibri" panose="020F0502020204030204" pitchFamily="34" charset="0"/>
+              </a:rPr>
+              <a:t>Embedded IoT Acoustic Sensors</a:t>
+            </a:r>
+            <a:r>
+              <a:rPr lang="en-US" sz="1200" i="1" dirty="0">
+                <a:latin typeface="Calibri" panose="020F0502020204030204" pitchFamily="34" charset="0"/>
+                <a:ea typeface="Calibri" panose="020F0502020204030204" pitchFamily="34" charset="0"/>
+                <a:cs typeface="Calibri" panose="020F0502020204030204" pitchFamily="34" charset="0"/>
+              </a:rPr>
+              <a:t>: Plans for real-time sensors inside concrete pours to stream live acoustic velocity data directly to the database.</a:t>
+            </a:r>
+          </a:p>
+          <a:p>
+            <a:pPr marL="228600" lvl="0" indent="-228600">
+              <a:buFont typeface="+mj-lt"/>
+              <a:buAutoNum type="arabicPeriod"/>
+            </a:pPr>
+            <a:endParaRPr lang="en-US" sz="1200" i="1" dirty="0">
+              <a:latin typeface="Calibri" panose="020F0502020204030204" pitchFamily="34" charset="0"/>
+              <a:ea typeface="Calibri" panose="020F0502020204030204" pitchFamily="34" charset="0"/>
+              <a:cs typeface="Calibri" panose="020F0502020204030204" pitchFamily="34" charset="0"/>
+            </a:endParaRPr>
+          </a:p>
+          <a:p>
+            <a:pPr marL="228600" lvl="0" indent="-228600">
+              <a:buFont typeface="+mj-lt"/>
+              <a:buAutoNum type="arabicPeriod"/>
+            </a:pPr>
+            <a:r>
+              <a:rPr lang="en-US" sz="1200" b="1" u="sng" dirty="0">
+                <a:latin typeface="Calibri" panose="020F0502020204030204" pitchFamily="34" charset="0"/>
+                <a:ea typeface="Calibri" panose="020F0502020204030204" pitchFamily="34" charset="0"/>
+                <a:cs typeface="Calibri" panose="020F0502020204030204" pitchFamily="34" charset="0"/>
+              </a:rPr>
+              <a:t>Drone Photogrammetry Integration: </a:t>
+            </a:r>
+            <a:r>
+              <a:rPr lang="en-US" sz="1200" i="1" dirty="0">
+                <a:latin typeface="Calibri" panose="020F0502020204030204" pitchFamily="34" charset="0"/>
+                <a:ea typeface="Calibri" panose="020F0502020204030204" pitchFamily="34" charset="0"/>
+                <a:cs typeface="Calibri" panose="020F0502020204030204" pitchFamily="34" charset="0"/>
+              </a:rPr>
+              <a:t>Aerial crack detection and automated surface defect measurements integrated with multi-class damage triage models.</a:t>
+            </a:r>
+            <a:endParaRPr lang="en-US" sz="1400" i="1" dirty="0">
+              <a:latin typeface="Calibri" panose="020F0502020204030204" pitchFamily="34" charset="0"/>
+              <a:ea typeface="Calibri" panose="020F0502020204030204" pitchFamily="34" charset="0"/>
+              <a:cs typeface="Calibri" panose="020F0502020204030204" pitchFamily="34" charset="0"/>
+            </a:endParaRPr>
+          </a:p>
+        </p:txBody>
+      </p:sp>
+    </p:spTree>
+    <p:extLst>
+      <p:ext uri="{BB962C8B-B14F-4D97-AF65-F5344CB8AC3E}">
+        <p14:creationId xmlns:p14="http://schemas.microsoft.com/office/powerpoint/2010/main" val="3944819669"/>
+      </p:ext>
+    </p:extLst>
+  </p:cSld>
+  <p:clrMapOvr>
+    <a:masterClrMapping/>
+  </p:clrMapOvr>
+</p:sld>
+</file>
+
 <file path=ppt/slides/slide2.xml><?xml version="1.0" encoding="utf-8"?>
 <p:sld xmlns:a="http://schemas.openxmlformats.org/drawingml/2006/main" xmlns:r="http://schemas.openxmlformats.org/officeDocument/2006/relationships" xmlns:p="http://schemas.openxmlformats.org/presentationml/2006/main">
   <p:cSld>
@@ -15173,7 +16901,7 @@
                 <a:ea typeface="Calibri" panose="020F0502020204030204" pitchFamily="34" charset="0"/>
                 <a:cs typeface="Calibri" panose="020F0502020204030204" pitchFamily="34" charset="0"/>
               </a:rPr>
-              <a:t>SQL Commercial Engine – Progressive Billing &amp; Cash Flow</a:t>
+              <a:t>SQL Commercial Engine: Progressive Billing &amp; Cash Flow</a:t>
             </a:r>
           </a:p>
         </p:txBody>
@@ -15192,7 +16920,7 @@
         </p:nvSpPr>
         <p:spPr>
           <a:xfrm>
-            <a:off x="6693408" y="6161892"/>
+            <a:off x="0" y="6334780"/>
             <a:ext cx="8010144" cy="523220"/>
           </a:xfrm>
           <a:prstGeom prst="rect">
@@ -15226,6 +16954,606 @@
               <a:t>https://github.com/Pallabi5200/Civil_Engineering_Data_Science_Project</a:t>
             </a:r>
             <a:endParaRPr lang="en-US" sz="1400" dirty="0">
+              <a:latin typeface="Calibri" panose="020F0502020204030204" pitchFamily="34" charset="0"/>
+              <a:ea typeface="Calibri" panose="020F0502020204030204" pitchFamily="34" charset="0"/>
+              <a:cs typeface="Calibri" panose="020F0502020204030204" pitchFamily="34" charset="0"/>
+            </a:endParaRPr>
+          </a:p>
+        </p:txBody>
+      </p:sp>
+      <p:pic>
+        <p:nvPicPr>
+          <p:cNvPr id="4" name="Picture 3">
+            <a:extLst>
+              <a:ext uri="{FF2B5EF4-FFF2-40B4-BE49-F238E27FC236}">
+                <a16:creationId xmlns:a16="http://schemas.microsoft.com/office/drawing/2014/main" id="{B3F85E40-3F72-D4C1-D73A-A409FCC0E43C}"/>
+              </a:ext>
+            </a:extLst>
+          </p:cNvPr>
+          <p:cNvPicPr>
+            <a:picLocks noChangeAspect="1"/>
+          </p:cNvPicPr>
+          <p:nvPr/>
+        </p:nvPicPr>
+        <p:blipFill>
+          <a:blip r:embed="rId3">
+            <a:extLst>
+              <a:ext uri="{28A0092B-C50C-407E-A947-70E740481C1C}">
+                <a14:useLocalDpi xmlns:a14="http://schemas.microsoft.com/office/drawing/2010/main" val="0"/>
+              </a:ext>
+            </a:extLst>
+          </a:blip>
+          <a:stretch>
+            <a:fillRect/>
+          </a:stretch>
+        </p:blipFill>
+        <p:spPr>
+          <a:xfrm>
+            <a:off x="131975" y="893637"/>
+            <a:ext cx="6108569" cy="4008301"/>
+          </a:xfrm>
+          <a:prstGeom prst="rect">
+            <a:avLst/>
+          </a:prstGeom>
+        </p:spPr>
+      </p:pic>
+      <p:sp>
+        <p:nvSpPr>
+          <p:cNvPr id="6" name="Rectangle: Rounded Corners 5">
+            <a:extLst>
+              <a:ext uri="{FF2B5EF4-FFF2-40B4-BE49-F238E27FC236}">
+                <a16:creationId xmlns:a16="http://schemas.microsoft.com/office/drawing/2014/main" id="{32B86EBF-E7F9-F22A-A470-CB206121B77B}"/>
+              </a:ext>
+            </a:extLst>
+          </p:cNvPr>
+          <p:cNvSpPr/>
+          <p:nvPr/>
+        </p:nvSpPr>
+        <p:spPr>
+          <a:xfrm>
+            <a:off x="6354169" y="826731"/>
+            <a:ext cx="5705856" cy="2868576"/>
+          </a:xfrm>
+          <a:prstGeom prst="roundRect">
+            <a:avLst/>
+          </a:prstGeom>
+        </p:spPr>
+        <p:style>
+          <a:lnRef idx="0">
+            <a:schemeClr val="accent2"/>
+          </a:lnRef>
+          <a:fillRef idx="3">
+            <a:schemeClr val="accent2"/>
+          </a:fillRef>
+          <a:effectRef idx="3">
+            <a:schemeClr val="accent2"/>
+          </a:effectRef>
+          <a:fontRef idx="minor">
+            <a:schemeClr val="lt1"/>
+          </a:fontRef>
+        </p:style>
+        <p:txBody>
+          <a:bodyPr rtlCol="0" anchor="ctr"/>
+          <a:lstStyle/>
+          <a:p>
+            <a:pPr algn="ctr"/>
+            <a:endParaRPr lang="en-US"/>
+          </a:p>
+        </p:txBody>
+      </p:sp>
+      <p:sp>
+        <p:nvSpPr>
+          <p:cNvPr id="8" name="Rectangle: Rounded Corners 7">
+            <a:extLst>
+              <a:ext uri="{FF2B5EF4-FFF2-40B4-BE49-F238E27FC236}">
+                <a16:creationId xmlns:a16="http://schemas.microsoft.com/office/drawing/2014/main" id="{7A687E30-0ADC-6128-BB26-9E83AE0560E7}"/>
+              </a:ext>
+            </a:extLst>
+          </p:cNvPr>
+          <p:cNvSpPr/>
+          <p:nvPr/>
+        </p:nvSpPr>
+        <p:spPr>
+          <a:xfrm>
+            <a:off x="6413605" y="3881470"/>
+            <a:ext cx="5705856" cy="2714920"/>
+          </a:xfrm>
+          <a:prstGeom prst="roundRect">
+            <a:avLst/>
+          </a:prstGeom>
+        </p:spPr>
+        <p:style>
+          <a:lnRef idx="1">
+            <a:schemeClr val="accent4"/>
+          </a:lnRef>
+          <a:fillRef idx="2">
+            <a:schemeClr val="accent4"/>
+          </a:fillRef>
+          <a:effectRef idx="1">
+            <a:schemeClr val="accent4"/>
+          </a:effectRef>
+          <a:fontRef idx="minor">
+            <a:schemeClr val="dk1"/>
+          </a:fontRef>
+        </p:style>
+        <p:txBody>
+          <a:bodyPr rtlCol="0" anchor="ctr"/>
+          <a:lstStyle/>
+          <a:p>
+            <a:pPr algn="ctr"/>
+            <a:endParaRPr lang="en-US"/>
+          </a:p>
+        </p:txBody>
+      </p:sp>
+      <p:sp>
+        <p:nvSpPr>
+          <p:cNvPr id="10" name="TextBox 9">
+            <a:extLst>
+              <a:ext uri="{FF2B5EF4-FFF2-40B4-BE49-F238E27FC236}">
+                <a16:creationId xmlns:a16="http://schemas.microsoft.com/office/drawing/2014/main" id="{5D5443D3-9ADA-5045-2ED0-E3DE47A9859E}"/>
+              </a:ext>
+            </a:extLst>
+          </p:cNvPr>
+          <p:cNvSpPr txBox="1"/>
+          <p:nvPr/>
+        </p:nvSpPr>
+        <p:spPr>
+          <a:xfrm>
+            <a:off x="6975835" y="964850"/>
+            <a:ext cx="4627900" cy="338554"/>
+          </a:xfrm>
+          <a:prstGeom prst="rect">
+            <a:avLst/>
+          </a:prstGeom>
+          <a:noFill/>
+        </p:spPr>
+        <p:txBody>
+          <a:bodyPr wrap="square" rtlCol="0">
+            <a:spAutoFit/>
+          </a:bodyPr>
+          <a:lstStyle/>
+          <a:p>
+            <a:r>
+              <a:rPr lang="en-US" sz="1600" b="1" u="sng" dirty="0">
+                <a:latin typeface="Calibri" panose="020F0502020204030204" pitchFamily="34" charset="0"/>
+                <a:ea typeface="Calibri" panose="020F0502020204030204" pitchFamily="34" charset="0"/>
+                <a:cs typeface="Calibri" panose="020F0502020204030204" pitchFamily="34" charset="0"/>
+              </a:rPr>
+              <a:t>Running Balance Window Function (SUM() OVER)</a:t>
+            </a:r>
+            <a:endParaRPr lang="en-US" sz="1600" u="sng" dirty="0">
+              <a:latin typeface="Calibri" panose="020F0502020204030204" pitchFamily="34" charset="0"/>
+              <a:ea typeface="Calibri" panose="020F0502020204030204" pitchFamily="34" charset="0"/>
+              <a:cs typeface="Calibri" panose="020F0502020204030204" pitchFamily="34" charset="0"/>
+            </a:endParaRPr>
+          </a:p>
+        </p:txBody>
+      </p:sp>
+      <p:sp>
+        <p:nvSpPr>
+          <p:cNvPr id="14" name="TextBox 13">
+            <a:extLst>
+              <a:ext uri="{FF2B5EF4-FFF2-40B4-BE49-F238E27FC236}">
+                <a16:creationId xmlns:a16="http://schemas.microsoft.com/office/drawing/2014/main" id="{F126F4F7-03CF-0A58-C9C2-28AA28838034}"/>
+              </a:ext>
+            </a:extLst>
+          </p:cNvPr>
+          <p:cNvSpPr txBox="1"/>
+          <p:nvPr/>
+        </p:nvSpPr>
+        <p:spPr>
+          <a:xfrm>
+            <a:off x="7575849" y="3995307"/>
+            <a:ext cx="3593591" cy="338554"/>
+          </a:xfrm>
+          <a:prstGeom prst="rect">
+            <a:avLst/>
+          </a:prstGeom>
+          <a:noFill/>
+        </p:spPr>
+        <p:txBody>
+          <a:bodyPr wrap="square" rtlCol="0">
+            <a:spAutoFit/>
+          </a:bodyPr>
+          <a:lstStyle/>
+          <a:p>
+            <a:r>
+              <a:rPr lang="en-US" sz="1600" b="1" u="sng" dirty="0">
+                <a:latin typeface="Calibri" panose="020F0502020204030204" pitchFamily="34" charset="0"/>
+                <a:ea typeface="Calibri" panose="020F0502020204030204" pitchFamily="34" charset="0"/>
+                <a:cs typeface="Calibri" panose="020F0502020204030204" pitchFamily="34" charset="0"/>
+              </a:rPr>
+              <a:t>Chronological Billing Findings</a:t>
+            </a:r>
+            <a:endParaRPr lang="en-US" sz="1600" u="sng" dirty="0">
+              <a:latin typeface="Calibri" panose="020F0502020204030204" pitchFamily="34" charset="0"/>
+              <a:ea typeface="Calibri" panose="020F0502020204030204" pitchFamily="34" charset="0"/>
+              <a:cs typeface="Calibri" panose="020F0502020204030204" pitchFamily="34" charset="0"/>
+            </a:endParaRPr>
+          </a:p>
+        </p:txBody>
+      </p:sp>
+      <p:sp>
+        <p:nvSpPr>
+          <p:cNvPr id="17" name="TextBox 16">
+            <a:extLst>
+              <a:ext uri="{FF2B5EF4-FFF2-40B4-BE49-F238E27FC236}">
+                <a16:creationId xmlns:a16="http://schemas.microsoft.com/office/drawing/2014/main" id="{7C805701-912F-BF32-05EA-930944A47DBB}"/>
+              </a:ext>
+            </a:extLst>
+          </p:cNvPr>
+          <p:cNvSpPr txBox="1"/>
+          <p:nvPr/>
+        </p:nvSpPr>
+        <p:spPr>
+          <a:xfrm>
+            <a:off x="6473041" y="1589162"/>
+            <a:ext cx="5586984" cy="1754326"/>
+          </a:xfrm>
+          <a:prstGeom prst="rect">
+            <a:avLst/>
+          </a:prstGeom>
+          <a:noFill/>
+        </p:spPr>
+        <p:txBody>
+          <a:bodyPr wrap="square" rtlCol="0">
+            <a:spAutoFit/>
+          </a:bodyPr>
+          <a:lstStyle/>
+          <a:p>
+            <a:pPr marL="228600" lvl="0" indent="-228600">
+              <a:buFont typeface="+mj-lt"/>
+              <a:buAutoNum type="arabicPeriod"/>
+            </a:pPr>
+            <a:r>
+              <a:rPr lang="en-US" sz="1200" b="1" u="sng" dirty="0">
+                <a:latin typeface="Calibri" panose="020F0502020204030204" pitchFamily="34" charset="0"/>
+                <a:ea typeface="Calibri" panose="020F0502020204030204" pitchFamily="34" charset="0"/>
+                <a:cs typeface="Calibri" panose="020F0502020204030204" pitchFamily="34" charset="0"/>
+              </a:rPr>
+              <a:t>Passbook Query Logic</a:t>
+            </a:r>
+            <a:r>
+              <a:rPr lang="en-US" sz="1200" i="1" dirty="0">
+                <a:latin typeface="Calibri" panose="020F0502020204030204" pitchFamily="34" charset="0"/>
+                <a:ea typeface="Calibri" panose="020F0502020204030204" pitchFamily="34" charset="0"/>
+                <a:cs typeface="Calibri" panose="020F0502020204030204" pitchFamily="34" charset="0"/>
+              </a:rPr>
+              <a:t>: Wrote a running balance window function </a:t>
+            </a:r>
+            <a:r>
+              <a:rPr lang="en-US" sz="1200" b="1" i="1" dirty="0">
+                <a:latin typeface="Calibri" panose="020F0502020204030204" pitchFamily="34" charset="0"/>
+                <a:ea typeface="Calibri" panose="020F0502020204030204" pitchFamily="34" charset="0"/>
+                <a:cs typeface="Calibri" panose="020F0502020204030204" pitchFamily="34" charset="0"/>
+              </a:rPr>
+              <a:t>(SUM(</a:t>
+            </a:r>
+            <a:r>
+              <a:rPr lang="en-US" sz="1200" b="1" i="1" dirty="0" err="1">
+                <a:latin typeface="Calibri" panose="020F0502020204030204" pitchFamily="34" charset="0"/>
+                <a:ea typeface="Calibri" panose="020F0502020204030204" pitchFamily="34" charset="0"/>
+                <a:cs typeface="Calibri" panose="020F0502020204030204" pitchFamily="34" charset="0"/>
+              </a:rPr>
+              <a:t>net_payable_amount</a:t>
+            </a:r>
+            <a:r>
+              <a:rPr lang="en-US" sz="1200" b="1" i="1" dirty="0">
+                <a:latin typeface="Calibri" panose="020F0502020204030204" pitchFamily="34" charset="0"/>
+                <a:ea typeface="Calibri" panose="020F0502020204030204" pitchFamily="34" charset="0"/>
+                <a:cs typeface="Calibri" panose="020F0502020204030204" pitchFamily="34" charset="0"/>
+              </a:rPr>
+              <a:t>) OVER (PARTITION BY </a:t>
+            </a:r>
+            <a:r>
+              <a:rPr lang="en-US" sz="1200" b="1" i="1" dirty="0" err="1">
+                <a:latin typeface="Calibri" panose="020F0502020204030204" pitchFamily="34" charset="0"/>
+                <a:ea typeface="Calibri" panose="020F0502020204030204" pitchFamily="34" charset="0"/>
+                <a:cs typeface="Calibri" panose="020F0502020204030204" pitchFamily="34" charset="0"/>
+              </a:rPr>
+              <a:t>project_name</a:t>
+            </a:r>
+            <a:r>
+              <a:rPr lang="en-US" sz="1200" b="1" i="1" dirty="0">
+                <a:latin typeface="Calibri" panose="020F0502020204030204" pitchFamily="34" charset="0"/>
+                <a:ea typeface="Calibri" panose="020F0502020204030204" pitchFamily="34" charset="0"/>
+                <a:cs typeface="Calibri" panose="020F0502020204030204" pitchFamily="34" charset="0"/>
+              </a:rPr>
+              <a:t> ORDER BY </a:t>
+            </a:r>
+            <a:r>
+              <a:rPr lang="en-US" sz="1200" b="1" i="1" dirty="0" err="1">
+                <a:latin typeface="Calibri" panose="020F0502020204030204" pitchFamily="34" charset="0"/>
+                <a:ea typeface="Calibri" panose="020F0502020204030204" pitchFamily="34" charset="0"/>
+                <a:cs typeface="Calibri" panose="020F0502020204030204" pitchFamily="34" charset="0"/>
+              </a:rPr>
+              <a:t>invoice_date</a:t>
+            </a:r>
+            <a:r>
+              <a:rPr lang="en-US" sz="1200" b="1" i="1" dirty="0">
+                <a:latin typeface="Calibri" panose="020F0502020204030204" pitchFamily="34" charset="0"/>
+                <a:ea typeface="Calibri" panose="020F0502020204030204" pitchFamily="34" charset="0"/>
+                <a:cs typeface="Calibri" panose="020F0502020204030204" pitchFamily="34" charset="0"/>
+              </a:rPr>
+              <a:t>)).</a:t>
+            </a:r>
+          </a:p>
+          <a:p>
+            <a:pPr marL="228600" lvl="0" indent="-228600">
+              <a:buFont typeface="+mj-lt"/>
+              <a:buAutoNum type="arabicPeriod"/>
+            </a:pPr>
+            <a:endParaRPr lang="en-US" sz="1200" i="1" dirty="0">
+              <a:latin typeface="Calibri" panose="020F0502020204030204" pitchFamily="34" charset="0"/>
+              <a:ea typeface="Calibri" panose="020F0502020204030204" pitchFamily="34" charset="0"/>
+              <a:cs typeface="Calibri" panose="020F0502020204030204" pitchFamily="34" charset="0"/>
+            </a:endParaRPr>
+          </a:p>
+          <a:p>
+            <a:pPr marL="228600" lvl="0" indent="-228600">
+              <a:buFont typeface="+mj-lt"/>
+              <a:buAutoNum type="arabicPeriod"/>
+            </a:pPr>
+            <a:r>
+              <a:rPr lang="en-US" sz="1200" b="1" u="sng" dirty="0">
+                <a:latin typeface="Calibri" panose="020F0502020204030204" pitchFamily="34" charset="0"/>
+                <a:ea typeface="Calibri" panose="020F0502020204030204" pitchFamily="34" charset="0"/>
+                <a:cs typeface="Calibri" panose="020F0502020204030204" pitchFamily="34" charset="0"/>
+              </a:rPr>
+              <a:t>Granular Milestone Auditing</a:t>
+            </a:r>
+            <a:r>
+              <a:rPr lang="en-US" sz="1200" i="1" dirty="0">
+                <a:latin typeface="Calibri" panose="020F0502020204030204" pitchFamily="34" charset="0"/>
+                <a:ea typeface="Calibri" panose="020F0502020204030204" pitchFamily="34" charset="0"/>
+                <a:cs typeface="Calibri" panose="020F0502020204030204" pitchFamily="34" charset="0"/>
+              </a:rPr>
+              <a:t>: Calculates cumulative billed amounts chronologically per site without dropping individual invoice line-item records.</a:t>
+            </a:r>
+          </a:p>
+          <a:p>
+            <a:pPr marL="228600" lvl="0" indent="-228600">
+              <a:buFont typeface="+mj-lt"/>
+              <a:buAutoNum type="arabicPeriod"/>
+            </a:pPr>
+            <a:endParaRPr lang="en-US" sz="1200" i="1" dirty="0">
+              <a:latin typeface="Calibri" panose="020F0502020204030204" pitchFamily="34" charset="0"/>
+              <a:ea typeface="Calibri" panose="020F0502020204030204" pitchFamily="34" charset="0"/>
+              <a:cs typeface="Calibri" panose="020F0502020204030204" pitchFamily="34" charset="0"/>
+            </a:endParaRPr>
+          </a:p>
+          <a:p>
+            <a:pPr marL="228600" lvl="0" indent="-228600">
+              <a:buFont typeface="+mj-lt"/>
+              <a:buAutoNum type="arabicPeriod"/>
+            </a:pPr>
+            <a:r>
+              <a:rPr lang="en-US" sz="1200" b="1" u="sng" dirty="0">
+                <a:latin typeface="Calibri" panose="020F0502020204030204" pitchFamily="34" charset="0"/>
+                <a:ea typeface="Calibri" panose="020F0502020204030204" pitchFamily="34" charset="0"/>
+                <a:cs typeface="Calibri" panose="020F0502020204030204" pitchFamily="34" charset="0"/>
+              </a:rPr>
+              <a:t>Multi-Table Relational Joins</a:t>
+            </a:r>
+            <a:r>
+              <a:rPr lang="en-US" sz="1200" i="1" dirty="0">
+                <a:latin typeface="Calibri" panose="020F0502020204030204" pitchFamily="34" charset="0"/>
+                <a:ea typeface="Calibri" panose="020F0502020204030204" pitchFamily="34" charset="0"/>
+                <a:cs typeface="Calibri" panose="020F0502020204030204" pitchFamily="34" charset="0"/>
+              </a:rPr>
+              <a:t>: Joined </a:t>
+            </a:r>
+            <a:r>
+              <a:rPr lang="en-US" sz="1200" b="1" i="1" dirty="0">
+                <a:latin typeface="Calibri" panose="020F0502020204030204" pitchFamily="34" charset="0"/>
+                <a:ea typeface="Calibri" panose="020F0502020204030204" pitchFamily="34" charset="0"/>
+                <a:cs typeface="Calibri" panose="020F0502020204030204" pitchFamily="34" charset="0"/>
+              </a:rPr>
+              <a:t>Projects, </a:t>
+            </a:r>
+            <a:r>
+              <a:rPr lang="en-US" sz="1200" b="1" i="1" dirty="0" err="1">
+                <a:latin typeface="Calibri" panose="020F0502020204030204" pitchFamily="34" charset="0"/>
+                <a:ea typeface="Calibri" panose="020F0502020204030204" pitchFamily="34" charset="0"/>
+                <a:cs typeface="Calibri" panose="020F0502020204030204" pitchFamily="34" charset="0"/>
+              </a:rPr>
+              <a:t>Work_Orders</a:t>
+            </a:r>
+            <a:r>
+              <a:rPr lang="en-US" sz="1200" b="1" i="1" dirty="0">
+                <a:latin typeface="Calibri" panose="020F0502020204030204" pitchFamily="34" charset="0"/>
+                <a:ea typeface="Calibri" panose="020F0502020204030204" pitchFamily="34" charset="0"/>
+                <a:cs typeface="Calibri" panose="020F0502020204030204" pitchFamily="34" charset="0"/>
+              </a:rPr>
+              <a:t>, and </a:t>
+            </a:r>
+            <a:r>
+              <a:rPr lang="en-US" sz="1200" b="1" i="1" dirty="0" err="1">
+                <a:latin typeface="Calibri" panose="020F0502020204030204" pitchFamily="34" charset="0"/>
+                <a:ea typeface="Calibri" panose="020F0502020204030204" pitchFamily="34" charset="0"/>
+                <a:cs typeface="Calibri" panose="020F0502020204030204" pitchFamily="34" charset="0"/>
+              </a:rPr>
+              <a:t>Tax_Invoices</a:t>
+            </a:r>
+            <a:r>
+              <a:rPr lang="en-US" sz="1200" i="1" dirty="0">
+                <a:latin typeface="Calibri" panose="020F0502020204030204" pitchFamily="34" charset="0"/>
+                <a:ea typeface="Calibri" panose="020F0502020204030204" pitchFamily="34" charset="0"/>
+                <a:cs typeface="Calibri" panose="020F0502020204030204" pitchFamily="34" charset="0"/>
+              </a:rPr>
+              <a:t> using primary and foreign key relationships </a:t>
+            </a:r>
+            <a:r>
+              <a:rPr lang="en-US" sz="1200" b="1" i="1" dirty="0">
+                <a:latin typeface="Calibri" panose="020F0502020204030204" pitchFamily="34" charset="0"/>
+                <a:ea typeface="Calibri" panose="020F0502020204030204" pitchFamily="34" charset="0"/>
+                <a:cs typeface="Calibri" panose="020F0502020204030204" pitchFamily="34" charset="0"/>
+              </a:rPr>
+              <a:t>(</a:t>
+            </a:r>
+            <a:r>
+              <a:rPr lang="en-US" sz="1200" b="1" i="1" dirty="0" err="1">
+                <a:latin typeface="Calibri" panose="020F0502020204030204" pitchFamily="34" charset="0"/>
+                <a:ea typeface="Calibri" panose="020F0502020204030204" pitchFamily="34" charset="0"/>
+                <a:cs typeface="Calibri" panose="020F0502020204030204" pitchFamily="34" charset="0"/>
+              </a:rPr>
+              <a:t>project_id</a:t>
+            </a:r>
+            <a:r>
+              <a:rPr lang="en-US" sz="1200" b="1" i="1" dirty="0">
+                <a:latin typeface="Calibri" panose="020F0502020204030204" pitchFamily="34" charset="0"/>
+                <a:ea typeface="Calibri" panose="020F0502020204030204" pitchFamily="34" charset="0"/>
+                <a:cs typeface="Calibri" panose="020F0502020204030204" pitchFamily="34" charset="0"/>
+              </a:rPr>
+              <a:t>, </a:t>
+            </a:r>
+            <a:r>
+              <a:rPr lang="en-US" sz="1200" b="1" i="1" dirty="0" err="1">
+                <a:latin typeface="Calibri" panose="020F0502020204030204" pitchFamily="34" charset="0"/>
+                <a:ea typeface="Calibri" panose="020F0502020204030204" pitchFamily="34" charset="0"/>
+                <a:cs typeface="Calibri" panose="020F0502020204030204" pitchFamily="34" charset="0"/>
+              </a:rPr>
+              <a:t>work_order_id</a:t>
+            </a:r>
+            <a:r>
+              <a:rPr lang="en-US" sz="1200" b="1" i="1" dirty="0">
+                <a:latin typeface="Calibri" panose="020F0502020204030204" pitchFamily="34" charset="0"/>
+                <a:ea typeface="Calibri" panose="020F0502020204030204" pitchFamily="34" charset="0"/>
+                <a:cs typeface="Calibri" panose="020F0502020204030204" pitchFamily="34" charset="0"/>
+              </a:rPr>
+              <a:t>).</a:t>
+            </a:r>
+            <a:endParaRPr lang="en-US" sz="1400" b="1" i="1" dirty="0">
+              <a:latin typeface="Calibri" panose="020F0502020204030204" pitchFamily="34" charset="0"/>
+              <a:ea typeface="Calibri" panose="020F0502020204030204" pitchFamily="34" charset="0"/>
+              <a:cs typeface="Calibri" panose="020F0502020204030204" pitchFamily="34" charset="0"/>
+            </a:endParaRPr>
+          </a:p>
+        </p:txBody>
+      </p:sp>
+      <p:sp>
+        <p:nvSpPr>
+          <p:cNvPr id="19" name="TextBox 18">
+            <a:extLst>
+              <a:ext uri="{FF2B5EF4-FFF2-40B4-BE49-F238E27FC236}">
+                <a16:creationId xmlns:a16="http://schemas.microsoft.com/office/drawing/2014/main" id="{233CD17B-B9F0-3A2E-FE6D-11A282757B3C}"/>
+              </a:ext>
+            </a:extLst>
+          </p:cNvPr>
+          <p:cNvSpPr txBox="1"/>
+          <p:nvPr/>
+        </p:nvSpPr>
+        <p:spPr>
+          <a:xfrm>
+            <a:off x="6532462" y="4520024"/>
+            <a:ext cx="5586984" cy="1569660"/>
+          </a:xfrm>
+          <a:prstGeom prst="rect">
+            <a:avLst/>
+          </a:prstGeom>
+          <a:noFill/>
+        </p:spPr>
+        <p:txBody>
+          <a:bodyPr wrap="square" rtlCol="0">
+            <a:spAutoFit/>
+          </a:bodyPr>
+          <a:lstStyle/>
+          <a:p>
+            <a:pPr marL="228600" lvl="0" indent="-228600">
+              <a:buFont typeface="+mj-lt"/>
+              <a:buAutoNum type="arabicPeriod"/>
+            </a:pPr>
+            <a:r>
+              <a:rPr lang="en-US" sz="1200" b="1" u="sng" dirty="0">
+                <a:latin typeface="Calibri" panose="020F0502020204030204" pitchFamily="34" charset="0"/>
+                <a:ea typeface="Calibri" panose="020F0502020204030204" pitchFamily="34" charset="0"/>
+                <a:cs typeface="Calibri" panose="020F0502020204030204" pitchFamily="34" charset="0"/>
+              </a:rPr>
+              <a:t>GAL33 WTG Foundation Site</a:t>
+            </a:r>
+            <a:r>
+              <a:rPr lang="en-US" sz="1200" i="1" dirty="0">
+                <a:latin typeface="Calibri" panose="020F0502020204030204" pitchFamily="34" charset="0"/>
+                <a:ea typeface="Calibri" panose="020F0502020204030204" pitchFamily="34" charset="0"/>
+                <a:cs typeface="Calibri" panose="020F0502020204030204" pitchFamily="34" charset="0"/>
+              </a:rPr>
+              <a:t>: Cumulative milestone billing grew from ₹4.55 Lakhs in Feb 2026 to ₹13.65 Lakhs by late March 2026 across 3 milestones.</a:t>
+            </a:r>
+          </a:p>
+          <a:p>
+            <a:pPr marL="228600" lvl="0" indent="-228600">
+              <a:buFont typeface="+mj-lt"/>
+              <a:buAutoNum type="arabicPeriod"/>
+            </a:pPr>
+            <a:endParaRPr lang="en-US" sz="1200" i="1" dirty="0">
+              <a:latin typeface="Calibri" panose="020F0502020204030204" pitchFamily="34" charset="0"/>
+              <a:ea typeface="Calibri" panose="020F0502020204030204" pitchFamily="34" charset="0"/>
+              <a:cs typeface="Calibri" panose="020F0502020204030204" pitchFamily="34" charset="0"/>
+            </a:endParaRPr>
+          </a:p>
+          <a:p>
+            <a:pPr marL="228600" lvl="0" indent="-228600">
+              <a:buFont typeface="+mj-lt"/>
+              <a:buAutoNum type="arabicPeriod"/>
+            </a:pPr>
+            <a:r>
+              <a:rPr lang="en-US" sz="1200" b="1" u="sng" dirty="0" err="1">
+                <a:latin typeface="Calibri" panose="020F0502020204030204" pitchFamily="34" charset="0"/>
+                <a:ea typeface="Calibri" panose="020F0502020204030204" pitchFamily="34" charset="0"/>
+                <a:cs typeface="Calibri" panose="020F0502020204030204" pitchFamily="34" charset="0"/>
+              </a:rPr>
+              <a:t>Molagavali</a:t>
+            </a:r>
+            <a:r>
+              <a:rPr lang="en-US" sz="1200" b="1" u="sng" dirty="0">
+                <a:latin typeface="Calibri" panose="020F0502020204030204" pitchFamily="34" charset="0"/>
+                <a:ea typeface="Calibri" panose="020F0502020204030204" pitchFamily="34" charset="0"/>
+                <a:cs typeface="Calibri" panose="020F0502020204030204" pitchFamily="34" charset="0"/>
+              </a:rPr>
+              <a:t> Grouting Repair Site</a:t>
+            </a:r>
+            <a:r>
+              <a:rPr lang="en-US" sz="1200" i="1" dirty="0">
+                <a:latin typeface="Calibri" panose="020F0502020204030204" pitchFamily="34" charset="0"/>
+                <a:ea typeface="Calibri" panose="020F0502020204030204" pitchFamily="34" charset="0"/>
+                <a:cs typeface="Calibri" panose="020F0502020204030204" pitchFamily="34" charset="0"/>
+              </a:rPr>
+              <a:t>: Tracks progressive milestone payouts up to ₹5.16 Lakhs cleanly.</a:t>
+            </a:r>
+          </a:p>
+          <a:p>
+            <a:pPr marL="228600" lvl="0" indent="-228600">
+              <a:buFont typeface="+mj-lt"/>
+              <a:buAutoNum type="arabicPeriod"/>
+            </a:pPr>
+            <a:endParaRPr lang="en-US" sz="1200" i="1" dirty="0">
+              <a:latin typeface="Calibri" panose="020F0502020204030204" pitchFamily="34" charset="0"/>
+              <a:ea typeface="Calibri" panose="020F0502020204030204" pitchFamily="34" charset="0"/>
+              <a:cs typeface="Calibri" panose="020F0502020204030204" pitchFamily="34" charset="0"/>
+            </a:endParaRPr>
+          </a:p>
+          <a:p>
+            <a:pPr marL="228600" lvl="0" indent="-228600">
+              <a:buFont typeface="+mj-lt"/>
+              <a:buAutoNum type="arabicPeriod"/>
+            </a:pPr>
+            <a:r>
+              <a:rPr lang="en-US" sz="1200" b="1" u="sng" dirty="0">
+                <a:latin typeface="Calibri" panose="020F0502020204030204" pitchFamily="34" charset="0"/>
+                <a:ea typeface="Calibri" panose="020F0502020204030204" pitchFamily="34" charset="0"/>
+                <a:cs typeface="Calibri" panose="020F0502020204030204" pitchFamily="34" charset="0"/>
+              </a:rPr>
+              <a:t>Commercial Value</a:t>
+            </a:r>
+            <a:r>
+              <a:rPr lang="en-US" sz="1200" i="1" dirty="0">
+                <a:latin typeface="Calibri" panose="020F0502020204030204" pitchFamily="34" charset="0"/>
+                <a:ea typeface="Calibri" panose="020F0502020204030204" pitchFamily="34" charset="0"/>
+                <a:cs typeface="Calibri" panose="020F0502020204030204" pitchFamily="34" charset="0"/>
+              </a:rPr>
+              <a:t>: Prevents billing bottlenecks and guarantees 100% audit-ready financial transparency for client reviews.</a:t>
+            </a:r>
+            <a:endParaRPr lang="en-US" sz="1400" i="1" dirty="0">
               <a:latin typeface="Calibri" panose="020F0502020204030204" pitchFamily="34" charset="0"/>
               <a:ea typeface="Calibri" panose="020F0502020204030204" pitchFamily="34" charset="0"/>
               <a:cs typeface="Calibri" panose="020F0502020204030204" pitchFamily="34" charset="0"/>
@@ -15297,7 +17625,7 @@
                 <a:ea typeface="Calibri" panose="020F0502020204030204" pitchFamily="34" charset="0"/>
                 <a:cs typeface="Calibri" panose="020F0502020204030204" pitchFamily="34" charset="0"/>
               </a:rPr>
-              <a:t>SQL Commercial Engine: Vendor Overrun Risk &amp; Quality Audits</a:t>
+              <a:t>SQL Commercial Engine: Subcontractor Budget Overrun Risk CTE</a:t>
             </a:r>
           </a:p>
           <a:p>
@@ -15330,7 +17658,7 @@
         </p:nvSpPr>
         <p:spPr>
           <a:xfrm>
-            <a:off x="448056" y="987552"/>
+            <a:off x="5772064" y="987552"/>
             <a:ext cx="6126480" cy="2368296"/>
           </a:xfrm>
           <a:prstGeom prst="roundRect">
@@ -15375,8 +17703,8 @@
         </p:nvSpPr>
         <p:spPr>
           <a:xfrm>
-            <a:off x="448056" y="3585737"/>
-            <a:ext cx="6126480" cy="2284711"/>
+            <a:off x="5617464" y="3602822"/>
+            <a:ext cx="6126480" cy="2468040"/>
           </a:xfrm>
           <a:prstGeom prst="roundRect">
             <a:avLst/>
@@ -15427,7 +17755,7 @@
           <a:lstStyle/>
           <a:p>
             <a:pPr algn="ctr"/>
-            <a:endParaRPr lang="en-US"/>
+            <a:endParaRPr lang="en-US" dirty="0"/>
           </a:p>
         </p:txBody>
       </p:sp>
@@ -15445,7 +17773,7 @@
         </p:nvSpPr>
         <p:spPr>
           <a:xfrm>
-            <a:off x="775338" y="1162852"/>
+            <a:off x="6574536" y="1061412"/>
             <a:ext cx="5095109" cy="338554"/>
           </a:xfrm>
           <a:prstGeom prst="rect">
@@ -15465,7 +17793,7 @@
                 <a:ea typeface="Calibri" panose="020F0502020204030204" pitchFamily="34" charset="0"/>
                 <a:cs typeface="Calibri" panose="020F0502020204030204" pitchFamily="34" charset="0"/>
               </a:rPr>
-              <a:t>Subcontractor Overrun Risk CTE (WITH ... AS)</a:t>
+              <a:t>Subcontractor Commitment CTE (WITH ... AS)</a:t>
             </a:r>
             <a:endParaRPr lang="en-US" sz="1600" u="sng" dirty="0">
               <a:latin typeface="Calibri" panose="020F0502020204030204" pitchFamily="34" charset="0"/>
@@ -15477,10 +17805,10 @@
       </p:sp>
       <p:sp>
         <p:nvSpPr>
-          <p:cNvPr id="11" name="TextBox 10">
-            <a:extLst>
-              <a:ext uri="{FF2B5EF4-FFF2-40B4-BE49-F238E27FC236}">
-                <a16:creationId xmlns:a16="http://schemas.microsoft.com/office/drawing/2014/main" id="{6B30D507-A647-AE7F-42A2-DD875A91A757}"/>
+          <p:cNvPr id="13" name="TextBox 12">
+            <a:extLst>
+              <a:ext uri="{FF2B5EF4-FFF2-40B4-BE49-F238E27FC236}">
+                <a16:creationId xmlns:a16="http://schemas.microsoft.com/office/drawing/2014/main" id="{4664ECC1-FB43-3056-6889-FE23A7A3BC64}"/>
               </a:ext>
             </a:extLst>
           </p:cNvPr>
@@ -15489,7 +17817,51 @@
         </p:nvSpPr>
         <p:spPr>
           <a:xfrm>
-            <a:off x="717804" y="1587773"/>
+            <a:off x="6648835" y="3689829"/>
+            <a:ext cx="5095109" cy="338554"/>
+          </a:xfrm>
+          <a:prstGeom prst="rect">
+            <a:avLst/>
+          </a:prstGeom>
+          <a:noFill/>
+        </p:spPr>
+        <p:txBody>
+          <a:bodyPr wrap="square" rtlCol="0">
+            <a:spAutoFit/>
+          </a:bodyPr>
+          <a:lstStyle/>
+          <a:p>
+            <a:r>
+              <a:rPr lang="en-US" sz="1600" b="1" u="sng" dirty="0">
+                <a:latin typeface="Calibri" panose="020F0502020204030204" pitchFamily="34" charset="0"/>
+                <a:ea typeface="Calibri" panose="020F0502020204030204" pitchFamily="34" charset="0"/>
+                <a:cs typeface="Calibri" panose="020F0502020204030204" pitchFamily="34" charset="0"/>
+              </a:rPr>
+              <a:t>Automated Overrun Risk Flag (CASE WHEN)</a:t>
+            </a:r>
+            <a:endParaRPr lang="en-US" sz="1600" u="sng" dirty="0">
+              <a:latin typeface="Calibri" panose="020F0502020204030204" pitchFamily="34" charset="0"/>
+              <a:ea typeface="Calibri" panose="020F0502020204030204" pitchFamily="34" charset="0"/>
+              <a:cs typeface="Calibri" panose="020F0502020204030204" pitchFamily="34" charset="0"/>
+            </a:endParaRPr>
+          </a:p>
+        </p:txBody>
+      </p:sp>
+      <p:sp>
+        <p:nvSpPr>
+          <p:cNvPr id="15" name="TextBox 14">
+            <a:extLst>
+              <a:ext uri="{FF2B5EF4-FFF2-40B4-BE49-F238E27FC236}">
+                <a16:creationId xmlns:a16="http://schemas.microsoft.com/office/drawing/2014/main" id="{41F1E240-C883-F8C6-78C7-2ABA68BEEBDB}"/>
+              </a:ext>
+            </a:extLst>
+          </p:cNvPr>
+          <p:cNvSpPr txBox="1"/>
+          <p:nvPr/>
+        </p:nvSpPr>
+        <p:spPr>
+          <a:xfrm>
+            <a:off x="5887212" y="4155160"/>
             <a:ext cx="5586984" cy="1569660"/>
           </a:xfrm>
           <a:prstGeom prst="rect">
@@ -15508,20 +17880,20 @@
               <a:buAutoNum type="arabicPeriod"/>
             </a:pPr>
             <a:r>
+              <a:rPr lang="en-US" sz="1200" b="1" u="sng" dirty="0">
+                <a:latin typeface="Calibri" panose="020F0502020204030204" pitchFamily="34" charset="0"/>
+                <a:ea typeface="Calibri" panose="020F0502020204030204" pitchFamily="34" charset="0"/>
+                <a:cs typeface="Calibri" panose="020F0502020204030204" pitchFamily="34" charset="0"/>
+              </a:rPr>
+              <a:t>3-Tier Risk Logic</a:t>
+            </a:r>
+            <a:r>
               <a:rPr lang="en-US" sz="1200" i="1" dirty="0">
                 <a:latin typeface="Calibri" panose="020F0502020204030204" pitchFamily="34" charset="0"/>
                 <a:ea typeface="Calibri" panose="020F0502020204030204" pitchFamily="34" charset="0"/>
                 <a:cs typeface="Calibri" panose="020F0502020204030204" pitchFamily="34" charset="0"/>
               </a:rPr>
-              <a:t>Created a Common Table Expression to calculate </a:t>
-            </a:r>
-            <a:r>
-              <a:rPr lang="en-US" sz="1200" b="1" i="1" dirty="0">
-                <a:latin typeface="Calibri" panose="020F0502020204030204" pitchFamily="34" charset="0"/>
-                <a:ea typeface="Calibri" panose="020F0502020204030204" pitchFamily="34" charset="0"/>
-                <a:cs typeface="Calibri" panose="020F0502020204030204" pitchFamily="34" charset="0"/>
-              </a:rPr>
-              <a:t>(Total PO Value / Work Order Ceiling) * 100.</a:t>
+              <a:t>: Used CASE WHEN to set automatic alerts: HIGH (&gt;80%), MODERATE (&gt;50%), and LOW.</a:t>
             </a:r>
           </a:p>
           <a:p>
@@ -15541,44 +17913,20 @@
               <a:buAutoNum type="arabicPeriod"/>
             </a:pPr>
             <a:r>
+              <a:rPr lang="en-US" sz="1200" b="1" u="sng" dirty="0">
+                <a:latin typeface="Calibri" panose="020F0502020204030204" pitchFamily="34" charset="0"/>
+                <a:ea typeface="Calibri" panose="020F0502020204030204" pitchFamily="34" charset="0"/>
+                <a:cs typeface="Calibri" panose="020F0502020204030204" pitchFamily="34" charset="0"/>
+              </a:rPr>
+              <a:t>Audit Finding</a:t>
+            </a:r>
+            <a:r>
               <a:rPr lang="en-US" sz="1200" i="1" dirty="0">
                 <a:latin typeface="Calibri" panose="020F0502020204030204" pitchFamily="34" charset="0"/>
                 <a:ea typeface="Calibri" panose="020F0502020204030204" pitchFamily="34" charset="0"/>
                 <a:cs typeface="Calibri" panose="020F0502020204030204" pitchFamily="34" charset="0"/>
               </a:rPr>
-              <a:t>Applied </a:t>
-            </a:r>
-            <a:r>
-              <a:rPr lang="en-US" sz="1200" b="1" i="1" dirty="0">
-                <a:latin typeface="Calibri" panose="020F0502020204030204" pitchFamily="34" charset="0"/>
-                <a:ea typeface="Calibri" panose="020F0502020204030204" pitchFamily="34" charset="0"/>
-                <a:cs typeface="Calibri" panose="020F0502020204030204" pitchFamily="34" charset="0"/>
-              </a:rPr>
-              <a:t>CASE WHEN </a:t>
-            </a:r>
-            <a:r>
-              <a:rPr lang="en-US" sz="1200" i="1" dirty="0">
-                <a:latin typeface="Calibri" panose="020F0502020204030204" pitchFamily="34" charset="0"/>
-                <a:ea typeface="Calibri" panose="020F0502020204030204" pitchFamily="34" charset="0"/>
-                <a:cs typeface="Calibri" panose="020F0502020204030204" pitchFamily="34" charset="0"/>
-              </a:rPr>
-              <a:t>to trigger a </a:t>
-            </a:r>
-            <a:r>
-              <a:rPr lang="en-US" sz="1200" b="1" i="1" dirty="0">
-                <a:latin typeface="Calibri" panose="020F0502020204030204" pitchFamily="34" charset="0"/>
-                <a:ea typeface="Calibri" panose="020F0502020204030204" pitchFamily="34" charset="0"/>
-                <a:cs typeface="Calibri" panose="020F0502020204030204" pitchFamily="34" charset="0"/>
-              </a:rPr>
-              <a:t>HIGH RISK (&gt;80%) </a:t>
-            </a:r>
-            <a:r>
-              <a:rPr lang="en-US" sz="1200" i="1" dirty="0">
-                <a:latin typeface="Calibri" panose="020F0502020204030204" pitchFamily="34" charset="0"/>
-                <a:ea typeface="Calibri" panose="020F0502020204030204" pitchFamily="34" charset="0"/>
-                <a:cs typeface="Calibri" panose="020F0502020204030204" pitchFamily="34" charset="0"/>
-              </a:rPr>
-              <a:t>warning whenever subcontractor orders approach budget limits.</a:t>
+              <a:t>: Flagged HIGH RISK (100% Commitment) for retrofitting at GAL33, storage shed at Patan, and shed at Otha Ph 3.</a:t>
             </a:r>
           </a:p>
           <a:p>
@@ -15598,12 +17946,20 @@
               <a:buAutoNum type="arabicPeriod"/>
             </a:pPr>
             <a:r>
+              <a:rPr lang="en-US" sz="1200" b="1" u="sng" dirty="0">
+                <a:latin typeface="Calibri" panose="020F0502020204030204" pitchFamily="34" charset="0"/>
+                <a:ea typeface="Calibri" panose="020F0502020204030204" pitchFamily="34" charset="0"/>
+                <a:cs typeface="Calibri" panose="020F0502020204030204" pitchFamily="34" charset="0"/>
+              </a:rPr>
+              <a:t>Margin ROI: </a:t>
+            </a:r>
+            <a:r>
               <a:rPr lang="en-US" sz="1200" i="1" dirty="0">
                 <a:latin typeface="Calibri" panose="020F0502020204030204" pitchFamily="34" charset="0"/>
                 <a:ea typeface="Calibri" panose="020F0502020204030204" pitchFamily="34" charset="0"/>
                 <a:cs typeface="Calibri" panose="020F0502020204030204" pitchFamily="34" charset="0"/>
               </a:rPr>
-              <a:t>ROI: Protects contracting profit margins by stopping unbudgeted cost overruns early.</a:t>
+              <a:t>Serves as an early financial alert to protect contractor profit margins against vendor budget overruns.</a:t>
             </a:r>
             <a:endParaRPr lang="en-US" sz="1400" i="1" dirty="0">
               <a:latin typeface="Calibri" panose="020F0502020204030204" pitchFamily="34" charset="0"/>
@@ -15615,10 +17971,10 @@
       </p:sp>
       <p:sp>
         <p:nvSpPr>
-          <p:cNvPr id="13" name="TextBox 12">
-            <a:extLst>
-              <a:ext uri="{FF2B5EF4-FFF2-40B4-BE49-F238E27FC236}">
-                <a16:creationId xmlns:a16="http://schemas.microsoft.com/office/drawing/2014/main" id="{4664ECC1-FB43-3056-6889-FE23A7A3BC64}"/>
+          <p:cNvPr id="8" name="TextBox 7">
+            <a:extLst>
+              <a:ext uri="{FF2B5EF4-FFF2-40B4-BE49-F238E27FC236}">
+                <a16:creationId xmlns:a16="http://schemas.microsoft.com/office/drawing/2014/main" id="{86271ECB-23D5-494E-27A8-6CC97D66F90C}"/>
               </a:ext>
             </a:extLst>
           </p:cNvPr>
@@ -15627,8 +17983,8 @@
         </p:nvSpPr>
         <p:spPr>
           <a:xfrm>
-            <a:off x="717804" y="3757654"/>
-            <a:ext cx="5095109" cy="338554"/>
+            <a:off x="6041812" y="1490810"/>
+            <a:ext cx="5586984" cy="1569660"/>
           </a:xfrm>
           <a:prstGeom prst="rect">
             <a:avLst/>
@@ -15641,13 +17997,529 @@
           </a:bodyPr>
           <a:lstStyle/>
           <a:p>
+            <a:pPr marL="228600" lvl="0" indent="-228600">
+              <a:buFont typeface="+mj-lt"/>
+              <a:buAutoNum type="arabicPeriod"/>
+            </a:pPr>
+            <a:r>
+              <a:rPr lang="en-US" sz="1200" b="1" u="sng" dirty="0">
+                <a:latin typeface="Calibri" panose="020F0502020204030204" pitchFamily="34" charset="0"/>
+                <a:ea typeface="Calibri" panose="020F0502020204030204" pitchFamily="34" charset="0"/>
+                <a:cs typeface="Calibri" panose="020F0502020204030204" pitchFamily="34" charset="0"/>
+              </a:rPr>
+              <a:t>CTE Pre-Aggregation</a:t>
+            </a:r>
+            <a:r>
+              <a:rPr lang="en-US" sz="1200" i="1" dirty="0">
+                <a:latin typeface="Calibri" panose="020F0502020204030204" pitchFamily="34" charset="0"/>
+                <a:ea typeface="Calibri" panose="020F0502020204030204" pitchFamily="34" charset="0"/>
+                <a:cs typeface="Calibri" panose="020F0502020204030204" pitchFamily="34" charset="0"/>
+              </a:rPr>
+              <a:t>: Built WITH </a:t>
+            </a:r>
+            <a:r>
+              <a:rPr lang="en-US" sz="1200" i="1" dirty="0" err="1">
+                <a:latin typeface="Calibri" panose="020F0502020204030204" pitchFamily="34" charset="0"/>
+                <a:ea typeface="Calibri" panose="020F0502020204030204" pitchFamily="34" charset="0"/>
+                <a:cs typeface="Calibri" panose="020F0502020204030204" pitchFamily="34" charset="0"/>
+              </a:rPr>
+              <a:t>VendorCommitments</a:t>
+            </a:r>
+            <a:r>
+              <a:rPr lang="en-US" sz="1200" i="1" dirty="0">
+                <a:latin typeface="Calibri" panose="020F0502020204030204" pitchFamily="34" charset="0"/>
+                <a:ea typeface="Calibri" panose="020F0502020204030204" pitchFamily="34" charset="0"/>
+                <a:cs typeface="Calibri" panose="020F0502020204030204" pitchFamily="34" charset="0"/>
+              </a:rPr>
+              <a:t> AS (...) to sum subcontractor purchase orders (SUM(</a:t>
+            </a:r>
+            <a:r>
+              <a:rPr lang="en-US" sz="1200" i="1" dirty="0" err="1">
+                <a:latin typeface="Calibri" panose="020F0502020204030204" pitchFamily="34" charset="0"/>
+                <a:ea typeface="Calibri" panose="020F0502020204030204" pitchFamily="34" charset="0"/>
+                <a:cs typeface="Calibri" panose="020F0502020204030204" pitchFamily="34" charset="0"/>
+              </a:rPr>
+              <a:t>total_po_value</a:t>
+            </a:r>
+            <a:r>
+              <a:rPr lang="en-US" sz="1200" i="1" dirty="0">
+                <a:latin typeface="Calibri" panose="020F0502020204030204" pitchFamily="34" charset="0"/>
+                <a:ea typeface="Calibri" panose="020F0502020204030204" pitchFamily="34" charset="0"/>
+                <a:cs typeface="Calibri" panose="020F0502020204030204" pitchFamily="34" charset="0"/>
+              </a:rPr>
+              <a:t>)) per site.</a:t>
+            </a:r>
+          </a:p>
+          <a:p>
+            <a:pPr marL="228600" lvl="0" indent="-228600">
+              <a:buFont typeface="+mj-lt"/>
+              <a:buAutoNum type="arabicPeriod"/>
+            </a:pPr>
+            <a:endParaRPr lang="en-US" sz="1200" i="1" dirty="0">
+              <a:latin typeface="Calibri" panose="020F0502020204030204" pitchFamily="34" charset="0"/>
+              <a:ea typeface="Calibri" panose="020F0502020204030204" pitchFamily="34" charset="0"/>
+              <a:cs typeface="Calibri" panose="020F0502020204030204" pitchFamily="34" charset="0"/>
+            </a:endParaRPr>
+          </a:p>
+          <a:p>
+            <a:pPr marL="228600" lvl="0" indent="-228600">
+              <a:buFont typeface="+mj-lt"/>
+              <a:buAutoNum type="arabicPeriod"/>
+            </a:pPr>
+            <a:r>
+              <a:rPr lang="en-US" sz="1200" b="1" u="sng" dirty="0">
+                <a:latin typeface="Calibri" panose="020F0502020204030204" pitchFamily="34" charset="0"/>
+                <a:ea typeface="Calibri" panose="020F0502020204030204" pitchFamily="34" charset="0"/>
+                <a:cs typeface="Calibri" panose="020F0502020204030204" pitchFamily="34" charset="0"/>
+              </a:rPr>
+              <a:t>Commitment Ratio Formula</a:t>
+            </a:r>
+            <a:r>
+              <a:rPr lang="en-US" sz="1200" i="1" dirty="0">
+                <a:latin typeface="Calibri" panose="020F0502020204030204" pitchFamily="34" charset="0"/>
+                <a:ea typeface="Calibri" panose="020F0502020204030204" pitchFamily="34" charset="0"/>
+                <a:cs typeface="Calibri" panose="020F0502020204030204" pitchFamily="34" charset="0"/>
+              </a:rPr>
+              <a:t>: Calculated cost ratio (</a:t>
+            </a:r>
+            <a:r>
+              <a:rPr lang="en-US" sz="1200" i="1" dirty="0" err="1">
+                <a:latin typeface="Calibri" panose="020F0502020204030204" pitchFamily="34" charset="0"/>
+                <a:ea typeface="Calibri" panose="020F0502020204030204" pitchFamily="34" charset="0"/>
+                <a:cs typeface="Calibri" panose="020F0502020204030204" pitchFamily="34" charset="0"/>
+              </a:rPr>
+              <a:t>total_po_commitment</a:t>
+            </a:r>
+            <a:r>
+              <a:rPr lang="en-US" sz="1200" i="1" dirty="0">
+                <a:latin typeface="Calibri" panose="020F0502020204030204" pitchFamily="34" charset="0"/>
+                <a:ea typeface="Calibri" panose="020F0502020204030204" pitchFamily="34" charset="0"/>
+                <a:cs typeface="Calibri" panose="020F0502020204030204" pitchFamily="34" charset="0"/>
+              </a:rPr>
+              <a:t> * 100.0 / </a:t>
+            </a:r>
+            <a:r>
+              <a:rPr lang="en-US" sz="1200" i="1" dirty="0" err="1">
+                <a:latin typeface="Calibri" panose="020F0502020204030204" pitchFamily="34" charset="0"/>
+                <a:ea typeface="Calibri" panose="020F0502020204030204" pitchFamily="34" charset="0"/>
+                <a:cs typeface="Calibri" panose="020F0502020204030204" pitchFamily="34" charset="0"/>
+              </a:rPr>
+              <a:t>total_contract_value</a:t>
+            </a:r>
+            <a:r>
+              <a:rPr lang="en-US" sz="1200" i="1" dirty="0">
+                <a:latin typeface="Calibri" panose="020F0502020204030204" pitchFamily="34" charset="0"/>
+                <a:ea typeface="Calibri" panose="020F0502020204030204" pitchFamily="34" charset="0"/>
+                <a:cs typeface="Calibri" panose="020F0502020204030204" pitchFamily="34" charset="0"/>
+              </a:rPr>
+              <a:t>).</a:t>
+            </a:r>
+          </a:p>
+          <a:p>
+            <a:pPr marL="228600" lvl="0" indent="-228600">
+              <a:buFont typeface="+mj-lt"/>
+              <a:buAutoNum type="arabicPeriod"/>
+            </a:pPr>
+            <a:endParaRPr lang="en-US" sz="1200" i="1" dirty="0">
+              <a:latin typeface="Calibri" panose="020F0502020204030204" pitchFamily="34" charset="0"/>
+              <a:ea typeface="Calibri" panose="020F0502020204030204" pitchFamily="34" charset="0"/>
+              <a:cs typeface="Calibri" panose="020F0502020204030204" pitchFamily="34" charset="0"/>
+            </a:endParaRPr>
+          </a:p>
+          <a:p>
+            <a:pPr marL="228600" lvl="0" indent="-228600">
+              <a:buFont typeface="+mj-lt"/>
+              <a:buAutoNum type="arabicPeriod"/>
+            </a:pPr>
+            <a:r>
+              <a:rPr lang="en-US" sz="1200" b="1" u="sng" dirty="0">
+                <a:latin typeface="Calibri" panose="020F0502020204030204" pitchFamily="34" charset="0"/>
+                <a:ea typeface="Calibri" panose="020F0502020204030204" pitchFamily="34" charset="0"/>
+                <a:cs typeface="Calibri" panose="020F0502020204030204" pitchFamily="34" charset="0"/>
+              </a:rPr>
+              <a:t>Relational Joins: </a:t>
+            </a:r>
+            <a:r>
+              <a:rPr lang="en-US" sz="1200" i="1" dirty="0">
+                <a:latin typeface="Calibri" panose="020F0502020204030204" pitchFamily="34" charset="0"/>
+                <a:ea typeface="Calibri" panose="020F0502020204030204" pitchFamily="34" charset="0"/>
+                <a:cs typeface="Calibri" panose="020F0502020204030204" pitchFamily="34" charset="0"/>
+              </a:rPr>
+              <a:t>Joined Projects, </a:t>
+            </a:r>
+            <a:r>
+              <a:rPr lang="en-US" sz="1200" i="1" dirty="0" err="1">
+                <a:latin typeface="Calibri" panose="020F0502020204030204" pitchFamily="34" charset="0"/>
+                <a:ea typeface="Calibri" panose="020F0502020204030204" pitchFamily="34" charset="0"/>
+                <a:cs typeface="Calibri" panose="020F0502020204030204" pitchFamily="34" charset="0"/>
+              </a:rPr>
+              <a:t>Work_Orders</a:t>
+            </a:r>
+            <a:r>
+              <a:rPr lang="en-US" sz="1200" i="1" dirty="0">
+                <a:latin typeface="Calibri" panose="020F0502020204030204" pitchFamily="34" charset="0"/>
+                <a:ea typeface="Calibri" panose="020F0502020204030204" pitchFamily="34" charset="0"/>
+                <a:cs typeface="Calibri" panose="020F0502020204030204" pitchFamily="34" charset="0"/>
+              </a:rPr>
+              <a:t>, and </a:t>
+            </a:r>
+            <a:r>
+              <a:rPr lang="en-US" sz="1200" i="1" dirty="0" err="1">
+                <a:latin typeface="Calibri" panose="020F0502020204030204" pitchFamily="34" charset="0"/>
+                <a:ea typeface="Calibri" panose="020F0502020204030204" pitchFamily="34" charset="0"/>
+                <a:cs typeface="Calibri" panose="020F0502020204030204" pitchFamily="34" charset="0"/>
+              </a:rPr>
+              <a:t>VendorCommitments</a:t>
+            </a:r>
+            <a:r>
+              <a:rPr lang="en-US" sz="1200" i="1" dirty="0">
+                <a:latin typeface="Calibri" panose="020F0502020204030204" pitchFamily="34" charset="0"/>
+                <a:ea typeface="Calibri" panose="020F0502020204030204" pitchFamily="34" charset="0"/>
+                <a:cs typeface="Calibri" panose="020F0502020204030204" pitchFamily="34" charset="0"/>
+              </a:rPr>
+              <a:t> on </a:t>
+            </a:r>
+            <a:r>
+              <a:rPr lang="en-US" sz="1200" i="1" dirty="0" err="1">
+                <a:latin typeface="Calibri" panose="020F0502020204030204" pitchFamily="34" charset="0"/>
+                <a:ea typeface="Calibri" panose="020F0502020204030204" pitchFamily="34" charset="0"/>
+                <a:cs typeface="Calibri" panose="020F0502020204030204" pitchFamily="34" charset="0"/>
+              </a:rPr>
+              <a:t>project_id</a:t>
+            </a:r>
+            <a:r>
+              <a:rPr lang="en-US" sz="1200" i="1" dirty="0">
+                <a:latin typeface="Calibri" panose="020F0502020204030204" pitchFamily="34" charset="0"/>
+                <a:ea typeface="Calibri" panose="020F0502020204030204" pitchFamily="34" charset="0"/>
+                <a:cs typeface="Calibri" panose="020F0502020204030204" pitchFamily="34" charset="0"/>
+              </a:rPr>
+              <a:t>.</a:t>
+            </a:r>
+            <a:endParaRPr lang="en-US" sz="1400" i="1" dirty="0">
+              <a:latin typeface="Calibri" panose="020F0502020204030204" pitchFamily="34" charset="0"/>
+              <a:ea typeface="Calibri" panose="020F0502020204030204" pitchFamily="34" charset="0"/>
+              <a:cs typeface="Calibri" panose="020F0502020204030204" pitchFamily="34" charset="0"/>
+            </a:endParaRPr>
+          </a:p>
+        </p:txBody>
+      </p:sp>
+      <p:pic>
+        <p:nvPicPr>
+          <p:cNvPr id="12" name="Picture 11">
+            <a:extLst>
+              <a:ext uri="{FF2B5EF4-FFF2-40B4-BE49-F238E27FC236}">
+                <a16:creationId xmlns:a16="http://schemas.microsoft.com/office/drawing/2014/main" id="{58497E02-94F4-37C2-2ABB-CFAC81E71574}"/>
+              </a:ext>
+            </a:extLst>
+          </p:cNvPr>
+          <p:cNvPicPr>
+            <a:picLocks noChangeAspect="1"/>
+          </p:cNvPicPr>
+          <p:nvPr/>
+        </p:nvPicPr>
+        <p:blipFill>
+          <a:blip r:embed="rId2">
+            <a:extLst>
+              <a:ext uri="{28A0092B-C50C-407E-A947-70E740481C1C}">
+                <a14:useLocalDpi xmlns:a14="http://schemas.microsoft.com/office/drawing/2010/main" val="0"/>
+              </a:ext>
+            </a:extLst>
+          </a:blip>
+          <a:stretch>
+            <a:fillRect/>
+          </a:stretch>
+        </p:blipFill>
+        <p:spPr>
+          <a:xfrm>
+            <a:off x="210532" y="987552"/>
+            <a:ext cx="5241084" cy="4300671"/>
+          </a:xfrm>
+          <a:prstGeom prst="rect">
+            <a:avLst/>
+          </a:prstGeom>
+        </p:spPr>
+      </p:pic>
+      <p:sp>
+        <p:nvSpPr>
+          <p:cNvPr id="16" name="TextBox 15">
+            <a:extLst>
+              <a:ext uri="{FF2B5EF4-FFF2-40B4-BE49-F238E27FC236}">
+                <a16:creationId xmlns:a16="http://schemas.microsoft.com/office/drawing/2014/main" id="{BD6B941B-1133-E840-15AB-5FC4C550A4CB}"/>
+              </a:ext>
+            </a:extLst>
+          </p:cNvPr>
+          <p:cNvSpPr txBox="1"/>
+          <p:nvPr/>
+        </p:nvSpPr>
+        <p:spPr>
+          <a:xfrm>
+            <a:off x="0" y="6334780"/>
+            <a:ext cx="8010144" cy="523220"/>
+          </a:xfrm>
+          <a:prstGeom prst="rect">
+            <a:avLst/>
+          </a:prstGeom>
+          <a:noFill/>
+        </p:spPr>
+        <p:txBody>
+          <a:bodyPr wrap="square" rtlCol="0">
+            <a:spAutoFit/>
+          </a:bodyPr>
+          <a:lstStyle/>
+          <a:p>
+            <a:r>
+              <a:rPr lang="en-US" sz="1400" dirty="0">
+                <a:latin typeface="Calibri" panose="020F0502020204030204" pitchFamily="34" charset="0"/>
+                <a:ea typeface="Calibri" panose="020F0502020204030204" pitchFamily="34" charset="0"/>
+                <a:cs typeface="Calibri" panose="020F0502020204030204" pitchFamily="34" charset="0"/>
+              </a:rPr>
+              <a:t>Project Repository:</a:t>
+            </a:r>
+          </a:p>
+          <a:p>
+            <a:r>
+              <a:rPr lang="en-US" sz="1400" dirty="0">
+                <a:latin typeface="Calibri" panose="020F0502020204030204" pitchFamily="34" charset="0"/>
+                <a:ea typeface="Calibri" panose="020F0502020204030204" pitchFamily="34" charset="0"/>
+                <a:cs typeface="Calibri" panose="020F0502020204030204" pitchFamily="34" charset="0"/>
+                <a:hlinkClick r:id="rId3"/>
+              </a:rPr>
+              <a:t>https://github.com/Pallabi5200/Civil_Engineering_Data_Science_Project</a:t>
+            </a:r>
+            <a:endParaRPr lang="en-US" sz="1400" dirty="0">
+              <a:latin typeface="Calibri" panose="020F0502020204030204" pitchFamily="34" charset="0"/>
+              <a:ea typeface="Calibri" panose="020F0502020204030204" pitchFamily="34" charset="0"/>
+              <a:cs typeface="Calibri" panose="020F0502020204030204" pitchFamily="34" charset="0"/>
+            </a:endParaRPr>
+          </a:p>
+        </p:txBody>
+      </p:sp>
+    </p:spTree>
+    <p:extLst>
+      <p:ext uri="{BB962C8B-B14F-4D97-AF65-F5344CB8AC3E}">
+        <p14:creationId xmlns:p14="http://schemas.microsoft.com/office/powerpoint/2010/main" val="3536277166"/>
+      </p:ext>
+    </p:extLst>
+  </p:cSld>
+  <p:clrMapOvr>
+    <a:masterClrMapping/>
+  </p:clrMapOvr>
+</p:sld>
+</file>
+
+<file path=ppt/slides/slide8.xml><?xml version="1.0" encoding="utf-8"?>
+<p:sld xmlns:a="http://schemas.openxmlformats.org/drawingml/2006/main" xmlns:r="http://schemas.openxmlformats.org/officeDocument/2006/relationships" xmlns:p="http://schemas.openxmlformats.org/presentationml/2006/main">
+  <p:cSld>
+    <p:spTree>
+      <p:nvGrpSpPr>
+        <p:cNvPr id="1" name=""/>
+        <p:cNvGrpSpPr/>
+        <p:nvPr/>
+      </p:nvGrpSpPr>
+      <p:grpSpPr>
+        <a:xfrm>
+          <a:off x="0" y="0"/>
+          <a:ext cx="0" cy="0"/>
+          <a:chOff x="0" y="0"/>
+          <a:chExt cx="0" cy="0"/>
+        </a:xfrm>
+      </p:grpSpPr>
+      <p:sp>
+        <p:nvSpPr>
+          <p:cNvPr id="3" name="TextBox 2">
+            <a:extLst>
+              <a:ext uri="{FF2B5EF4-FFF2-40B4-BE49-F238E27FC236}">
+                <a16:creationId xmlns:a16="http://schemas.microsoft.com/office/drawing/2014/main" id="{57C18D09-CAE3-90DE-EF95-374E366A904A}"/>
+              </a:ext>
+            </a:extLst>
+          </p:cNvPr>
+          <p:cNvSpPr txBox="1"/>
+          <p:nvPr/>
+        </p:nvSpPr>
+        <p:spPr>
+          <a:xfrm>
+            <a:off x="810706" y="276582"/>
+            <a:ext cx="11170762" cy="1077218"/>
+          </a:xfrm>
+          <a:prstGeom prst="rect">
+            <a:avLst/>
+          </a:prstGeom>
+          <a:noFill/>
+        </p:spPr>
+        <p:txBody>
+          <a:bodyPr wrap="square" rtlCol="0">
+            <a:spAutoFit/>
+          </a:bodyPr>
+          <a:lstStyle/>
+          <a:p>
+            <a:r>
+              <a:rPr lang="en-US" sz="3200" b="1" u="sng" dirty="0">
+                <a:latin typeface="Calibri" panose="020F0502020204030204" pitchFamily="34" charset="0"/>
+                <a:ea typeface="Calibri" panose="020F0502020204030204" pitchFamily="34" charset="0"/>
+                <a:cs typeface="Calibri" panose="020F0502020204030204" pitchFamily="34" charset="0"/>
+              </a:rPr>
+              <a:t>Quality Control &amp; Non-Destructive Sound Wave Testing (NDT)</a:t>
+            </a:r>
+          </a:p>
+          <a:p>
+            <a:endParaRPr lang="en-US" sz="3200" b="1" u="sng" dirty="0">
+              <a:latin typeface="Calibri" panose="020F0502020204030204" pitchFamily="34" charset="0"/>
+              <a:ea typeface="Calibri" panose="020F0502020204030204" pitchFamily="34" charset="0"/>
+              <a:cs typeface="Calibri" panose="020F0502020204030204" pitchFamily="34" charset="0"/>
+            </a:endParaRPr>
+          </a:p>
+        </p:txBody>
+      </p:sp>
+      <p:sp>
+        <p:nvSpPr>
+          <p:cNvPr id="5" name="Rectangle: Rounded Corners 4">
+            <a:extLst>
+              <a:ext uri="{FF2B5EF4-FFF2-40B4-BE49-F238E27FC236}">
+                <a16:creationId xmlns:a16="http://schemas.microsoft.com/office/drawing/2014/main" id="{CAA88D5B-5DE0-2593-6FDF-246018DB0F19}"/>
+              </a:ext>
+            </a:extLst>
+          </p:cNvPr>
+          <p:cNvSpPr/>
+          <p:nvPr/>
+        </p:nvSpPr>
+        <p:spPr>
+          <a:xfrm>
+            <a:off x="5772064" y="987552"/>
+            <a:ext cx="6126480" cy="2368296"/>
+          </a:xfrm>
+          <a:prstGeom prst="roundRect">
+            <a:avLst/>
+          </a:prstGeom>
+          <a:ln/>
+        </p:spPr>
+        <p:style>
+          <a:lnRef idx="1">
+            <a:schemeClr val="accent3"/>
+          </a:lnRef>
+          <a:fillRef idx="2">
+            <a:schemeClr val="accent3"/>
+          </a:fillRef>
+          <a:effectRef idx="1">
+            <a:schemeClr val="accent3"/>
+          </a:effectRef>
+          <a:fontRef idx="minor">
+            <a:schemeClr val="dk1"/>
+          </a:fontRef>
+        </p:style>
+        <p:txBody>
+          <a:bodyPr rtlCol="0" anchor="ctr"/>
+          <a:lstStyle/>
+          <a:p>
+            <a:pPr algn="ctr"/>
+            <a:endParaRPr lang="en-US"/>
+          </a:p>
+        </p:txBody>
+      </p:sp>
+      <p:sp>
+        <p:nvSpPr>
+          <p:cNvPr id="7" name="Rectangle: Rounded Corners 6">
+            <a:extLst>
+              <a:ext uri="{FF2B5EF4-FFF2-40B4-BE49-F238E27FC236}">
+                <a16:creationId xmlns:a16="http://schemas.microsoft.com/office/drawing/2014/main" id="{5C5E1BCA-40CB-9890-1A53-E9B25481E45A}"/>
+              </a:ext>
+            </a:extLst>
+          </p:cNvPr>
+          <p:cNvSpPr/>
+          <p:nvPr/>
+        </p:nvSpPr>
+        <p:spPr>
+          <a:xfrm>
+            <a:off x="5617464" y="3602822"/>
+            <a:ext cx="6126480" cy="2468040"/>
+          </a:xfrm>
+          <a:prstGeom prst="roundRect">
+            <a:avLst/>
+          </a:prstGeom>
+          <a:gradFill flip="none" rotWithShape="1">
+            <a:gsLst>
+              <a:gs pos="0">
+                <a:schemeClr val="accent2">
+                  <a:lumMod val="67000"/>
+                </a:schemeClr>
+              </a:gs>
+              <a:gs pos="48000">
+                <a:schemeClr val="accent2">
+                  <a:lumMod val="97000"/>
+                  <a:lumOff val="3000"/>
+                </a:schemeClr>
+              </a:gs>
+              <a:gs pos="100000">
+                <a:schemeClr val="accent2">
+                  <a:lumMod val="60000"/>
+                  <a:lumOff val="40000"/>
+                </a:schemeClr>
+              </a:gs>
+            </a:gsLst>
+            <a:lin ang="16200000" scaled="1"/>
+            <a:tileRect/>
+          </a:gradFill>
+          <a:ln>
+            <a:noFill/>
+          </a:ln>
+        </p:spPr>
+        <p:style>
+          <a:lnRef idx="0">
+            <a:scrgbClr r="0" g="0" b="0"/>
+          </a:lnRef>
+          <a:fillRef idx="0">
+            <a:scrgbClr r="0" g="0" b="0"/>
+          </a:fillRef>
+          <a:effectRef idx="0">
+            <a:scrgbClr r="0" g="0" b="0"/>
+          </a:effectRef>
+          <a:fontRef idx="minor">
+            <a:schemeClr val="lt1"/>
+          </a:fontRef>
+        </p:style>
+        <p:txBody>
+          <a:bodyPr rtlCol="0" anchor="ctr"/>
+          <a:lstStyle/>
+          <a:p>
+            <a:pPr algn="ctr"/>
+            <a:endParaRPr lang="en-US" dirty="0"/>
+          </a:p>
+        </p:txBody>
+      </p:sp>
+      <p:sp>
+        <p:nvSpPr>
+          <p:cNvPr id="9" name="TextBox 8">
+            <a:extLst>
+              <a:ext uri="{FF2B5EF4-FFF2-40B4-BE49-F238E27FC236}">
+                <a16:creationId xmlns:a16="http://schemas.microsoft.com/office/drawing/2014/main" id="{4F15CE01-818A-096E-102B-E832A66F18E1}"/>
+              </a:ext>
+            </a:extLst>
+          </p:cNvPr>
+          <p:cNvSpPr txBox="1"/>
+          <p:nvPr/>
+        </p:nvSpPr>
+        <p:spPr>
+          <a:xfrm>
+            <a:off x="6574536" y="1061412"/>
+            <a:ext cx="5095109" cy="338554"/>
+          </a:xfrm>
+          <a:prstGeom prst="rect">
+            <a:avLst/>
+          </a:prstGeom>
+          <a:noFill/>
+        </p:spPr>
+        <p:txBody>
+          <a:bodyPr wrap="square" rtlCol="0">
+            <a:spAutoFit/>
+          </a:bodyPr>
+          <a:lstStyle/>
+          <a:p>
             <a:r>
               <a:rPr lang="en-US" sz="1600" b="1" u="sng" dirty="0">
                 <a:latin typeface="Calibri" panose="020F0502020204030204" pitchFamily="34" charset="0"/>
                 <a:ea typeface="Calibri" panose="020F0502020204030204" pitchFamily="34" charset="0"/>
                 <a:cs typeface="Calibri" panose="020F0502020204030204" pitchFamily="34" charset="0"/>
               </a:rPr>
-              <a:t>Single-Pass Quality Audits (CASE WHEN)</a:t>
+              <a:t>Python Quality EDA &amp; Outlier Audit</a:t>
             </a:r>
             <a:endParaRPr lang="en-US" sz="1600" u="sng" dirty="0">
               <a:latin typeface="Calibri" panose="020F0502020204030204" pitchFamily="34" charset="0"/>
@@ -15659,10 +18531,10 @@
       </p:sp>
       <p:sp>
         <p:nvSpPr>
-          <p:cNvPr id="15" name="TextBox 14">
-            <a:extLst>
-              <a:ext uri="{FF2B5EF4-FFF2-40B4-BE49-F238E27FC236}">
-                <a16:creationId xmlns:a16="http://schemas.microsoft.com/office/drawing/2014/main" id="{41F1E240-C883-F8C6-78C7-2ABA68BEEBDB}"/>
+          <p:cNvPr id="13" name="TextBox 12">
+            <a:extLst>
+              <a:ext uri="{FF2B5EF4-FFF2-40B4-BE49-F238E27FC236}">
+                <a16:creationId xmlns:a16="http://schemas.microsoft.com/office/drawing/2014/main" id="{21F0CC72-7F76-1473-6BA0-29E153DECB72}"/>
               </a:ext>
             </a:extLst>
           </p:cNvPr>
@@ -15671,8 +18543,8 @@
         </p:nvSpPr>
         <p:spPr>
           <a:xfrm>
-            <a:off x="717804" y="4096208"/>
-            <a:ext cx="5586984" cy="276999"/>
+            <a:off x="5785677" y="4035210"/>
+            <a:ext cx="5586984" cy="1569660"/>
           </a:xfrm>
           <a:prstGeom prst="rect">
             <a:avLst/>
@@ -15685,14 +18557,107 @@
           </a:bodyPr>
           <a:lstStyle/>
           <a:p>
-            <a:pPr lvl="0"/>
+            <a:pPr marL="228600" lvl="0" indent="-228600">
+              <a:buFont typeface="+mj-lt"/>
+              <a:buAutoNum type="arabicPeriod"/>
+            </a:pPr>
+            <a:r>
+              <a:rPr lang="en-US" sz="1200" b="1" u="sng" dirty="0">
+                <a:latin typeface="Calibri" panose="020F0502020204030204" pitchFamily="34" charset="0"/>
+                <a:ea typeface="Calibri" panose="020F0502020204030204" pitchFamily="34" charset="0"/>
+                <a:cs typeface="Calibri" panose="020F0502020204030204" pitchFamily="34" charset="0"/>
+              </a:rPr>
+              <a:t>Quality Specification</a:t>
+            </a:r>
             <a:r>
               <a:rPr lang="en-US" sz="1200" i="1" dirty="0">
                 <a:latin typeface="Calibri" panose="020F0502020204030204" pitchFamily="34" charset="0"/>
                 <a:ea typeface="Calibri" panose="020F0502020204030204" pitchFamily="34" charset="0"/>
                 <a:cs typeface="Calibri" panose="020F0502020204030204" pitchFamily="34" charset="0"/>
               </a:rPr>
-              <a:t>U</a:t>
+              <a:t>: Target structural concrete (M-40 grade) requires &gt;= 40.0 MPa at 28 days of curing.</a:t>
+            </a:r>
+          </a:p>
+          <a:p>
+            <a:pPr marL="228600" lvl="0" indent="-228600">
+              <a:buFont typeface="+mj-lt"/>
+              <a:buAutoNum type="arabicPeriod"/>
+            </a:pPr>
+            <a:endParaRPr lang="en-US" sz="1200" i="1" dirty="0">
+              <a:latin typeface="Calibri" panose="020F0502020204030204" pitchFamily="34" charset="0"/>
+              <a:ea typeface="Calibri" panose="020F0502020204030204" pitchFamily="34" charset="0"/>
+              <a:cs typeface="Calibri" panose="020F0502020204030204" pitchFamily="34" charset="0"/>
+            </a:endParaRPr>
+          </a:p>
+          <a:p>
+            <a:pPr marL="228600" lvl="0" indent="-228600">
+              <a:buFont typeface="+mj-lt"/>
+              <a:buAutoNum type="arabicPeriod"/>
+            </a:pPr>
+            <a:r>
+              <a:rPr lang="en-US" sz="1200" b="1" u="sng" dirty="0">
+                <a:latin typeface="Calibri" panose="020F0502020204030204" pitchFamily="34" charset="0"/>
+                <a:ea typeface="Calibri" panose="020F0502020204030204" pitchFamily="34" charset="0"/>
+                <a:cs typeface="Calibri" panose="020F0502020204030204" pitchFamily="34" charset="0"/>
+              </a:rPr>
+              <a:t>Acoustic Velocity Metric</a:t>
+            </a:r>
+            <a:r>
+              <a:rPr lang="en-US" sz="1200" i="1" dirty="0">
+                <a:latin typeface="Calibri" panose="020F0502020204030204" pitchFamily="34" charset="0"/>
+                <a:ea typeface="Calibri" panose="020F0502020204030204" pitchFamily="34" charset="0"/>
+                <a:cs typeface="Calibri" panose="020F0502020204030204" pitchFamily="34" charset="0"/>
+              </a:rPr>
+              <a:t>: High Ultrasonic Pulse Velocity (&gt;= 4200 m/s) indicates high concrete density with zero voids or micro-cracks.</a:t>
+            </a:r>
+          </a:p>
+          <a:p>
+            <a:pPr marL="228600" lvl="0" indent="-228600">
+              <a:buFont typeface="+mj-lt"/>
+              <a:buAutoNum type="arabicPeriod"/>
+            </a:pPr>
+            <a:endParaRPr lang="en-US" sz="1200" i="1" dirty="0">
+              <a:latin typeface="Calibri" panose="020F0502020204030204" pitchFamily="34" charset="0"/>
+              <a:ea typeface="Calibri" panose="020F0502020204030204" pitchFamily="34" charset="0"/>
+              <a:cs typeface="Calibri" panose="020F0502020204030204" pitchFamily="34" charset="0"/>
+            </a:endParaRPr>
+          </a:p>
+          <a:p>
+            <a:pPr marL="228600" lvl="0" indent="-228600">
+              <a:buFont typeface="+mj-lt"/>
+              <a:buAutoNum type="arabicPeriod"/>
+            </a:pPr>
+            <a:r>
+              <a:rPr lang="en-US" sz="1200" b="1" u="sng" dirty="0">
+                <a:latin typeface="Calibri" panose="020F0502020204030204" pitchFamily="34" charset="0"/>
+                <a:ea typeface="Calibri" panose="020F0502020204030204" pitchFamily="34" charset="0"/>
+                <a:cs typeface="Calibri" panose="020F0502020204030204" pitchFamily="34" charset="0"/>
+              </a:rPr>
+              <a:t>Empirical Site Finding</a:t>
+            </a:r>
+            <a:r>
+              <a:rPr lang="en-US" sz="1200" i="1" dirty="0">
+                <a:latin typeface="Calibri" panose="020F0502020204030204" pitchFamily="34" charset="0"/>
+                <a:ea typeface="Calibri" panose="020F0502020204030204" pitchFamily="34" charset="0"/>
+                <a:cs typeface="Calibri" panose="020F0502020204030204" pitchFamily="34" charset="0"/>
+              </a:rPr>
+              <a:t>: High-strength epoxy grouting at </a:t>
+            </a:r>
+            <a:r>
+              <a:rPr lang="en-US" sz="1200" i="1" dirty="0" err="1">
+                <a:latin typeface="Calibri" panose="020F0502020204030204" pitchFamily="34" charset="0"/>
+                <a:ea typeface="Calibri" panose="020F0502020204030204" pitchFamily="34" charset="0"/>
+                <a:cs typeface="Calibri" panose="020F0502020204030204" pitchFamily="34" charset="0"/>
+              </a:rPr>
+              <a:t>Molagavali</a:t>
+            </a:r>
+            <a:r>
+              <a:rPr lang="en-US" sz="1200" i="1" dirty="0">
+                <a:latin typeface="Calibri" panose="020F0502020204030204" pitchFamily="34" charset="0"/>
+                <a:ea typeface="Calibri" panose="020F0502020204030204" pitchFamily="34" charset="0"/>
+                <a:cs typeface="Calibri" panose="020F0502020204030204" pitchFamily="34" charset="0"/>
+              </a:rPr>
+              <a:t> site achieved 100% compliance with an average compressive strength of 58.40 MPa.</a:t>
             </a:r>
             <a:endParaRPr lang="en-US" sz="1400" i="1" dirty="0">
               <a:latin typeface="Calibri" panose="020F0502020204030204" pitchFamily="34" charset="0"/>
@@ -15702,10 +18667,986 @@
           </a:p>
         </p:txBody>
       </p:sp>
+      <p:sp>
+        <p:nvSpPr>
+          <p:cNvPr id="15" name="TextBox 14">
+            <a:extLst>
+              <a:ext uri="{FF2B5EF4-FFF2-40B4-BE49-F238E27FC236}">
+                <a16:creationId xmlns:a16="http://schemas.microsoft.com/office/drawing/2014/main" id="{02924354-E160-77FD-3243-E28E2EA2AEDB}"/>
+              </a:ext>
+            </a:extLst>
+          </p:cNvPr>
+          <p:cNvSpPr txBox="1"/>
+          <p:nvPr/>
+        </p:nvSpPr>
+        <p:spPr>
+          <a:xfrm>
+            <a:off x="6031615" y="3698547"/>
+            <a:ext cx="5095109" cy="338554"/>
+          </a:xfrm>
+          <a:prstGeom prst="rect">
+            <a:avLst/>
+          </a:prstGeom>
+          <a:noFill/>
+        </p:spPr>
+        <p:txBody>
+          <a:bodyPr wrap="square" rtlCol="0">
+            <a:spAutoFit/>
+          </a:bodyPr>
+          <a:lstStyle/>
+          <a:p>
+            <a:pPr algn="ctr"/>
+            <a:r>
+              <a:rPr lang="en-US" sz="1600" b="1" u="sng" dirty="0">
+                <a:latin typeface="Calibri" panose="020F0502020204030204" pitchFamily="34" charset="0"/>
+                <a:ea typeface="Calibri" panose="020F0502020204030204" pitchFamily="34" charset="0"/>
+                <a:cs typeface="Calibri" panose="020F0502020204030204" pitchFamily="34" charset="0"/>
+              </a:rPr>
+              <a:t>Sound Wave NDT &amp; Strength Findings</a:t>
+            </a:r>
+            <a:endParaRPr lang="en-US" sz="1600" u="sng" dirty="0">
+              <a:latin typeface="Calibri" panose="020F0502020204030204" pitchFamily="34" charset="0"/>
+              <a:ea typeface="Calibri" panose="020F0502020204030204" pitchFamily="34" charset="0"/>
+              <a:cs typeface="Calibri" panose="020F0502020204030204" pitchFamily="34" charset="0"/>
+            </a:endParaRPr>
+          </a:p>
+        </p:txBody>
+      </p:sp>
+      <p:sp>
+        <p:nvSpPr>
+          <p:cNvPr id="17" name="TextBox 16">
+            <a:extLst>
+              <a:ext uri="{FF2B5EF4-FFF2-40B4-BE49-F238E27FC236}">
+                <a16:creationId xmlns:a16="http://schemas.microsoft.com/office/drawing/2014/main" id="{970C87FC-FE91-6A70-70B5-21D5724A168E}"/>
+              </a:ext>
+            </a:extLst>
+          </p:cNvPr>
+          <p:cNvSpPr txBox="1"/>
+          <p:nvPr/>
+        </p:nvSpPr>
+        <p:spPr>
+          <a:xfrm>
+            <a:off x="5913120" y="1529229"/>
+            <a:ext cx="5586984" cy="1384995"/>
+          </a:xfrm>
+          <a:prstGeom prst="rect">
+            <a:avLst/>
+          </a:prstGeom>
+          <a:noFill/>
+        </p:spPr>
+        <p:txBody>
+          <a:bodyPr wrap="square" rtlCol="0">
+            <a:spAutoFit/>
+          </a:bodyPr>
+          <a:lstStyle/>
+          <a:p>
+            <a:pPr marL="228600" lvl="0" indent="-228600">
+              <a:buFont typeface="+mj-lt"/>
+              <a:buAutoNum type="arabicPeriod"/>
+            </a:pPr>
+            <a:r>
+              <a:rPr lang="en-US" sz="1200" b="1" u="sng" dirty="0">
+                <a:latin typeface="Calibri" panose="020F0502020204030204" pitchFamily="34" charset="0"/>
+                <a:ea typeface="Calibri" panose="020F0502020204030204" pitchFamily="34" charset="0"/>
+                <a:cs typeface="Calibri" panose="020F0502020204030204" pitchFamily="34" charset="0"/>
+              </a:rPr>
+              <a:t>Database Ingestion</a:t>
+            </a:r>
+            <a:r>
+              <a:rPr lang="en-US" sz="1200" i="1" dirty="0">
+                <a:latin typeface="Calibri" panose="020F0502020204030204" pitchFamily="34" charset="0"/>
+                <a:ea typeface="Calibri" panose="020F0502020204030204" pitchFamily="34" charset="0"/>
+                <a:cs typeface="Calibri" panose="020F0502020204030204" pitchFamily="34" charset="0"/>
+              </a:rPr>
+              <a:t>: Extracted concrete quality test logs (</a:t>
+            </a:r>
+            <a:r>
+              <a:rPr lang="en-US" sz="1200" i="1" dirty="0" err="1">
+                <a:latin typeface="Calibri" panose="020F0502020204030204" pitchFamily="34" charset="0"/>
+                <a:ea typeface="Calibri" panose="020F0502020204030204" pitchFamily="34" charset="0"/>
+                <a:cs typeface="Calibri" panose="020F0502020204030204" pitchFamily="34" charset="0"/>
+              </a:rPr>
+              <a:t>Field_Quality_Logs</a:t>
+            </a:r>
+            <a:r>
+              <a:rPr lang="en-US" sz="1200" i="1" dirty="0">
+                <a:latin typeface="Calibri" panose="020F0502020204030204" pitchFamily="34" charset="0"/>
+                <a:ea typeface="Calibri" panose="020F0502020204030204" pitchFamily="34" charset="0"/>
+                <a:cs typeface="Calibri" panose="020F0502020204030204" pitchFamily="34" charset="0"/>
+              </a:rPr>
+              <a:t>) from SQLite database into Pandas </a:t>
+            </a:r>
+            <a:r>
+              <a:rPr lang="en-US" sz="1200" i="1" dirty="0" err="1">
+                <a:latin typeface="Calibri" panose="020F0502020204030204" pitchFamily="34" charset="0"/>
+                <a:ea typeface="Calibri" panose="020F0502020204030204" pitchFamily="34" charset="0"/>
+                <a:cs typeface="Calibri" panose="020F0502020204030204" pitchFamily="34" charset="0"/>
+              </a:rPr>
+              <a:t>df_quality</a:t>
+            </a:r>
+            <a:r>
+              <a:rPr lang="en-US" sz="1200" i="1" dirty="0">
+                <a:latin typeface="Calibri" panose="020F0502020204030204" pitchFamily="34" charset="0"/>
+                <a:ea typeface="Calibri" panose="020F0502020204030204" pitchFamily="34" charset="0"/>
+                <a:cs typeface="Calibri" panose="020F0502020204030204" pitchFamily="34" charset="0"/>
+              </a:rPr>
+              <a:t>.</a:t>
+            </a:r>
+          </a:p>
+          <a:p>
+            <a:pPr marL="228600" lvl="0" indent="-228600">
+              <a:buFont typeface="+mj-lt"/>
+              <a:buAutoNum type="arabicPeriod"/>
+            </a:pPr>
+            <a:endParaRPr lang="en-US" sz="1200" i="1" dirty="0">
+              <a:latin typeface="Calibri" panose="020F0502020204030204" pitchFamily="34" charset="0"/>
+              <a:ea typeface="Calibri" panose="020F0502020204030204" pitchFamily="34" charset="0"/>
+              <a:cs typeface="Calibri" panose="020F0502020204030204" pitchFamily="34" charset="0"/>
+            </a:endParaRPr>
+          </a:p>
+          <a:p>
+            <a:pPr marL="228600" lvl="0" indent="-228600">
+              <a:buFont typeface="+mj-lt"/>
+              <a:buAutoNum type="arabicPeriod"/>
+            </a:pPr>
+            <a:r>
+              <a:rPr lang="en-US" sz="1200" b="1" u="sng" dirty="0">
+                <a:latin typeface="Calibri" panose="020F0502020204030204" pitchFamily="34" charset="0"/>
+                <a:ea typeface="Calibri" panose="020F0502020204030204" pitchFamily="34" charset="0"/>
+                <a:cs typeface="Calibri" panose="020F0502020204030204" pitchFamily="34" charset="0"/>
+              </a:rPr>
+              <a:t>IQR Outlier Filtering</a:t>
+            </a:r>
+            <a:r>
+              <a:rPr lang="en-US" sz="1200" i="1" dirty="0">
+                <a:latin typeface="Calibri" panose="020F0502020204030204" pitchFamily="34" charset="0"/>
+                <a:ea typeface="Calibri" panose="020F0502020204030204" pitchFamily="34" charset="0"/>
+                <a:cs typeface="Calibri" panose="020F0502020204030204" pitchFamily="34" charset="0"/>
+              </a:rPr>
+              <a:t>: Computed 1.5 x IQR bounds on compressive strength (Q1 = 32.03 MPa, Q3 = 44.97 MPa).</a:t>
+            </a:r>
+          </a:p>
+          <a:p>
+            <a:pPr marL="228600" lvl="0" indent="-228600">
+              <a:buFont typeface="+mj-lt"/>
+              <a:buAutoNum type="arabicPeriod"/>
+            </a:pPr>
+            <a:endParaRPr lang="en-US" sz="1200" i="1" dirty="0">
+              <a:latin typeface="Calibri" panose="020F0502020204030204" pitchFamily="34" charset="0"/>
+              <a:ea typeface="Calibri" panose="020F0502020204030204" pitchFamily="34" charset="0"/>
+              <a:cs typeface="Calibri" panose="020F0502020204030204" pitchFamily="34" charset="0"/>
+            </a:endParaRPr>
+          </a:p>
+          <a:p>
+            <a:pPr marL="228600" lvl="0" indent="-228600">
+              <a:buFont typeface="+mj-lt"/>
+              <a:buAutoNum type="arabicPeriod"/>
+            </a:pPr>
+            <a:r>
+              <a:rPr lang="en-US" sz="1200" b="1" u="sng" dirty="0">
+                <a:latin typeface="Calibri" panose="020F0502020204030204" pitchFamily="34" charset="0"/>
+                <a:ea typeface="Calibri" panose="020F0502020204030204" pitchFamily="34" charset="0"/>
+                <a:cs typeface="Calibri" panose="020F0502020204030204" pitchFamily="34" charset="0"/>
+              </a:rPr>
+              <a:t>Data Quality Result</a:t>
+            </a:r>
+            <a:r>
+              <a:rPr lang="en-US" sz="1200" i="1" dirty="0">
+                <a:latin typeface="Calibri" panose="020F0502020204030204" pitchFamily="34" charset="0"/>
+                <a:ea typeface="Calibri" panose="020F0502020204030204" pitchFamily="34" charset="0"/>
+                <a:cs typeface="Calibri" panose="020F0502020204030204" pitchFamily="34" charset="0"/>
+              </a:rPr>
+              <a:t>: Confirmed 0 quality outliers, proving lab test data consistency.</a:t>
+            </a:r>
+            <a:endParaRPr lang="en-US" sz="1400" i="1" dirty="0">
+              <a:latin typeface="Calibri" panose="020F0502020204030204" pitchFamily="34" charset="0"/>
+              <a:ea typeface="Calibri" panose="020F0502020204030204" pitchFamily="34" charset="0"/>
+              <a:cs typeface="Calibri" panose="020F0502020204030204" pitchFamily="34" charset="0"/>
+            </a:endParaRPr>
+          </a:p>
+        </p:txBody>
+      </p:sp>
+      <p:pic>
+        <p:nvPicPr>
+          <p:cNvPr id="19" name="Picture 18">
+            <a:extLst>
+              <a:ext uri="{FF2B5EF4-FFF2-40B4-BE49-F238E27FC236}">
+                <a16:creationId xmlns:a16="http://schemas.microsoft.com/office/drawing/2014/main" id="{687A0F1D-99DD-99E6-AEF2-BBFC27353DF1}"/>
+              </a:ext>
+            </a:extLst>
+          </p:cNvPr>
+          <p:cNvPicPr>
+            <a:picLocks noChangeAspect="1"/>
+          </p:cNvPicPr>
+          <p:nvPr/>
+        </p:nvPicPr>
+        <p:blipFill>
+          <a:blip r:embed="rId2">
+            <a:extLst>
+              <a:ext uri="{28A0092B-C50C-407E-A947-70E740481C1C}">
+                <a14:useLocalDpi xmlns:a14="http://schemas.microsoft.com/office/drawing/2010/main" val="0"/>
+              </a:ext>
+            </a:extLst>
+          </a:blip>
+          <a:stretch>
+            <a:fillRect/>
+          </a:stretch>
+        </p:blipFill>
+        <p:spPr>
+          <a:xfrm>
+            <a:off x="157572" y="987552"/>
+            <a:ext cx="5336923" cy="3972136"/>
+          </a:xfrm>
+          <a:prstGeom prst="rect">
+            <a:avLst/>
+          </a:prstGeom>
+        </p:spPr>
+      </p:pic>
+      <p:sp>
+        <p:nvSpPr>
+          <p:cNvPr id="21" name="TextBox 20">
+            <a:extLst>
+              <a:ext uri="{FF2B5EF4-FFF2-40B4-BE49-F238E27FC236}">
+                <a16:creationId xmlns:a16="http://schemas.microsoft.com/office/drawing/2014/main" id="{CB17630B-558F-141F-523A-3F7723326146}"/>
+              </a:ext>
+            </a:extLst>
+          </p:cNvPr>
+          <p:cNvSpPr txBox="1"/>
+          <p:nvPr/>
+        </p:nvSpPr>
+        <p:spPr>
+          <a:xfrm>
+            <a:off x="0" y="6334780"/>
+            <a:ext cx="8010144" cy="523220"/>
+          </a:xfrm>
+          <a:prstGeom prst="rect">
+            <a:avLst/>
+          </a:prstGeom>
+          <a:noFill/>
+        </p:spPr>
+        <p:txBody>
+          <a:bodyPr wrap="square" rtlCol="0">
+            <a:spAutoFit/>
+          </a:bodyPr>
+          <a:lstStyle/>
+          <a:p>
+            <a:r>
+              <a:rPr lang="en-US" sz="1400" dirty="0">
+                <a:latin typeface="Calibri" panose="020F0502020204030204" pitchFamily="34" charset="0"/>
+                <a:ea typeface="Calibri" panose="020F0502020204030204" pitchFamily="34" charset="0"/>
+                <a:cs typeface="Calibri" panose="020F0502020204030204" pitchFamily="34" charset="0"/>
+              </a:rPr>
+              <a:t>Project Repository:</a:t>
+            </a:r>
+          </a:p>
+          <a:p>
+            <a:r>
+              <a:rPr lang="en-US" sz="1400" dirty="0">
+                <a:latin typeface="Calibri" panose="020F0502020204030204" pitchFamily="34" charset="0"/>
+                <a:ea typeface="Calibri" panose="020F0502020204030204" pitchFamily="34" charset="0"/>
+                <a:cs typeface="Calibri" panose="020F0502020204030204" pitchFamily="34" charset="0"/>
+                <a:hlinkClick r:id="rId3"/>
+              </a:rPr>
+              <a:t>https://github.com/Pallabi5200/Civil_Engineering_Data_Science_Project</a:t>
+            </a:r>
+            <a:endParaRPr lang="en-US" sz="1400" dirty="0">
+              <a:latin typeface="Calibri" panose="020F0502020204030204" pitchFamily="34" charset="0"/>
+              <a:ea typeface="Calibri" panose="020F0502020204030204" pitchFamily="34" charset="0"/>
+              <a:cs typeface="Calibri" panose="020F0502020204030204" pitchFamily="34" charset="0"/>
+            </a:endParaRPr>
+          </a:p>
+        </p:txBody>
+      </p:sp>
     </p:spTree>
     <p:extLst>
       <p:ext uri="{BB962C8B-B14F-4D97-AF65-F5344CB8AC3E}">
-        <p14:creationId xmlns:p14="http://schemas.microsoft.com/office/powerpoint/2010/main" val="3536277166"/>
+        <p14:creationId xmlns:p14="http://schemas.microsoft.com/office/powerpoint/2010/main" val="1949994117"/>
+      </p:ext>
+    </p:extLst>
+  </p:cSld>
+  <p:clrMapOvr>
+    <a:masterClrMapping/>
+  </p:clrMapOvr>
+</p:sld>
+</file>
+
+<file path=ppt/slides/slide9.xml><?xml version="1.0" encoding="utf-8"?>
+<p:sld xmlns:a="http://schemas.openxmlformats.org/drawingml/2006/main" xmlns:r="http://schemas.openxmlformats.org/officeDocument/2006/relationships" xmlns:p="http://schemas.openxmlformats.org/presentationml/2006/main">
+  <p:cSld>
+    <p:spTree>
+      <p:nvGrpSpPr>
+        <p:cNvPr id="1" name=""/>
+        <p:cNvGrpSpPr/>
+        <p:nvPr/>
+      </p:nvGrpSpPr>
+      <p:grpSpPr>
+        <a:xfrm>
+          <a:off x="0" y="0"/>
+          <a:ext cx="0" cy="0"/>
+          <a:chOff x="0" y="0"/>
+          <a:chExt cx="0" cy="0"/>
+        </a:xfrm>
+      </p:grpSpPr>
+      <p:sp>
+        <p:nvSpPr>
+          <p:cNvPr id="3" name="TextBox 2">
+            <a:extLst>
+              <a:ext uri="{FF2B5EF4-FFF2-40B4-BE49-F238E27FC236}">
+                <a16:creationId xmlns:a16="http://schemas.microsoft.com/office/drawing/2014/main" id="{E7C76C40-761B-F7D6-97D5-29A5D1A96FF2}"/>
+              </a:ext>
+            </a:extLst>
+          </p:cNvPr>
+          <p:cNvSpPr txBox="1"/>
+          <p:nvPr/>
+        </p:nvSpPr>
+        <p:spPr>
+          <a:xfrm>
+            <a:off x="1021238" y="212574"/>
+            <a:ext cx="11170762" cy="584775"/>
+          </a:xfrm>
+          <a:prstGeom prst="rect">
+            <a:avLst/>
+          </a:prstGeom>
+          <a:noFill/>
+        </p:spPr>
+        <p:txBody>
+          <a:bodyPr wrap="square" rtlCol="0">
+            <a:spAutoFit/>
+          </a:bodyPr>
+          <a:lstStyle/>
+          <a:p>
+            <a:r>
+              <a:rPr lang="en-US" sz="3200" b="1" u="sng" dirty="0">
+                <a:latin typeface="Calibri" panose="020F0502020204030204" pitchFamily="34" charset="0"/>
+                <a:ea typeface="Calibri" panose="020F0502020204030204" pitchFamily="34" charset="0"/>
+                <a:cs typeface="Calibri" panose="020F0502020204030204" pitchFamily="34" charset="0"/>
+              </a:rPr>
+              <a:t>Interactive Executive Dashboards (</a:t>
+            </a:r>
+            <a:r>
+              <a:rPr lang="en-US" sz="3200" b="1" u="sng" dirty="0" err="1">
+                <a:latin typeface="Calibri" panose="020F0502020204030204" pitchFamily="34" charset="0"/>
+                <a:ea typeface="Calibri" panose="020F0502020204030204" pitchFamily="34" charset="0"/>
+                <a:cs typeface="Calibri" panose="020F0502020204030204" pitchFamily="34" charset="0"/>
+              </a:rPr>
+              <a:t>Streamlit</a:t>
+            </a:r>
+            <a:r>
+              <a:rPr lang="en-US" sz="3200" b="1" u="sng" dirty="0">
+                <a:latin typeface="Calibri" panose="020F0502020204030204" pitchFamily="34" charset="0"/>
+                <a:ea typeface="Calibri" panose="020F0502020204030204" pitchFamily="34" charset="0"/>
+                <a:cs typeface="Calibri" panose="020F0502020204030204" pitchFamily="34" charset="0"/>
+              </a:rPr>
+              <a:t> &amp; Power BI)</a:t>
+            </a:r>
+          </a:p>
+        </p:txBody>
+      </p:sp>
+      <p:sp>
+        <p:nvSpPr>
+          <p:cNvPr id="5" name="Rectangle: Rounded Corners 4">
+            <a:extLst>
+              <a:ext uri="{FF2B5EF4-FFF2-40B4-BE49-F238E27FC236}">
+                <a16:creationId xmlns:a16="http://schemas.microsoft.com/office/drawing/2014/main" id="{0EF61B14-023A-17A9-D948-DF5A39DD4C99}"/>
+              </a:ext>
+            </a:extLst>
+          </p:cNvPr>
+          <p:cNvSpPr/>
+          <p:nvPr/>
+        </p:nvSpPr>
+        <p:spPr>
+          <a:xfrm>
+            <a:off x="5772064" y="987552"/>
+            <a:ext cx="6126480" cy="2368296"/>
+          </a:xfrm>
+          <a:prstGeom prst="roundRect">
+            <a:avLst/>
+          </a:prstGeom>
+          <a:ln/>
+        </p:spPr>
+        <p:style>
+          <a:lnRef idx="1">
+            <a:schemeClr val="accent3"/>
+          </a:lnRef>
+          <a:fillRef idx="2">
+            <a:schemeClr val="accent3"/>
+          </a:fillRef>
+          <a:effectRef idx="1">
+            <a:schemeClr val="accent3"/>
+          </a:effectRef>
+          <a:fontRef idx="minor">
+            <a:schemeClr val="dk1"/>
+          </a:fontRef>
+        </p:style>
+        <p:txBody>
+          <a:bodyPr rtlCol="0" anchor="ctr"/>
+          <a:lstStyle/>
+          <a:p>
+            <a:pPr algn="ctr"/>
+            <a:endParaRPr lang="en-US"/>
+          </a:p>
+        </p:txBody>
+      </p:sp>
+      <p:sp>
+        <p:nvSpPr>
+          <p:cNvPr id="7" name="Rectangle: Rounded Corners 6">
+            <a:extLst>
+              <a:ext uri="{FF2B5EF4-FFF2-40B4-BE49-F238E27FC236}">
+                <a16:creationId xmlns:a16="http://schemas.microsoft.com/office/drawing/2014/main" id="{E1B59B2C-21D5-0259-70DD-73CABD1E1062}"/>
+              </a:ext>
+            </a:extLst>
+          </p:cNvPr>
+          <p:cNvSpPr/>
+          <p:nvPr/>
+        </p:nvSpPr>
+        <p:spPr>
+          <a:xfrm>
+            <a:off x="5772064" y="3681984"/>
+            <a:ext cx="6126480" cy="2368296"/>
+          </a:xfrm>
+          <a:prstGeom prst="roundRect">
+            <a:avLst/>
+          </a:prstGeom>
+          <a:ln/>
+        </p:spPr>
+        <p:style>
+          <a:lnRef idx="1">
+            <a:schemeClr val="accent2"/>
+          </a:lnRef>
+          <a:fillRef idx="2">
+            <a:schemeClr val="accent2"/>
+          </a:fillRef>
+          <a:effectRef idx="1">
+            <a:schemeClr val="accent2"/>
+          </a:effectRef>
+          <a:fontRef idx="minor">
+            <a:schemeClr val="dk1"/>
+          </a:fontRef>
+        </p:style>
+        <p:txBody>
+          <a:bodyPr rtlCol="0" anchor="ctr"/>
+          <a:lstStyle/>
+          <a:p>
+            <a:pPr algn="ctr"/>
+            <a:endParaRPr lang="en-US"/>
+          </a:p>
+        </p:txBody>
+      </p:sp>
+      <p:sp>
+        <p:nvSpPr>
+          <p:cNvPr id="9" name="TextBox 8">
+            <a:extLst>
+              <a:ext uri="{FF2B5EF4-FFF2-40B4-BE49-F238E27FC236}">
+                <a16:creationId xmlns:a16="http://schemas.microsoft.com/office/drawing/2014/main" id="{A38F77A8-AA83-BA21-C17C-552C646881B0}"/>
+              </a:ext>
+            </a:extLst>
+          </p:cNvPr>
+          <p:cNvSpPr txBox="1"/>
+          <p:nvPr/>
+        </p:nvSpPr>
+        <p:spPr>
+          <a:xfrm>
+            <a:off x="6208776" y="1052268"/>
+            <a:ext cx="5095109" cy="338554"/>
+          </a:xfrm>
+          <a:prstGeom prst="rect">
+            <a:avLst/>
+          </a:prstGeom>
+          <a:noFill/>
+        </p:spPr>
+        <p:txBody>
+          <a:bodyPr wrap="square" rtlCol="0">
+            <a:spAutoFit/>
+          </a:bodyPr>
+          <a:lstStyle/>
+          <a:p>
+            <a:pPr algn="ctr"/>
+            <a:r>
+              <a:rPr lang="en-US" sz="1600" b="1" u="sng" dirty="0">
+                <a:latin typeface="Calibri" panose="020F0502020204030204" pitchFamily="34" charset="0"/>
+                <a:ea typeface="Calibri" panose="020F0502020204030204" pitchFamily="34" charset="0"/>
+                <a:cs typeface="Calibri" panose="020F0502020204030204" pitchFamily="34" charset="0"/>
+              </a:rPr>
+              <a:t>Dual-Dashboard Architecture</a:t>
+            </a:r>
+            <a:endParaRPr lang="en-US" sz="1600" u="sng" dirty="0">
+              <a:latin typeface="Calibri" panose="020F0502020204030204" pitchFamily="34" charset="0"/>
+              <a:ea typeface="Calibri" panose="020F0502020204030204" pitchFamily="34" charset="0"/>
+              <a:cs typeface="Calibri" panose="020F0502020204030204" pitchFamily="34" charset="0"/>
+            </a:endParaRPr>
+          </a:p>
+        </p:txBody>
+      </p:sp>
+      <p:sp>
+        <p:nvSpPr>
+          <p:cNvPr id="11" name="TextBox 10">
+            <a:extLst>
+              <a:ext uri="{FF2B5EF4-FFF2-40B4-BE49-F238E27FC236}">
+                <a16:creationId xmlns:a16="http://schemas.microsoft.com/office/drawing/2014/main" id="{197274B2-D972-CC28-9B64-5177C76ED5C2}"/>
+              </a:ext>
+            </a:extLst>
+          </p:cNvPr>
+          <p:cNvSpPr txBox="1"/>
+          <p:nvPr/>
+        </p:nvSpPr>
+        <p:spPr>
+          <a:xfrm>
+            <a:off x="5962838" y="1455538"/>
+            <a:ext cx="5586984" cy="1569660"/>
+          </a:xfrm>
+          <a:prstGeom prst="rect">
+            <a:avLst/>
+          </a:prstGeom>
+          <a:noFill/>
+        </p:spPr>
+        <p:txBody>
+          <a:bodyPr wrap="square" rtlCol="0">
+            <a:spAutoFit/>
+          </a:bodyPr>
+          <a:lstStyle/>
+          <a:p>
+            <a:pPr marL="228600" lvl="0" indent="-228600">
+              <a:buFont typeface="+mj-lt"/>
+              <a:buAutoNum type="arabicPeriod"/>
+            </a:pPr>
+            <a:r>
+              <a:rPr lang="en-US" sz="1200" b="1" u="sng" dirty="0" err="1">
+                <a:latin typeface="Calibri" panose="020F0502020204030204" pitchFamily="34" charset="0"/>
+                <a:ea typeface="Calibri" panose="020F0502020204030204" pitchFamily="34" charset="0"/>
+                <a:cs typeface="Calibri" panose="020F0502020204030204" pitchFamily="34" charset="0"/>
+              </a:rPr>
+              <a:t>Streamlit</a:t>
+            </a:r>
+            <a:r>
+              <a:rPr lang="en-US" sz="1200" b="1" u="sng" dirty="0">
+                <a:latin typeface="Calibri" panose="020F0502020204030204" pitchFamily="34" charset="0"/>
+                <a:ea typeface="Calibri" panose="020F0502020204030204" pitchFamily="34" charset="0"/>
+                <a:cs typeface="Calibri" panose="020F0502020204030204" pitchFamily="34" charset="0"/>
+              </a:rPr>
+              <a:t> Web App (app.py): </a:t>
+            </a:r>
+            <a:r>
+              <a:rPr lang="en-US" sz="1200" i="1" dirty="0">
+                <a:latin typeface="Calibri" panose="020F0502020204030204" pitchFamily="34" charset="0"/>
+                <a:ea typeface="Calibri" panose="020F0502020204030204" pitchFamily="34" charset="0"/>
+                <a:cs typeface="Calibri" panose="020F0502020204030204" pitchFamily="34" charset="0"/>
+              </a:rPr>
+              <a:t>Built for site engineers with project dropdown filters, top KPI cards, and </a:t>
+            </a:r>
+            <a:r>
+              <a:rPr lang="en-US" sz="1200" i="1" dirty="0" err="1">
+                <a:latin typeface="Calibri" panose="020F0502020204030204" pitchFamily="34" charset="0"/>
+                <a:ea typeface="Calibri" panose="020F0502020204030204" pitchFamily="34" charset="0"/>
+                <a:cs typeface="Calibri" panose="020F0502020204030204" pitchFamily="34" charset="0"/>
+              </a:rPr>
+              <a:t>Plotly</a:t>
+            </a:r>
+            <a:r>
+              <a:rPr lang="en-US" sz="1200" i="1" dirty="0">
+                <a:latin typeface="Calibri" panose="020F0502020204030204" pitchFamily="34" charset="0"/>
+                <a:ea typeface="Calibri" panose="020F0502020204030204" pitchFamily="34" charset="0"/>
+                <a:cs typeface="Calibri" panose="020F0502020204030204" pitchFamily="34" charset="0"/>
+              </a:rPr>
+              <a:t> analytics charts.</a:t>
+            </a:r>
+          </a:p>
+          <a:p>
+            <a:pPr marL="228600" lvl="0" indent="-228600">
+              <a:buFont typeface="+mj-lt"/>
+              <a:buAutoNum type="arabicPeriod"/>
+            </a:pPr>
+            <a:endParaRPr lang="en-US" sz="1200" i="1" dirty="0">
+              <a:latin typeface="Calibri" panose="020F0502020204030204" pitchFamily="34" charset="0"/>
+              <a:ea typeface="Calibri" panose="020F0502020204030204" pitchFamily="34" charset="0"/>
+              <a:cs typeface="Calibri" panose="020F0502020204030204" pitchFamily="34" charset="0"/>
+            </a:endParaRPr>
+          </a:p>
+          <a:p>
+            <a:pPr marL="228600" lvl="0" indent="-228600">
+              <a:buFont typeface="+mj-lt"/>
+              <a:buAutoNum type="arabicPeriod"/>
+            </a:pPr>
+            <a:r>
+              <a:rPr lang="en-US" sz="1200" b="1" u="sng" dirty="0">
+                <a:latin typeface="Calibri" panose="020F0502020204030204" pitchFamily="34" charset="0"/>
+                <a:ea typeface="Calibri" panose="020F0502020204030204" pitchFamily="34" charset="0"/>
+                <a:cs typeface="Calibri" panose="020F0502020204030204" pitchFamily="34" charset="0"/>
+              </a:rPr>
+              <a:t>Power BI Executive Suite:</a:t>
+            </a:r>
+            <a:r>
+              <a:rPr lang="en-US" sz="1200" i="1" dirty="0">
+                <a:latin typeface="Calibri" panose="020F0502020204030204" pitchFamily="34" charset="0"/>
+                <a:ea typeface="Calibri" panose="020F0502020204030204" pitchFamily="34" charset="0"/>
+                <a:cs typeface="Calibri" panose="020F0502020204030204" pitchFamily="34" charset="0"/>
+              </a:rPr>
+              <a:t> Built for C-suite directors using a Star Schema model (</a:t>
+            </a:r>
+            <a:r>
+              <a:rPr lang="en-US" sz="1200" i="1" dirty="0" err="1">
+                <a:latin typeface="Calibri" panose="020F0502020204030204" pitchFamily="34" charset="0"/>
+                <a:ea typeface="Calibri" panose="020F0502020204030204" pitchFamily="34" charset="0"/>
+                <a:cs typeface="Calibri" panose="020F0502020204030204" pitchFamily="34" charset="0"/>
+              </a:rPr>
+              <a:t>Fact_TaxInvoices</a:t>
+            </a:r>
+            <a:r>
+              <a:rPr lang="en-US" sz="1200" i="1" dirty="0">
+                <a:latin typeface="Calibri" panose="020F0502020204030204" pitchFamily="34" charset="0"/>
+                <a:ea typeface="Calibri" panose="020F0502020204030204" pitchFamily="34" charset="0"/>
+                <a:cs typeface="Calibri" panose="020F0502020204030204" pitchFamily="34" charset="0"/>
+              </a:rPr>
+              <a:t>, </a:t>
+            </a:r>
+            <a:r>
+              <a:rPr lang="en-US" sz="1200" i="1" dirty="0" err="1">
+                <a:latin typeface="Calibri" panose="020F0502020204030204" pitchFamily="34" charset="0"/>
+                <a:ea typeface="Calibri" panose="020F0502020204030204" pitchFamily="34" charset="0"/>
+                <a:cs typeface="Calibri" panose="020F0502020204030204" pitchFamily="34" charset="0"/>
+              </a:rPr>
+              <a:t>Dim_Projects</a:t>
+            </a:r>
+            <a:r>
+              <a:rPr lang="en-US" sz="1200" i="1" dirty="0">
+                <a:latin typeface="Calibri" panose="020F0502020204030204" pitchFamily="34" charset="0"/>
+                <a:ea typeface="Calibri" panose="020F0502020204030204" pitchFamily="34" charset="0"/>
+                <a:cs typeface="Calibri" panose="020F0502020204030204" pitchFamily="34" charset="0"/>
+              </a:rPr>
+              <a:t>) with 6 DAX measures.</a:t>
+            </a:r>
+          </a:p>
+          <a:p>
+            <a:pPr marL="228600" lvl="0" indent="-228600">
+              <a:buFont typeface="+mj-lt"/>
+              <a:buAutoNum type="arabicPeriod"/>
+            </a:pPr>
+            <a:endParaRPr lang="en-US" sz="1200" i="1" dirty="0">
+              <a:latin typeface="Calibri" panose="020F0502020204030204" pitchFamily="34" charset="0"/>
+              <a:ea typeface="Calibri" panose="020F0502020204030204" pitchFamily="34" charset="0"/>
+              <a:cs typeface="Calibri" panose="020F0502020204030204" pitchFamily="34" charset="0"/>
+            </a:endParaRPr>
+          </a:p>
+          <a:p>
+            <a:pPr marL="228600" lvl="0" indent="-228600">
+              <a:buFont typeface="+mj-lt"/>
+              <a:buAutoNum type="arabicPeriod"/>
+            </a:pPr>
+            <a:r>
+              <a:rPr lang="en-US" sz="1200" b="1" u="sng" dirty="0">
+                <a:latin typeface="Calibri" panose="020F0502020204030204" pitchFamily="34" charset="0"/>
+                <a:ea typeface="Calibri" panose="020F0502020204030204" pitchFamily="34" charset="0"/>
+                <a:cs typeface="Calibri" panose="020F0502020204030204" pitchFamily="34" charset="0"/>
+              </a:rPr>
+              <a:t>Live Database Connection</a:t>
+            </a:r>
+            <a:r>
+              <a:rPr lang="en-US" sz="1200" i="1" dirty="0">
+                <a:latin typeface="Calibri" panose="020F0502020204030204" pitchFamily="34" charset="0"/>
+                <a:ea typeface="Calibri" panose="020F0502020204030204" pitchFamily="34" charset="0"/>
+                <a:cs typeface="Calibri" panose="020F0502020204030204" pitchFamily="34" charset="0"/>
+              </a:rPr>
+              <a:t>: Connects directly to SQLite (</a:t>
+            </a:r>
+            <a:r>
+              <a:rPr lang="en-US" sz="1200" i="1" dirty="0" err="1">
+                <a:latin typeface="Calibri" panose="020F0502020204030204" pitchFamily="34" charset="0"/>
+                <a:ea typeface="Calibri" panose="020F0502020204030204" pitchFamily="34" charset="0"/>
+                <a:cs typeface="Calibri" panose="020F0502020204030204" pitchFamily="34" charset="0"/>
+              </a:rPr>
+              <a:t>construction_project.db</a:t>
+            </a:r>
+            <a:r>
+              <a:rPr lang="en-US" sz="1200" i="1" dirty="0">
+                <a:latin typeface="Calibri" panose="020F0502020204030204" pitchFamily="34" charset="0"/>
+                <a:ea typeface="Calibri" panose="020F0502020204030204" pitchFamily="34" charset="0"/>
+                <a:cs typeface="Calibri" panose="020F0502020204030204" pitchFamily="34" charset="0"/>
+              </a:rPr>
+              <a:t>) for real-time commercial and quality auditing.</a:t>
+            </a:r>
+            <a:endParaRPr lang="en-US" sz="1400" i="1" dirty="0">
+              <a:latin typeface="Calibri" panose="020F0502020204030204" pitchFamily="34" charset="0"/>
+              <a:ea typeface="Calibri" panose="020F0502020204030204" pitchFamily="34" charset="0"/>
+              <a:cs typeface="Calibri" panose="020F0502020204030204" pitchFamily="34" charset="0"/>
+            </a:endParaRPr>
+          </a:p>
+        </p:txBody>
+      </p:sp>
+      <p:sp>
+        <p:nvSpPr>
+          <p:cNvPr id="13" name="TextBox 12">
+            <a:extLst>
+              <a:ext uri="{FF2B5EF4-FFF2-40B4-BE49-F238E27FC236}">
+                <a16:creationId xmlns:a16="http://schemas.microsoft.com/office/drawing/2014/main" id="{FB77D810-6A0C-4DD8-1A9E-C469F1981D4C}"/>
+              </a:ext>
+            </a:extLst>
+          </p:cNvPr>
+          <p:cNvSpPr txBox="1"/>
+          <p:nvPr/>
+        </p:nvSpPr>
+        <p:spPr>
+          <a:xfrm>
+            <a:off x="6208775" y="3824768"/>
+            <a:ext cx="5095109" cy="338554"/>
+          </a:xfrm>
+          <a:prstGeom prst="rect">
+            <a:avLst/>
+          </a:prstGeom>
+          <a:noFill/>
+        </p:spPr>
+        <p:txBody>
+          <a:bodyPr wrap="square" rtlCol="0">
+            <a:spAutoFit/>
+          </a:bodyPr>
+          <a:lstStyle/>
+          <a:p>
+            <a:pPr algn="ctr"/>
+            <a:r>
+              <a:rPr lang="en-US" sz="1600" b="1" u="sng" dirty="0">
+                <a:latin typeface="Calibri" panose="020F0502020204030204" pitchFamily="34" charset="0"/>
+                <a:ea typeface="Calibri" panose="020F0502020204030204" pitchFamily="34" charset="0"/>
+                <a:cs typeface="Calibri" panose="020F0502020204030204" pitchFamily="34" charset="0"/>
+              </a:rPr>
+              <a:t>Operational Impact &amp; Live ML Serving</a:t>
+            </a:r>
+            <a:endParaRPr lang="en-US" sz="1600" u="sng" dirty="0">
+              <a:latin typeface="Calibri" panose="020F0502020204030204" pitchFamily="34" charset="0"/>
+              <a:ea typeface="Calibri" panose="020F0502020204030204" pitchFamily="34" charset="0"/>
+              <a:cs typeface="Calibri" panose="020F0502020204030204" pitchFamily="34" charset="0"/>
+            </a:endParaRPr>
+          </a:p>
+        </p:txBody>
+      </p:sp>
+      <p:sp>
+        <p:nvSpPr>
+          <p:cNvPr id="15" name="TextBox 14">
+            <a:extLst>
+              <a:ext uri="{FF2B5EF4-FFF2-40B4-BE49-F238E27FC236}">
+                <a16:creationId xmlns:a16="http://schemas.microsoft.com/office/drawing/2014/main" id="{EDE502DB-7B3F-F789-1D8B-6B3BFE643417}"/>
+              </a:ext>
+            </a:extLst>
+          </p:cNvPr>
+          <p:cNvSpPr txBox="1"/>
+          <p:nvPr/>
+        </p:nvSpPr>
+        <p:spPr>
+          <a:xfrm>
+            <a:off x="6041812" y="4245027"/>
+            <a:ext cx="5586984" cy="1569660"/>
+          </a:xfrm>
+          <a:prstGeom prst="rect">
+            <a:avLst/>
+          </a:prstGeom>
+          <a:noFill/>
+        </p:spPr>
+        <p:txBody>
+          <a:bodyPr wrap="square" rtlCol="0">
+            <a:spAutoFit/>
+          </a:bodyPr>
+          <a:lstStyle/>
+          <a:p>
+            <a:pPr marL="228600" lvl="0" indent="-228600">
+              <a:buFont typeface="+mj-lt"/>
+              <a:buAutoNum type="arabicPeriod"/>
+            </a:pPr>
+            <a:r>
+              <a:rPr lang="en-US" sz="1200" b="1" u="sng" dirty="0">
+                <a:latin typeface="Calibri" panose="020F0502020204030204" pitchFamily="34" charset="0"/>
+                <a:ea typeface="Calibri" panose="020F0502020204030204" pitchFamily="34" charset="0"/>
+                <a:cs typeface="Calibri" panose="020F0502020204030204" pitchFamily="34" charset="0"/>
+              </a:rPr>
+              <a:t>Top Executive KPI Header</a:t>
+            </a:r>
+            <a:r>
+              <a:rPr lang="en-US" sz="1200" i="1" dirty="0">
+                <a:latin typeface="Calibri" panose="020F0502020204030204" pitchFamily="34" charset="0"/>
+                <a:ea typeface="Calibri" panose="020F0502020204030204" pitchFamily="34" charset="0"/>
+                <a:cs typeface="Calibri" panose="020F0502020204030204" pitchFamily="34" charset="0"/>
+              </a:rPr>
+              <a:t>: Displays Total Invoiced Value, Vendor PO Commitment Ratio, and Concrete Pass Rate at a glance.</a:t>
+            </a:r>
+          </a:p>
+          <a:p>
+            <a:pPr marL="228600" lvl="0" indent="-228600">
+              <a:buFont typeface="+mj-lt"/>
+              <a:buAutoNum type="arabicPeriod"/>
+            </a:pPr>
+            <a:endParaRPr lang="en-US" sz="1200" i="1" dirty="0">
+              <a:latin typeface="Calibri" panose="020F0502020204030204" pitchFamily="34" charset="0"/>
+              <a:ea typeface="Calibri" panose="020F0502020204030204" pitchFamily="34" charset="0"/>
+              <a:cs typeface="Calibri" panose="020F0502020204030204" pitchFamily="34" charset="0"/>
+            </a:endParaRPr>
+          </a:p>
+          <a:p>
+            <a:pPr marL="228600" lvl="0" indent="-228600">
+              <a:buFont typeface="+mj-lt"/>
+              <a:buAutoNum type="arabicPeriod"/>
+            </a:pPr>
+            <a:r>
+              <a:rPr lang="en-US" sz="1200" b="1" u="sng" dirty="0">
+                <a:latin typeface="Calibri" panose="020F0502020204030204" pitchFamily="34" charset="0"/>
+                <a:ea typeface="Calibri" panose="020F0502020204030204" pitchFamily="34" charset="0"/>
+                <a:cs typeface="Calibri" panose="020F0502020204030204" pitchFamily="34" charset="0"/>
+              </a:rPr>
+              <a:t>What-If ML Simulator</a:t>
+            </a:r>
+            <a:r>
+              <a:rPr lang="en-US" sz="1200" i="1" dirty="0">
+                <a:latin typeface="Calibri" panose="020F0502020204030204" pitchFamily="34" charset="0"/>
+                <a:ea typeface="Calibri" panose="020F0502020204030204" pitchFamily="34" charset="0"/>
+                <a:cs typeface="Calibri" panose="020F0502020204030204" pitchFamily="34" charset="0"/>
+              </a:rPr>
+              <a:t>: Enables site engineers to adjust physical field sliders (UPV velocity, curing age, crack length) for live Random Forest predictions.</a:t>
+            </a:r>
+          </a:p>
+          <a:p>
+            <a:pPr marL="228600" lvl="0" indent="-228600">
+              <a:buFont typeface="+mj-lt"/>
+              <a:buAutoNum type="arabicPeriod"/>
+            </a:pPr>
+            <a:endParaRPr lang="en-US" sz="1200" i="1" dirty="0">
+              <a:latin typeface="Calibri" panose="020F0502020204030204" pitchFamily="34" charset="0"/>
+              <a:ea typeface="Calibri" panose="020F0502020204030204" pitchFamily="34" charset="0"/>
+              <a:cs typeface="Calibri" panose="020F0502020204030204" pitchFamily="34" charset="0"/>
+            </a:endParaRPr>
+          </a:p>
+          <a:p>
+            <a:pPr marL="228600" lvl="0" indent="-228600">
+              <a:buFont typeface="+mj-lt"/>
+              <a:buAutoNum type="arabicPeriod"/>
+            </a:pPr>
+            <a:r>
+              <a:rPr lang="en-US" sz="1200" b="1" u="sng" dirty="0">
+                <a:latin typeface="Calibri" panose="020F0502020204030204" pitchFamily="34" charset="0"/>
+                <a:ea typeface="Calibri" panose="020F0502020204030204" pitchFamily="34" charset="0"/>
+                <a:cs typeface="Calibri" panose="020F0502020204030204" pitchFamily="34" charset="0"/>
+              </a:rPr>
+              <a:t>C-Suite Value</a:t>
+            </a:r>
+            <a:r>
+              <a:rPr lang="en-US" sz="1200" i="1" dirty="0">
+                <a:latin typeface="Calibri" panose="020F0502020204030204" pitchFamily="34" charset="0"/>
+                <a:ea typeface="Calibri" panose="020F0502020204030204" pitchFamily="34" charset="0"/>
+                <a:cs typeface="Calibri" panose="020F0502020204030204" pitchFamily="34" charset="0"/>
+              </a:rPr>
+              <a:t>: Replaces slow paper site notebooks with live interactive web screens for instant decision-making.</a:t>
+            </a:r>
+            <a:endParaRPr lang="en-US" sz="1400" i="1" dirty="0">
+              <a:latin typeface="Calibri" panose="020F0502020204030204" pitchFamily="34" charset="0"/>
+              <a:ea typeface="Calibri" panose="020F0502020204030204" pitchFamily="34" charset="0"/>
+              <a:cs typeface="Calibri" panose="020F0502020204030204" pitchFamily="34" charset="0"/>
+            </a:endParaRPr>
+          </a:p>
+        </p:txBody>
+      </p:sp>
+      <p:pic>
+        <p:nvPicPr>
+          <p:cNvPr id="17" name="Picture 16">
+            <a:extLst>
+              <a:ext uri="{FF2B5EF4-FFF2-40B4-BE49-F238E27FC236}">
+                <a16:creationId xmlns:a16="http://schemas.microsoft.com/office/drawing/2014/main" id="{6D125C50-020D-5A87-941C-3A06D67FD668}"/>
+              </a:ext>
+            </a:extLst>
+          </p:cNvPr>
+          <p:cNvPicPr>
+            <a:picLocks noChangeAspect="1"/>
+          </p:cNvPicPr>
+          <p:nvPr/>
+        </p:nvPicPr>
+        <p:blipFill>
+          <a:blip r:embed="rId2">
+            <a:extLst>
+              <a:ext uri="{28A0092B-C50C-407E-A947-70E740481C1C}">
+                <a14:useLocalDpi xmlns:a14="http://schemas.microsoft.com/office/drawing/2010/main" val="0"/>
+              </a:ext>
+            </a:extLst>
+          </a:blip>
+          <a:stretch>
+            <a:fillRect/>
+          </a:stretch>
+        </p:blipFill>
+        <p:spPr>
+          <a:xfrm>
+            <a:off x="485583" y="1026486"/>
+            <a:ext cx="4937759" cy="3710105"/>
+          </a:xfrm>
+          <a:prstGeom prst="rect">
+            <a:avLst/>
+          </a:prstGeom>
+          <a:ln w="38100" cap="sq">
+            <a:solidFill>
+              <a:srgbClr val="000000"/>
+            </a:solidFill>
+            <a:prstDash val="solid"/>
+            <a:miter lim="800000"/>
+          </a:ln>
+          <a:effectLst>
+            <a:outerShdw blurRad="50800" dist="38100" dir="2700000" algn="tl" rotWithShape="0">
+              <a:srgbClr val="000000">
+                <a:alpha val="43000"/>
+              </a:srgbClr>
+            </a:outerShdw>
+          </a:effectLst>
+        </p:spPr>
+      </p:pic>
+      <p:sp>
+        <p:nvSpPr>
+          <p:cNvPr id="19" name="TextBox 18">
+            <a:extLst>
+              <a:ext uri="{FF2B5EF4-FFF2-40B4-BE49-F238E27FC236}">
+                <a16:creationId xmlns:a16="http://schemas.microsoft.com/office/drawing/2014/main" id="{3E26248A-1A4E-C398-3D37-B4CF7479586F}"/>
+              </a:ext>
+            </a:extLst>
+          </p:cNvPr>
+          <p:cNvSpPr txBox="1"/>
+          <p:nvPr/>
+        </p:nvSpPr>
+        <p:spPr>
+          <a:xfrm>
+            <a:off x="0" y="6334780"/>
+            <a:ext cx="8010144" cy="523220"/>
+          </a:xfrm>
+          <a:prstGeom prst="rect">
+            <a:avLst/>
+          </a:prstGeom>
+          <a:noFill/>
+        </p:spPr>
+        <p:txBody>
+          <a:bodyPr wrap="square" rtlCol="0">
+            <a:spAutoFit/>
+          </a:bodyPr>
+          <a:lstStyle/>
+          <a:p>
+            <a:r>
+              <a:rPr lang="en-US" sz="1400" dirty="0">
+                <a:latin typeface="Calibri" panose="020F0502020204030204" pitchFamily="34" charset="0"/>
+                <a:ea typeface="Calibri" panose="020F0502020204030204" pitchFamily="34" charset="0"/>
+                <a:cs typeface="Calibri" panose="020F0502020204030204" pitchFamily="34" charset="0"/>
+              </a:rPr>
+              <a:t>Project Repository:</a:t>
+            </a:r>
+          </a:p>
+          <a:p>
+            <a:r>
+              <a:rPr lang="en-US" sz="1400" dirty="0">
+                <a:latin typeface="Calibri" panose="020F0502020204030204" pitchFamily="34" charset="0"/>
+                <a:ea typeface="Calibri" panose="020F0502020204030204" pitchFamily="34" charset="0"/>
+                <a:cs typeface="Calibri" panose="020F0502020204030204" pitchFamily="34" charset="0"/>
+                <a:hlinkClick r:id="rId3"/>
+              </a:rPr>
+              <a:t>https://github.com/Pallabi5200/Civil_Engineering_Data_Science_Project</a:t>
+            </a:r>
+            <a:endParaRPr lang="en-US" sz="1400" dirty="0">
+              <a:latin typeface="Calibri" panose="020F0502020204030204" pitchFamily="34" charset="0"/>
+              <a:ea typeface="Calibri" panose="020F0502020204030204" pitchFamily="34" charset="0"/>
+              <a:cs typeface="Calibri" panose="020F0502020204030204" pitchFamily="34" charset="0"/>
+            </a:endParaRPr>
+          </a:p>
+        </p:txBody>
+      </p:sp>
+    </p:spTree>
+    <p:extLst>
+      <p:ext uri="{BB962C8B-B14F-4D97-AF65-F5344CB8AC3E}">
+        <p14:creationId xmlns:p14="http://schemas.microsoft.com/office/powerpoint/2010/main" val="1793248201"/>
       </p:ext>
     </p:extLst>
   </p:cSld>

</xml_diff>

<commit_message>
Update Slide 7 screenshot and finalize 11-slide executive presentation deck
</commit_message>
<xml_diff>
--- a/PRESENTATION/Civil_Project.pptx
+++ b/PRESENTATION/Civil_Project.pptx
@@ -18866,12 +18866,67 @@
           </a:p>
         </p:txBody>
       </p:sp>
+      <p:sp>
+        <p:nvSpPr>
+          <p:cNvPr id="21" name="TextBox 20">
+            <a:extLst>
+              <a:ext uri="{FF2B5EF4-FFF2-40B4-BE49-F238E27FC236}">
+                <a16:creationId xmlns:a16="http://schemas.microsoft.com/office/drawing/2014/main" id="{CB17630B-558F-141F-523A-3F7723326146}"/>
+              </a:ext>
+            </a:extLst>
+          </p:cNvPr>
+          <p:cNvSpPr txBox="1"/>
+          <p:nvPr/>
+        </p:nvSpPr>
+        <p:spPr>
+          <a:xfrm>
+            <a:off x="0" y="6334780"/>
+            <a:ext cx="8010144" cy="523220"/>
+          </a:xfrm>
+          <a:prstGeom prst="rect">
+            <a:avLst/>
+          </a:prstGeom>
+          <a:noFill/>
+        </p:spPr>
+        <p:txBody>
+          <a:bodyPr wrap="square" rtlCol="0">
+            <a:spAutoFit/>
+          </a:bodyPr>
+          <a:lstStyle/>
+          <a:p>
+            <a:r>
+              <a:rPr lang="en-US" sz="1400" dirty="0">
+                <a:latin typeface="Calibri" panose="020F0502020204030204" pitchFamily="34" charset="0"/>
+                <a:ea typeface="Calibri" panose="020F0502020204030204" pitchFamily="34" charset="0"/>
+                <a:cs typeface="Calibri" panose="020F0502020204030204" pitchFamily="34" charset="0"/>
+              </a:rPr>
+              <a:t>Project Repository:</a:t>
+            </a:r>
+          </a:p>
+          <a:p>
+            <a:r>
+              <a:rPr lang="en-US" sz="1400" dirty="0">
+                <a:latin typeface="Calibri" panose="020F0502020204030204" pitchFamily="34" charset="0"/>
+                <a:ea typeface="Calibri" panose="020F0502020204030204" pitchFamily="34" charset="0"/>
+                <a:cs typeface="Calibri" panose="020F0502020204030204" pitchFamily="34" charset="0"/>
+                <a:hlinkClick r:id="rId2"/>
+              </a:rPr>
+              <a:t>https://github.com/Pallabi5200/Civil_Engineering_Data_Science_Project</a:t>
+            </a:r>
+            <a:endParaRPr lang="en-US" sz="1400" dirty="0">
+              <a:latin typeface="Calibri" panose="020F0502020204030204" pitchFamily="34" charset="0"/>
+              <a:ea typeface="Calibri" panose="020F0502020204030204" pitchFamily="34" charset="0"/>
+              <a:cs typeface="Calibri" panose="020F0502020204030204" pitchFamily="34" charset="0"/>
+            </a:endParaRPr>
+          </a:p>
+        </p:txBody>
+      </p:sp>
       <p:pic>
         <p:nvPicPr>
-          <p:cNvPr id="19" name="Picture 18">
-            <a:extLst>
-              <a:ext uri="{FF2B5EF4-FFF2-40B4-BE49-F238E27FC236}">
-                <a16:creationId xmlns:a16="http://schemas.microsoft.com/office/drawing/2014/main" id="{687A0F1D-99DD-99E6-AEF2-BBFC27353DF1}"/>
+          <p:cNvPr id="8" name="Picture 7">
+            <a:extLst>
+              <a:ext uri="{FF2B5EF4-FFF2-40B4-BE49-F238E27FC236}">
+                <a16:creationId xmlns:a16="http://schemas.microsoft.com/office/drawing/2014/main" id="{81E87CD1-888B-8F62-9911-F0E4B9D1CBC2}"/>
               </a:ext>
             </a:extLst>
           </p:cNvPr>
@@ -18881,7 +18936,7 @@
           <p:nvPr/>
         </p:nvPicPr>
         <p:blipFill>
-          <a:blip r:embed="rId2">
+          <a:blip r:embed="rId3">
             <a:extLst>
               <a:ext uri="{28A0092B-C50C-407E-A947-70E740481C1C}">
                 <a14:useLocalDpi xmlns:a14="http://schemas.microsoft.com/office/drawing/2010/main" val="0"/>
@@ -18894,69 +18949,14 @@
         </p:blipFill>
         <p:spPr>
           <a:xfrm>
-            <a:off x="157572" y="987552"/>
-            <a:ext cx="5336923" cy="3972136"/>
+            <a:off x="431068" y="1061412"/>
+            <a:ext cx="4956169" cy="3972332"/>
           </a:xfrm>
           <a:prstGeom prst="rect">
             <a:avLst/>
           </a:prstGeom>
         </p:spPr>
       </p:pic>
-      <p:sp>
-        <p:nvSpPr>
-          <p:cNvPr id="21" name="TextBox 20">
-            <a:extLst>
-              <a:ext uri="{FF2B5EF4-FFF2-40B4-BE49-F238E27FC236}">
-                <a16:creationId xmlns:a16="http://schemas.microsoft.com/office/drawing/2014/main" id="{CB17630B-558F-141F-523A-3F7723326146}"/>
-              </a:ext>
-            </a:extLst>
-          </p:cNvPr>
-          <p:cNvSpPr txBox="1"/>
-          <p:nvPr/>
-        </p:nvSpPr>
-        <p:spPr>
-          <a:xfrm>
-            <a:off x="0" y="6334780"/>
-            <a:ext cx="8010144" cy="523220"/>
-          </a:xfrm>
-          <a:prstGeom prst="rect">
-            <a:avLst/>
-          </a:prstGeom>
-          <a:noFill/>
-        </p:spPr>
-        <p:txBody>
-          <a:bodyPr wrap="square" rtlCol="0">
-            <a:spAutoFit/>
-          </a:bodyPr>
-          <a:lstStyle/>
-          <a:p>
-            <a:r>
-              <a:rPr lang="en-US" sz="1400" dirty="0">
-                <a:latin typeface="Calibri" panose="020F0502020204030204" pitchFamily="34" charset="0"/>
-                <a:ea typeface="Calibri" panose="020F0502020204030204" pitchFamily="34" charset="0"/>
-                <a:cs typeface="Calibri" panose="020F0502020204030204" pitchFamily="34" charset="0"/>
-              </a:rPr>
-              <a:t>Project Repository:</a:t>
-            </a:r>
-          </a:p>
-          <a:p>
-            <a:r>
-              <a:rPr lang="en-US" sz="1400" dirty="0">
-                <a:latin typeface="Calibri" panose="020F0502020204030204" pitchFamily="34" charset="0"/>
-                <a:ea typeface="Calibri" panose="020F0502020204030204" pitchFamily="34" charset="0"/>
-                <a:cs typeface="Calibri" panose="020F0502020204030204" pitchFamily="34" charset="0"/>
-                <a:hlinkClick r:id="rId3"/>
-              </a:rPr>
-              <a:t>https://github.com/Pallabi5200/Civil_Engineering_Data_Science_Project</a:t>
-            </a:r>
-            <a:endParaRPr lang="en-US" sz="1400" dirty="0">
-              <a:latin typeface="Calibri" panose="020F0502020204030204" pitchFamily="34" charset="0"/>
-              <a:ea typeface="Calibri" panose="020F0502020204030204" pitchFamily="34" charset="0"/>
-              <a:cs typeface="Calibri" panose="020F0502020204030204" pitchFamily="34" charset="0"/>
-            </a:endParaRPr>
-          </a:p>
-        </p:txBody>
-      </p:sp>
     </p:spTree>
     <p:extLst>
       <p:ext uri="{BB962C8B-B14F-4D97-AF65-F5344CB8AC3E}">

</xml_diff>